<commit_message>
Actualizar entrega docente: WAN MikroTik A/B, presupuesto y PPT WAN-2
</commit_message>
<xml_diff>
--- a/Presentacion/Avance_Financiera_Pacifico_30_oct_2026.pptx
+++ b/Presentacion/Avance_Financiera_Pacifico_30_oct_2026.pptx
@@ -2,26 +2,26 @@
 <file path=ppt/presentation.xml><?xml version="1.0" encoding="utf-8"?>
 <p:presentation xmlns:p="http://schemas.openxmlformats.org/presentationml/2006/main">
   <p:sldMasterIdLst>
-    <p:sldMasterId xmlns:r="http://schemas.openxmlformats.org/officeDocument/2006/relationships" id="2147483648" r:id="Rbaccaeef7cf64930"/>
+    <p:sldMasterId xmlns:r="http://schemas.openxmlformats.org/officeDocument/2006/relationships" id="2147483648" r:id="R062f9272c6bb434a"/>
   </p:sldMasterIdLst>
   <p:notesMasterIdLst>
-    <p:notesMasterId xmlns:r="http://schemas.openxmlformats.org/officeDocument/2006/relationships" r:id="R446b7145a77b4cb0"/>
+    <p:notesMasterId xmlns:r="http://schemas.openxmlformats.org/officeDocument/2006/relationships" r:id="R3106c8f0b4a54b6f"/>
   </p:notesMasterIdLst>
   <p:sldIdLst>
-    <p:sldId xmlns:r="http://schemas.openxmlformats.org/officeDocument/2006/relationships" id="256" r:id="Rda7967e6aa1e4829"/>
-    <p:sldId xmlns:r="http://schemas.openxmlformats.org/officeDocument/2006/relationships" id="257" r:id="Rbcc6c99ca7c6477f"/>
-    <p:sldId xmlns:r="http://schemas.openxmlformats.org/officeDocument/2006/relationships" id="258" r:id="R1f1405166cf64380"/>
-    <p:sldId xmlns:r="http://schemas.openxmlformats.org/officeDocument/2006/relationships" id="259" r:id="R1e113130714e41f0"/>
-    <p:sldId xmlns:r="http://schemas.openxmlformats.org/officeDocument/2006/relationships" id="260" r:id="R998eefc07ade463d"/>
-    <p:sldId xmlns:r="http://schemas.openxmlformats.org/officeDocument/2006/relationships" id="261" r:id="R1c0aa2aef047432d"/>
-    <p:sldId xmlns:r="http://schemas.openxmlformats.org/officeDocument/2006/relationships" id="262" r:id="Rcfe95d96547641e2"/>
-    <p:sldId xmlns:r="http://schemas.openxmlformats.org/officeDocument/2006/relationships" id="263" r:id="Refe6f87eda4b447d"/>
-    <p:sldId xmlns:r="http://schemas.openxmlformats.org/officeDocument/2006/relationships" id="264" r:id="Ra664fe04ecdd46e5"/>
-    <p:sldId xmlns:r="http://schemas.openxmlformats.org/officeDocument/2006/relationships" id="265" r:id="R21f22454f1c74507"/>
-    <p:sldId xmlns:r="http://schemas.openxmlformats.org/officeDocument/2006/relationships" id="266" r:id="R11bdbab62e4545df"/>
-    <p:sldId xmlns:r="http://schemas.openxmlformats.org/officeDocument/2006/relationships" id="267" r:id="Rb735e642e67b4b2f"/>
-    <p:sldId xmlns:r="http://schemas.openxmlformats.org/officeDocument/2006/relationships" id="268" r:id="Rc3d88aba4ca74c44"/>
-    <p:sldId xmlns:r="http://schemas.openxmlformats.org/officeDocument/2006/relationships" id="269" r:id="R3228760a79094035"/>
+    <p:sldId xmlns:r="http://schemas.openxmlformats.org/officeDocument/2006/relationships" id="256" r:id="Rd829d8430e794587"/>
+    <p:sldId xmlns:r="http://schemas.openxmlformats.org/officeDocument/2006/relationships" id="257" r:id="R176f519287c04e47"/>
+    <p:sldId xmlns:r="http://schemas.openxmlformats.org/officeDocument/2006/relationships" id="258" r:id="R27fd7ce9a9754f68"/>
+    <p:sldId xmlns:r="http://schemas.openxmlformats.org/officeDocument/2006/relationships" id="259" r:id="R752dd25d43754577"/>
+    <p:sldId xmlns:r="http://schemas.openxmlformats.org/officeDocument/2006/relationships" id="260" r:id="Rc8342c362c6d4071"/>
+    <p:sldId xmlns:r="http://schemas.openxmlformats.org/officeDocument/2006/relationships" id="261" r:id="R9810e706f807423f"/>
+    <p:sldId xmlns:r="http://schemas.openxmlformats.org/officeDocument/2006/relationships" id="262" r:id="R07ac87d9ea6e4b39"/>
+    <p:sldId xmlns:r="http://schemas.openxmlformats.org/officeDocument/2006/relationships" id="263" r:id="Rb852caad8670469a"/>
+    <p:sldId xmlns:r="http://schemas.openxmlformats.org/officeDocument/2006/relationships" id="264" r:id="R887fd7d002e64b29"/>
+    <p:sldId xmlns:r="http://schemas.openxmlformats.org/officeDocument/2006/relationships" id="265" r:id="R41fc2de77b99475b"/>
+    <p:sldId xmlns:r="http://schemas.openxmlformats.org/officeDocument/2006/relationships" id="266" r:id="R342cfb1d42a146f4"/>
+    <p:sldId xmlns:r="http://schemas.openxmlformats.org/officeDocument/2006/relationships" id="267" r:id="R2b9f794e8b24474a"/>
+    <p:sldId xmlns:r="http://schemas.openxmlformats.org/officeDocument/2006/relationships" id="268" r:id="R7ae9ba0844e6433d"/>
+    <p:sldId xmlns:r="http://schemas.openxmlformats.org/officeDocument/2006/relationships" id="269" r:id="Rdc72062108a64212"/>
   </p:sldIdLst>
   <p:sldSz cx="12192000" cy="6858000"/>
   <p:notesSz cx="6858000" cy="9144000"/>
@@ -1412,7 +1412,7 @@
           <p:cNvPr id="3" name="Title">
             <a:extLst xmlns:a="http://schemas.openxmlformats.org/drawingml/2006/main">
               <a:ext uri="{FF2B5EF4-FFF2-40B4-BE49-F238E27FC236}">
-                <a16:creationId xmlns:a16="http://schemas.microsoft.com/office/drawing/2014/main" id="{20945C45-2D93-42DF-8037-68B4C3EEE034}"/>
+                <a16:creationId xmlns:a16="http://schemas.microsoft.com/office/drawing/2014/main" id="{7AF0C6E2-7E90-4AB7-A1CD-E62C976F48AC}"/>
               </a:ext>
             </a:extLst>
           </p:cNvPr>
@@ -1641,7 +1641,7 @@
           <p:cNvPr id="2" name="Subtitle">
             <a:extLst xmlns:a="http://schemas.openxmlformats.org/drawingml/2006/main">
               <a:ext uri="{FF2B5EF4-FFF2-40B4-BE49-F238E27FC236}">
-                <a16:creationId xmlns:a16="http://schemas.microsoft.com/office/drawing/2014/main" id="{8A0BACBC-808E-482A-AA96-551C05805B56}"/>
+                <a16:creationId xmlns:a16="http://schemas.microsoft.com/office/drawing/2014/main" id="{D589974A-8308-48A6-ADB7-627686EC5F90}"/>
               </a:ext>
             </a:extLst>
           </p:cNvPr>
@@ -1887,7 +1887,7 @@
           <p:cNvPr id="2" name="Section title">
             <a:extLst xmlns:a="http://schemas.openxmlformats.org/drawingml/2006/main">
               <a:ext uri="{FF2B5EF4-FFF2-40B4-BE49-F238E27FC236}">
-                <a16:creationId xmlns:a16="http://schemas.microsoft.com/office/drawing/2014/main" id="{8825B655-D49E-4410-8E4C-29348072A5D6}"/>
+                <a16:creationId xmlns:a16="http://schemas.microsoft.com/office/drawing/2014/main" id="{9CCEB1EB-CCC9-4511-9C44-B47A47C97C72}"/>
               </a:ext>
             </a:extLst>
           </p:cNvPr>
@@ -2133,7 +2133,7 @@
           <p:cNvPr id="3" name="Title">
             <a:extLst xmlns:a="http://schemas.openxmlformats.org/drawingml/2006/main">
               <a:ext uri="{FF2B5EF4-FFF2-40B4-BE49-F238E27FC236}">
-                <a16:creationId xmlns:a16="http://schemas.microsoft.com/office/drawing/2014/main" id="{2E990DDB-10BD-4BD1-BDFC-35A098FE1F02}"/>
+                <a16:creationId xmlns:a16="http://schemas.microsoft.com/office/drawing/2014/main" id="{BD246A8F-DA40-450A-966C-E0975E97B107}"/>
               </a:ext>
             </a:extLst>
           </p:cNvPr>
@@ -2362,7 +2362,7 @@
           <p:cNvPr id="2" name="Body">
             <a:extLst xmlns:a="http://schemas.openxmlformats.org/drawingml/2006/main">
               <a:ext uri="{FF2B5EF4-FFF2-40B4-BE49-F238E27FC236}">
-                <a16:creationId xmlns:a16="http://schemas.microsoft.com/office/drawing/2014/main" id="{71AF7949-791C-47D1-A165-3101C97FDEC4}"/>
+                <a16:creationId xmlns:a16="http://schemas.microsoft.com/office/drawing/2014/main" id="{85DCE6A6-32F6-4A13-9E77-B5E9F30FD8C5}"/>
               </a:ext>
             </a:extLst>
           </p:cNvPr>
@@ -2608,7 +2608,7 @@
           <p:cNvPr id="4" name="Title">
             <a:extLst xmlns:a="http://schemas.openxmlformats.org/drawingml/2006/main">
               <a:ext uri="{FF2B5EF4-FFF2-40B4-BE49-F238E27FC236}">
-                <a16:creationId xmlns:a16="http://schemas.microsoft.com/office/drawing/2014/main" id="{256FB015-3AAE-4C2D-B892-8FA2F67944BB}"/>
+                <a16:creationId xmlns:a16="http://schemas.microsoft.com/office/drawing/2014/main" id="{393B74B6-D944-485C-8AC2-861667628E96}"/>
               </a:ext>
             </a:extLst>
           </p:cNvPr>
@@ -2837,7 +2837,7 @@
           <p:cNvPr id="2" name="Left column">
             <a:extLst xmlns:a="http://schemas.openxmlformats.org/drawingml/2006/main">
               <a:ext uri="{FF2B5EF4-FFF2-40B4-BE49-F238E27FC236}">
-                <a16:creationId xmlns:a16="http://schemas.microsoft.com/office/drawing/2014/main" id="{26440B3E-7B82-4707-A1A1-6FCEC04E751B}"/>
+                <a16:creationId xmlns:a16="http://schemas.microsoft.com/office/drawing/2014/main" id="{ECFBCD97-1D37-4D55-850C-52F4C3A77EBD}"/>
               </a:ext>
             </a:extLst>
           </p:cNvPr>
@@ -3066,7 +3066,7 @@
           <p:cNvPr id="3" name="Right column">
             <a:extLst xmlns:a="http://schemas.openxmlformats.org/drawingml/2006/main">
               <a:ext uri="{FF2B5EF4-FFF2-40B4-BE49-F238E27FC236}">
-                <a16:creationId xmlns:a16="http://schemas.microsoft.com/office/drawing/2014/main" id="{2EEB4F11-B030-46A5-9239-233A795291E5}"/>
+                <a16:creationId xmlns:a16="http://schemas.microsoft.com/office/drawing/2014/main" id="{9D77D2D1-E0C8-4B75-9CA1-AEB06645B723}"/>
               </a:ext>
             </a:extLst>
           </p:cNvPr>
@@ -3312,7 +3312,7 @@
           <p:cNvPr id="3" name="Title">
             <a:extLst xmlns:a="http://schemas.openxmlformats.org/drawingml/2006/main">
               <a:ext uri="{FF2B5EF4-FFF2-40B4-BE49-F238E27FC236}">
-                <a16:creationId xmlns:a16="http://schemas.microsoft.com/office/drawing/2014/main" id="{CDD1EEEE-CE70-4D67-B4A8-6FE4FAB882D0}"/>
+                <a16:creationId xmlns:a16="http://schemas.microsoft.com/office/drawing/2014/main" id="{935E2CC7-F6A9-4E28-B129-C0934DF9088C}"/>
               </a:ext>
             </a:extLst>
           </p:cNvPr>
@@ -3541,7 +3541,7 @@
           <p:cNvPr id="2" name="Left column">
             <a:extLst xmlns:a="http://schemas.openxmlformats.org/drawingml/2006/main">
               <a:ext uri="{FF2B5EF4-FFF2-40B4-BE49-F238E27FC236}">
-                <a16:creationId xmlns:a16="http://schemas.microsoft.com/office/drawing/2014/main" id="{C63FF595-B97A-4800-949B-D0F8D29B1587}"/>
+                <a16:creationId xmlns:a16="http://schemas.microsoft.com/office/drawing/2014/main" id="{7F5F9C98-C1C2-47F9-B049-5EC59312CE11}"/>
               </a:ext>
             </a:extLst>
           </p:cNvPr>
@@ -3808,12 +3808,12 @@
   </p:cSld>
   <p:clrMap bg1="lt1" tx1="dk1" bg2="lt2" tx2="dk2" accent1="accent1" accent2="accent2" accent3="accent3" accent4="accent4" accent5="accent5" accent6="accent6" hlink="hlink" folHlink="folHlink"/>
   <p:sldLayoutIdLst>
-    <p:sldLayoutId xmlns:r="http://schemas.openxmlformats.org/officeDocument/2006/relationships" id="2147483649" r:id="R9fefece25745460b"/>
-    <p:sldLayoutId xmlns:r="http://schemas.openxmlformats.org/officeDocument/2006/relationships" id="2147483650" r:id="Rc55a12d5b81e43e5"/>
-    <p:sldLayoutId xmlns:r="http://schemas.openxmlformats.org/officeDocument/2006/relationships" id="2147483651" r:id="R9265cbee61834142"/>
-    <p:sldLayoutId xmlns:r="http://schemas.openxmlformats.org/officeDocument/2006/relationships" id="2147483652" r:id="R311c9b5ea93e4127"/>
-    <p:sldLayoutId xmlns:r="http://schemas.openxmlformats.org/officeDocument/2006/relationships" id="2147483653" r:id="R0eb28c354f5b4689"/>
-    <p:sldLayoutId xmlns:r="http://schemas.openxmlformats.org/officeDocument/2006/relationships" id="2147483654" r:id="R8d083797f7d44e2b"/>
+    <p:sldLayoutId xmlns:r="http://schemas.openxmlformats.org/officeDocument/2006/relationships" id="2147483649" r:id="Rdb03e854affc4273"/>
+    <p:sldLayoutId xmlns:r="http://schemas.openxmlformats.org/officeDocument/2006/relationships" id="2147483650" r:id="Rc871822e10874281"/>
+    <p:sldLayoutId xmlns:r="http://schemas.openxmlformats.org/officeDocument/2006/relationships" id="2147483651" r:id="Rc5895bdcaa3c4231"/>
+    <p:sldLayoutId xmlns:r="http://schemas.openxmlformats.org/officeDocument/2006/relationships" id="2147483652" r:id="R2ea8dcc544604720"/>
+    <p:sldLayoutId xmlns:r="http://schemas.openxmlformats.org/officeDocument/2006/relationships" id="2147483653" r:id="Rb0ce696c0efa47bc"/>
+    <p:sldLayoutId xmlns:r="http://schemas.openxmlformats.org/officeDocument/2006/relationships" id="2147483654" r:id="Rf39054bb223742a7"/>
   </p:sldLayoutIdLst>
   <p:txStyles>
     <p:titleStyle>
@@ -4364,7 +4364,7 @@
           <p:cNvPr id="6" name="text-0">
             <a:extLst xmlns:a="http://schemas.openxmlformats.org/drawingml/2006/main">
               <a:ext uri="{FF2B5EF4-FFF2-40B4-BE49-F238E27FC236}">
-                <a16:creationId xmlns:a16="http://schemas.microsoft.com/office/drawing/2014/main" id="{BEF76570-8C32-47FF-B34E-DA1372B7C159}"/>
+                <a16:creationId xmlns:a16="http://schemas.microsoft.com/office/drawing/2014/main" id="{10C233B5-9DDC-4683-9997-EDF895CE6F67}"/>
               </a:ext>
             </a:extLst>
           </p:cNvPr>
@@ -4523,7 +4523,7 @@
           <p:cNvPr id="2" name="text-1">
             <a:extLst xmlns:a="http://schemas.openxmlformats.org/drawingml/2006/main">
               <a:ext uri="{FF2B5EF4-FFF2-40B4-BE49-F238E27FC236}">
-                <a16:creationId xmlns:a16="http://schemas.microsoft.com/office/drawing/2014/main" id="{052D149F-797F-4FC7-AE82-4060F93507C2}"/>
+                <a16:creationId xmlns:a16="http://schemas.microsoft.com/office/drawing/2014/main" id="{3CE3486B-E8DB-459E-AB43-210D30C5F00F}"/>
               </a:ext>
             </a:extLst>
           </p:cNvPr>
@@ -4682,7 +4682,7 @@
           <p:cNvPr id="3" name="text-2">
             <a:extLst xmlns:a="http://schemas.openxmlformats.org/drawingml/2006/main">
               <a:ext uri="{FF2B5EF4-FFF2-40B4-BE49-F238E27FC236}">
-                <a16:creationId xmlns:a16="http://schemas.microsoft.com/office/drawing/2014/main" id="{B25703A4-E9A9-41ED-8BE4-06F3F53B26BB}"/>
+                <a16:creationId xmlns:a16="http://schemas.microsoft.com/office/drawing/2014/main" id="{9F082752-0A06-44DB-8B28-6BAFFB70A23D}"/>
               </a:ext>
             </a:extLst>
           </p:cNvPr>
@@ -4864,7 +4864,7 @@
           <p:cNvPr id="4" name="text-3">
             <a:extLst xmlns:a="http://schemas.openxmlformats.org/drawingml/2006/main">
               <a:ext uri="{FF2B5EF4-FFF2-40B4-BE49-F238E27FC236}">
-                <a16:creationId xmlns:a16="http://schemas.microsoft.com/office/drawing/2014/main" id="{BD9388F0-01B4-484C-97EA-9DC625A2CB1E}"/>
+                <a16:creationId xmlns:a16="http://schemas.microsoft.com/office/drawing/2014/main" id="{9502132F-AB64-4B90-9693-E7B310FB3365}"/>
               </a:ext>
             </a:extLst>
           </p:cNvPr>
@@ -5013,7 +5013,7 @@
                 <a:ea typeface="DejaVu Sans"/>
                 <a:cs typeface="DejaVu Sans"/>
               </a:rPr>
-              <a:t>Avance Capstone al 23 de octubre de 2026</a:t>
+              <a:t>Avance Capstone al 24 de octubre de 2026</a:t>
             </a:r>
           </a:p>
         </p:txBody>
@@ -5023,7 +5023,7 @@
           <p:cNvPr id="5" name="text-4">
             <a:extLst xmlns:a="http://schemas.openxmlformats.org/drawingml/2006/main">
               <a:ext uri="{FF2B5EF4-FFF2-40B4-BE49-F238E27FC236}">
-                <a16:creationId xmlns:a16="http://schemas.microsoft.com/office/drawing/2014/main" id="{17EF7F20-8B83-407E-959C-9539621933B8}"/>
+                <a16:creationId xmlns:a16="http://schemas.microsoft.com/office/drawing/2014/main" id="{F51557CB-D290-4D86-9D77-7B2928DBF676}"/>
               </a:ext>
             </a:extLst>
           </p:cNvPr>
@@ -5203,7 +5203,7 @@
     </p:spTree>
     <p:extLst>
       <p:ext uri="{BB962C8B-B14F-4D97-AF65-F5344CB8AC3E}">
-        <p14:creationId xmlns:p14="http://schemas.microsoft.com/office/powerpoint/2010/main" val="314581338"/>
+        <p14:creationId xmlns:p14="http://schemas.microsoft.com/office/powerpoint/2010/main" val="1578053215"/>
       </p:ext>
     </p:extLst>
   </p:cSld>
@@ -5234,7 +5234,7 @@
           <p:cNvPr id="10" name="text-0">
             <a:extLst xmlns:a="http://schemas.openxmlformats.org/drawingml/2006/main">
               <a:ext uri="{FF2B5EF4-FFF2-40B4-BE49-F238E27FC236}">
-                <a16:creationId xmlns:a16="http://schemas.microsoft.com/office/drawing/2014/main" id="{831D55CE-8AA6-46B8-8125-55908CCC44D3}"/>
+                <a16:creationId xmlns:a16="http://schemas.microsoft.com/office/drawing/2014/main" id="{C2A51BF8-B013-42EC-B64E-D69CAC86D986}"/>
               </a:ext>
             </a:extLst>
           </p:cNvPr>
@@ -5393,7 +5393,7 @@
           <p:cNvPr id="2" name="text-1">
             <a:extLst xmlns:a="http://schemas.openxmlformats.org/drawingml/2006/main">
               <a:ext uri="{FF2B5EF4-FFF2-40B4-BE49-F238E27FC236}">
-                <a16:creationId xmlns:a16="http://schemas.microsoft.com/office/drawing/2014/main" id="{104F8D15-32CF-490D-8569-9BF58DFF7A99}"/>
+                <a16:creationId xmlns:a16="http://schemas.microsoft.com/office/drawing/2014/main" id="{E3742027-275A-4073-8720-EAC4C6452B8C}"/>
               </a:ext>
             </a:extLst>
           </p:cNvPr>
@@ -5552,7 +5552,7 @@
           <p:cNvPr id="3" name="text-2">
             <a:extLst xmlns:a="http://schemas.openxmlformats.org/drawingml/2006/main">
               <a:ext uri="{FF2B5EF4-FFF2-40B4-BE49-F238E27FC236}">
-                <a16:creationId xmlns:a16="http://schemas.microsoft.com/office/drawing/2014/main" id="{68B45C94-F3CC-4A01-922C-2FAB66FF3677}"/>
+                <a16:creationId xmlns:a16="http://schemas.microsoft.com/office/drawing/2014/main" id="{D3DA6D02-ECE0-4928-8B20-02A9A9EB6C21}"/>
               </a:ext>
             </a:extLst>
           </p:cNvPr>
@@ -5701,7 +5701,7 @@
                 <a:ea typeface="DejaVu Sans"/>
                 <a:cs typeface="DejaVu Sans"/>
               </a:rPr>
-              <a:t>78</a:t>
+              <a:t>79</a:t>
             </a:r>
           </a:p>
         </p:txBody>
@@ -5711,7 +5711,7 @@
           <p:cNvPr id="4" name="text-3">
             <a:extLst xmlns:a="http://schemas.openxmlformats.org/drawingml/2006/main">
               <a:ext uri="{FF2B5EF4-FFF2-40B4-BE49-F238E27FC236}">
-                <a16:creationId xmlns:a16="http://schemas.microsoft.com/office/drawing/2014/main" id="{236B6587-0487-4479-8F2F-1E213145FA0C}"/>
+                <a16:creationId xmlns:a16="http://schemas.microsoft.com/office/drawing/2014/main" id="{E914D401-62FC-43D1-9DB5-07B367589517}"/>
               </a:ext>
             </a:extLst>
           </p:cNvPr>
@@ -5870,7 +5870,7 @@
           <p:cNvPr id="5" name="text-4">
             <a:extLst xmlns:a="http://schemas.openxmlformats.org/drawingml/2006/main">
               <a:ext uri="{FF2B5EF4-FFF2-40B4-BE49-F238E27FC236}">
-                <a16:creationId xmlns:a16="http://schemas.microsoft.com/office/drawing/2014/main" id="{DEDD4012-2DBD-4D18-B594-74982080A1A6}"/>
+                <a16:creationId xmlns:a16="http://schemas.microsoft.com/office/drawing/2014/main" id="{A93068BE-625C-45FB-9444-B09AF9FD17C4}"/>
               </a:ext>
             </a:extLst>
           </p:cNvPr>
@@ -6029,7 +6029,7 @@
           <p:cNvPr id="6" name="text-5">
             <a:extLst xmlns:a="http://schemas.openxmlformats.org/drawingml/2006/main">
               <a:ext uri="{FF2B5EF4-FFF2-40B4-BE49-F238E27FC236}">
-                <a16:creationId xmlns:a16="http://schemas.microsoft.com/office/drawing/2014/main" id="{3D02244F-9618-4014-A119-22674412B689}"/>
+                <a16:creationId xmlns:a16="http://schemas.microsoft.com/office/drawing/2014/main" id="{3765DC43-037D-4B95-B599-3EDF46A79D5F}"/>
               </a:ext>
             </a:extLst>
           </p:cNvPr>
@@ -6188,7 +6188,7 @@
           <p:cNvPr id="7" name="text-6">
             <a:extLst xmlns:a="http://schemas.openxmlformats.org/drawingml/2006/main">
               <a:ext uri="{FF2B5EF4-FFF2-40B4-BE49-F238E27FC236}">
-                <a16:creationId xmlns:a16="http://schemas.microsoft.com/office/drawing/2014/main" id="{BABFBAA6-56F9-4820-87F0-A544E8364EA2}"/>
+                <a16:creationId xmlns:a16="http://schemas.microsoft.com/office/drawing/2014/main" id="{0E283F77-C0A4-41F5-B43C-105FCC7A67D0}"/>
               </a:ext>
             </a:extLst>
           </p:cNvPr>
@@ -6347,7 +6347,7 @@
           <p:cNvPr id="8" name="text-7">
             <a:extLst xmlns:a="http://schemas.openxmlformats.org/drawingml/2006/main">
               <a:ext uri="{FF2B5EF4-FFF2-40B4-BE49-F238E27FC236}">
-                <a16:creationId xmlns:a16="http://schemas.microsoft.com/office/drawing/2014/main" id="{058D59AA-7CB1-4D07-B339-7C57491222C5}"/>
+                <a16:creationId xmlns:a16="http://schemas.microsoft.com/office/drawing/2014/main" id="{8DB7A137-EAC3-4D55-9E86-A1F609F11155}"/>
               </a:ext>
             </a:extLst>
           </p:cNvPr>
@@ -6529,7 +6529,7 @@
           <p:cNvPr id="9" name="text-8">
             <a:extLst xmlns:a="http://schemas.openxmlformats.org/drawingml/2006/main">
               <a:ext uri="{FF2B5EF4-FFF2-40B4-BE49-F238E27FC236}">
-                <a16:creationId xmlns:a16="http://schemas.microsoft.com/office/drawing/2014/main" id="{0F431F18-D4A0-497A-BC89-90EE26C6AA32}"/>
+                <a16:creationId xmlns:a16="http://schemas.microsoft.com/office/drawing/2014/main" id="{EEAD08A1-C3F9-49BE-A470-17E8D767B835}"/>
               </a:ext>
             </a:extLst>
           </p:cNvPr>
@@ -6686,7 +6686,7 @@
     </p:spTree>
     <p:extLst>
       <p:ext uri="{BB962C8B-B14F-4D97-AF65-F5344CB8AC3E}">
-        <p14:creationId xmlns:p14="http://schemas.microsoft.com/office/powerpoint/2010/main" val="917079322"/>
+        <p14:creationId xmlns:p14="http://schemas.microsoft.com/office/powerpoint/2010/main" val="702076027"/>
       </p:ext>
     </p:extLst>
   </p:cSld>
@@ -6717,7 +6717,7 @@
           <p:cNvPr id="6" name="text-0">
             <a:extLst xmlns:a="http://schemas.openxmlformats.org/drawingml/2006/main">
               <a:ext uri="{FF2B5EF4-FFF2-40B4-BE49-F238E27FC236}">
-                <a16:creationId xmlns:a16="http://schemas.microsoft.com/office/drawing/2014/main" id="{E0E1627B-5FE3-4287-B333-F2D964D0C93C}"/>
+                <a16:creationId xmlns:a16="http://schemas.microsoft.com/office/drawing/2014/main" id="{83659B90-63F0-433C-B384-B228C33C01CC}"/>
               </a:ext>
             </a:extLst>
           </p:cNvPr>
@@ -6876,7 +6876,7 @@
           <p:cNvPr id="2" name="text-1">
             <a:extLst xmlns:a="http://schemas.openxmlformats.org/drawingml/2006/main">
               <a:ext uri="{FF2B5EF4-FFF2-40B4-BE49-F238E27FC236}">
-                <a16:creationId xmlns:a16="http://schemas.microsoft.com/office/drawing/2014/main" id="{3A7D0CCA-7994-4676-9CBE-9D10B0C14EBB}"/>
+                <a16:creationId xmlns:a16="http://schemas.microsoft.com/office/drawing/2014/main" id="{B3D3AB8D-C88A-4311-9007-94A4C7B32CDE}"/>
               </a:ext>
             </a:extLst>
           </p:cNvPr>
@@ -7035,7 +7035,7 @@
           <p:cNvPr id="3" name="">
             <a:extLst xmlns:a="http://schemas.openxmlformats.org/drawingml/2006/main">
               <a:ext uri="{FF2B5EF4-FFF2-40B4-BE49-F238E27FC236}">
-                <a16:creationId xmlns:a16="http://schemas.microsoft.com/office/drawing/2014/main" id="{E409B1B7-7148-437E-A9AF-2EA85B629A34}"/>
+                <a16:creationId xmlns:a16="http://schemas.microsoft.com/office/drawing/2014/main" id="{A988D7F6-8752-43DA-84B1-1E5BA9392AA3}"/>
               </a:ext>
             </a:extLst>
           </p:cNvPr>
@@ -7246,7 +7246,7 @@
                           <a:ea typeface="DejaVu Sans"/>
                           <a:cs typeface="DejaVu Sans"/>
                         </a:rPr>
-                        <a:t>817.268.133</a:t>
+                        <a:t>792.550.011</a:t>
                       </a:r>
                     </a:p>
                   </a:txBody>
@@ -7594,7 +7594,7 @@
                           <a:ea typeface="DejaVu Sans"/>
                           <a:cs typeface="DejaVu Sans"/>
                         </a:rPr>
-                        <a:t>1.526.153.453</a:t>
+                        <a:t>1.501.435.331</a:t>
                       </a:r>
                     </a:p>
                   </a:txBody>
@@ -7662,7 +7662,7 @@
           <p:cNvPr id="4" name="text-2">
             <a:extLst xmlns:a="http://schemas.openxmlformats.org/drawingml/2006/main">
               <a:ext uri="{FF2B5EF4-FFF2-40B4-BE49-F238E27FC236}">
-                <a16:creationId xmlns:a16="http://schemas.microsoft.com/office/drawing/2014/main" id="{2B7F8E2A-E744-480B-9548-C37E87C96680}"/>
+                <a16:creationId xmlns:a16="http://schemas.microsoft.com/office/drawing/2014/main" id="{66D9DA5B-54C5-482C-A550-64E8529DC4B7}"/>
               </a:ext>
             </a:extLst>
           </p:cNvPr>
@@ -7821,7 +7821,7 @@
           <p:cNvPr id="5" name="text-3">
             <a:extLst xmlns:a="http://schemas.openxmlformats.org/drawingml/2006/main">
               <a:ext uri="{FF2B5EF4-FFF2-40B4-BE49-F238E27FC236}">
-                <a16:creationId xmlns:a16="http://schemas.microsoft.com/office/drawing/2014/main" id="{4B86DB1F-F437-4B6C-A1DC-9D4C86495F1B}"/>
+                <a16:creationId xmlns:a16="http://schemas.microsoft.com/office/drawing/2014/main" id="{C6169EE3-4C58-432B-9760-C22A7A20FB42}"/>
               </a:ext>
             </a:extLst>
           </p:cNvPr>
@@ -7978,7 +7978,7 @@
     </p:spTree>
     <p:extLst>
       <p:ext uri="{BB962C8B-B14F-4D97-AF65-F5344CB8AC3E}">
-        <p14:creationId xmlns:p14="http://schemas.microsoft.com/office/powerpoint/2010/main" val="103162195"/>
+        <p14:creationId xmlns:p14="http://schemas.microsoft.com/office/powerpoint/2010/main" val="262337770"/>
       </p:ext>
     </p:extLst>
   </p:cSld>
@@ -8009,7 +8009,7 @@
           <p:cNvPr id="9" name="text-0">
             <a:extLst xmlns:a="http://schemas.openxmlformats.org/drawingml/2006/main">
               <a:ext uri="{FF2B5EF4-FFF2-40B4-BE49-F238E27FC236}">
-                <a16:creationId xmlns:a16="http://schemas.microsoft.com/office/drawing/2014/main" id="{CE3270B5-2371-428A-B218-105897FADCDB}"/>
+                <a16:creationId xmlns:a16="http://schemas.microsoft.com/office/drawing/2014/main" id="{6DF6B4EA-8FD5-46D4-AD2C-1E04282F19C9}"/>
               </a:ext>
             </a:extLst>
           </p:cNvPr>
@@ -8158,7 +8158,7 @@
                 <a:ea typeface="DejaVu Sans"/>
                 <a:cs typeface="DejaVu Sans"/>
               </a:rPr>
-              <a:t>Dificultades y decisiones pendientes</a:t>
+              <a:t>Revisión final y límites del diseño</a:t>
             </a:r>
           </a:p>
         </p:txBody>
@@ -8168,7 +8168,7 @@
           <p:cNvPr id="2" name="text-1">
             <a:extLst xmlns:a="http://schemas.openxmlformats.org/drawingml/2006/main">
               <a:ext uri="{FF2B5EF4-FFF2-40B4-BE49-F238E27FC236}">
-                <a16:creationId xmlns:a16="http://schemas.microsoft.com/office/drawing/2014/main" id="{8A3611E7-61B6-43BF-B363-DA9A434F62C6}"/>
+                <a16:creationId xmlns:a16="http://schemas.microsoft.com/office/drawing/2014/main" id="{0C9C7C00-F39A-4DF8-A6F8-FA995BDF4041}"/>
               </a:ext>
             </a:extLst>
           </p:cNvPr>
@@ -8327,7 +8327,7 @@
           <p:cNvPr id="3" name="text-2">
             <a:extLst xmlns:a="http://schemas.openxmlformats.org/drawingml/2006/main">
               <a:ext uri="{FF2B5EF4-FFF2-40B4-BE49-F238E27FC236}">
-                <a16:creationId xmlns:a16="http://schemas.microsoft.com/office/drawing/2014/main" id="{64696DF3-5575-4C91-82F3-D64782D62997}"/>
+                <a16:creationId xmlns:a16="http://schemas.microsoft.com/office/drawing/2014/main" id="{E11ABEFA-822F-4AA3-ABE2-F7E34FA893D9}"/>
               </a:ext>
             </a:extLst>
           </p:cNvPr>
@@ -8476,7 +8476,7 @@
                 <a:ea typeface="DejaVu Sans"/>
                 <a:cs typeface="DejaVu Sans"/>
               </a:rPr>
-              <a:t>Coherencia de la opción A</a:t>
+              <a:t>Ajuste WAN cerrado</a:t>
             </a:r>
           </a:p>
         </p:txBody>
@@ -8486,7 +8486,7 @@
           <p:cNvPr id="4" name="text-3">
             <a:extLst xmlns:a="http://schemas.openxmlformats.org/drawingml/2006/main">
               <a:ext uri="{FF2B5EF4-FFF2-40B4-BE49-F238E27FC236}">
-                <a16:creationId xmlns:a16="http://schemas.microsoft.com/office/drawing/2014/main" id="{BEADEF52-70E2-4873-8435-AB048B739037}"/>
+                <a16:creationId xmlns:a16="http://schemas.microsoft.com/office/drawing/2014/main" id="{08776B12-3345-4857-A9C7-FE0D08771907}"/>
               </a:ext>
             </a:extLst>
           </p:cNvPr>
@@ -8635,7 +8635,7 @@
                 <a:ea typeface="DejaVu Sans"/>
                 <a:cs typeface="DejaVu Sans"/>
               </a:rPr>
-              <a:t>A aún utiliza Cisco C1300 en WAN-A/B. Falta sustituirlos por otra marca y recalcular inventario, puertos y costos.</a:t>
+              <a:t>A y B ya usan distribuidores MikroTik. La revisión WAN-2 concilia modelos, puertos, inventario y presupuesto.</a:t>
             </a:r>
           </a:p>
         </p:txBody>
@@ -8645,7 +8645,7 @@
           <p:cNvPr id="5" name="text-4">
             <a:extLst xmlns:a="http://schemas.openxmlformats.org/drawingml/2006/main">
               <a:ext uri="{FF2B5EF4-FFF2-40B4-BE49-F238E27FC236}">
-                <a16:creationId xmlns:a16="http://schemas.microsoft.com/office/drawing/2014/main" id="{B95A9DE6-4981-4EBC-A548-3C034C35FC74}"/>
+                <a16:creationId xmlns:a16="http://schemas.microsoft.com/office/drawing/2014/main" id="{15930B70-6D0D-4458-A33A-69EB94556457}"/>
               </a:ext>
             </a:extLst>
           </p:cNvPr>
@@ -8804,7 +8804,7 @@
           <p:cNvPr id="6" name="text-5">
             <a:extLst xmlns:a="http://schemas.openxmlformats.org/drawingml/2006/main">
               <a:ext uri="{FF2B5EF4-FFF2-40B4-BE49-F238E27FC236}">
-                <a16:creationId xmlns:a16="http://schemas.microsoft.com/office/drawing/2014/main" id="{2C9315D4-B7EE-4AC4-833E-7A1587F7AE0A}"/>
+                <a16:creationId xmlns:a16="http://schemas.microsoft.com/office/drawing/2014/main" id="{BA6F7C28-F113-495F-B4C3-FE9876831033}"/>
               </a:ext>
             </a:extLst>
           </p:cNvPr>
@@ -8963,7 +8963,7 @@
           <p:cNvPr id="7" name="text-6">
             <a:extLst xmlns:a="http://schemas.openxmlformats.org/drawingml/2006/main">
               <a:ext uri="{FF2B5EF4-FFF2-40B4-BE49-F238E27FC236}">
-                <a16:creationId xmlns:a16="http://schemas.microsoft.com/office/drawing/2014/main" id="{EBA938CD-2E67-448F-90D9-0264197ECD24}"/>
+                <a16:creationId xmlns:a16="http://schemas.microsoft.com/office/drawing/2014/main" id="{85D1EDDE-6CD2-41D2-9CF6-4FEAE6453E93}"/>
               </a:ext>
             </a:extLst>
           </p:cNvPr>
@@ -9122,7 +9122,7 @@
           <p:cNvPr id="8" name="text-7">
             <a:extLst xmlns:a="http://schemas.openxmlformats.org/drawingml/2006/main">
               <a:ext uri="{FF2B5EF4-FFF2-40B4-BE49-F238E27FC236}">
-                <a16:creationId xmlns:a16="http://schemas.microsoft.com/office/drawing/2014/main" id="{C145D820-16C2-41DD-B139-5F85114A34DC}"/>
+                <a16:creationId xmlns:a16="http://schemas.microsoft.com/office/drawing/2014/main" id="{4FCDF9ED-0BE1-44FC-824E-3AE051AE60E1}"/>
               </a:ext>
             </a:extLst>
           </p:cNvPr>
@@ -9279,7 +9279,7 @@
     </p:spTree>
     <p:extLst>
       <p:ext uri="{BB962C8B-B14F-4D97-AF65-F5344CB8AC3E}">
-        <p14:creationId xmlns:p14="http://schemas.microsoft.com/office/powerpoint/2010/main" val="1609352926"/>
+        <p14:creationId xmlns:p14="http://schemas.microsoft.com/office/powerpoint/2010/main" val="134550108"/>
       </p:ext>
     </p:extLst>
   </p:cSld>
@@ -9310,7 +9310,7 @@
           <p:cNvPr id="5" name="text-0">
             <a:extLst xmlns:a="http://schemas.openxmlformats.org/drawingml/2006/main">
               <a:ext uri="{FF2B5EF4-FFF2-40B4-BE49-F238E27FC236}">
-                <a16:creationId xmlns:a16="http://schemas.microsoft.com/office/drawing/2014/main" id="{43BFFD78-F62F-4330-91ED-20F8CF54532A}"/>
+                <a16:creationId xmlns:a16="http://schemas.microsoft.com/office/drawing/2014/main" id="{E5CDC38B-9FAE-46F9-9918-AA6939465DD0}"/>
               </a:ext>
             </a:extLst>
           </p:cNvPr>
@@ -9469,7 +9469,7 @@
           <p:cNvPr id="2" name="text-1">
             <a:extLst xmlns:a="http://schemas.openxmlformats.org/drawingml/2006/main">
               <a:ext uri="{FF2B5EF4-FFF2-40B4-BE49-F238E27FC236}">
-                <a16:creationId xmlns:a16="http://schemas.microsoft.com/office/drawing/2014/main" id="{98F5BE47-1297-4226-9D57-D8B0EDF2461F}"/>
+                <a16:creationId xmlns:a16="http://schemas.microsoft.com/office/drawing/2014/main" id="{AD767768-4107-45E1-99C6-4236D1D32F85}"/>
               </a:ext>
             </a:extLst>
           </p:cNvPr>
@@ -9628,7 +9628,7 @@
           <p:cNvPr id="3" name="">
             <a:extLst xmlns:a="http://schemas.openxmlformats.org/drawingml/2006/main">
               <a:ext uri="{FF2B5EF4-FFF2-40B4-BE49-F238E27FC236}">
-                <a16:creationId xmlns:a16="http://schemas.microsoft.com/office/drawing/2014/main" id="{F86F35CA-1674-432A-9F0B-3DDD6DE1BF35}"/>
+                <a16:creationId xmlns:a16="http://schemas.microsoft.com/office/drawing/2014/main" id="{19540FED-14EA-4B1C-944C-4073CA6C4F0D}"/>
               </a:ext>
             </a:extLst>
           </p:cNvPr>
@@ -9988,7 +9988,7 @@
           <p:cNvPr id="4" name="text-2">
             <a:extLst xmlns:a="http://schemas.openxmlformats.org/drawingml/2006/main">
               <a:ext uri="{FF2B5EF4-FFF2-40B4-BE49-F238E27FC236}">
-                <a16:creationId xmlns:a16="http://schemas.microsoft.com/office/drawing/2014/main" id="{6F4C879F-E36F-42BF-896E-96DCB6A8015B}"/>
+                <a16:creationId xmlns:a16="http://schemas.microsoft.com/office/drawing/2014/main" id="{CAD99BF4-D821-49A9-ADA3-AD18829166DF}"/>
               </a:ext>
             </a:extLst>
           </p:cNvPr>
@@ -10145,7 +10145,7 @@
     </p:spTree>
     <p:extLst>
       <p:ext uri="{BB962C8B-B14F-4D97-AF65-F5344CB8AC3E}">
-        <p14:creationId xmlns:p14="http://schemas.microsoft.com/office/powerpoint/2010/main" val="999532484"/>
+        <p14:creationId xmlns:p14="http://schemas.microsoft.com/office/powerpoint/2010/main" val="279815981"/>
       </p:ext>
     </p:extLst>
   </p:cSld>
@@ -10176,7 +10176,7 @@
           <p:cNvPr id="5" name="text-0">
             <a:extLst xmlns:a="http://schemas.openxmlformats.org/drawingml/2006/main">
               <a:ext uri="{FF2B5EF4-FFF2-40B4-BE49-F238E27FC236}">
-                <a16:creationId xmlns:a16="http://schemas.microsoft.com/office/drawing/2014/main" id="{25FAFAFA-E6A2-429B-ACC4-7042A61061B4}"/>
+                <a16:creationId xmlns:a16="http://schemas.microsoft.com/office/drawing/2014/main" id="{27F0AC76-9E38-4C29-BA48-3400BB4EB787}"/>
               </a:ext>
             </a:extLst>
           </p:cNvPr>
@@ -10335,7 +10335,7 @@
           <p:cNvPr id="2" name="text-1">
             <a:extLst xmlns:a="http://schemas.openxmlformats.org/drawingml/2006/main">
               <a:ext uri="{FF2B5EF4-FFF2-40B4-BE49-F238E27FC236}">
-                <a16:creationId xmlns:a16="http://schemas.microsoft.com/office/drawing/2014/main" id="{B46B2DF4-333F-4C56-8706-F70511429753}"/>
+                <a16:creationId xmlns:a16="http://schemas.microsoft.com/office/drawing/2014/main" id="{4EE9687B-3EBB-4A9F-BBC6-1D6DD56AC53E}"/>
               </a:ext>
             </a:extLst>
           </p:cNvPr>
@@ -10494,7 +10494,7 @@
           <p:cNvPr id="3" name="">
             <a:extLst xmlns:a="http://schemas.openxmlformats.org/drawingml/2006/main">
               <a:ext uri="{FF2B5EF4-FFF2-40B4-BE49-F238E27FC236}">
-                <a16:creationId xmlns:a16="http://schemas.microsoft.com/office/drawing/2014/main" id="{3FD602D0-29B9-4BD9-929C-0A2D76B6B7F8}"/>
+                <a16:creationId xmlns:a16="http://schemas.microsoft.com/office/drawing/2014/main" id="{0AC11D2E-A2D0-4FFC-897E-8DF656F1A88A}"/>
               </a:ext>
             </a:extLst>
           </p:cNvPr>
@@ -10742,7 +10742,7 @@
                           <a:ea typeface="DejaVu Sans"/>
                           <a:cs typeface="DejaVu Sans"/>
                         </a:rPr>
-                        <a:t>Cerrar el cambio WAN de A y actualizar las salidas afectadas.</a:t>
+                        <a:t>Cambio WAN de A cerrado. Revisar el recorrido de la grabación.</a:t>
                       </a:r>
                     </a:p>
                   </a:txBody>
@@ -11014,7 +11014,7 @@
           <p:cNvPr id="4" name="text-2">
             <a:extLst xmlns:a="http://schemas.openxmlformats.org/drawingml/2006/main">
               <a:ext uri="{FF2B5EF4-FFF2-40B4-BE49-F238E27FC236}">
-                <a16:creationId xmlns:a16="http://schemas.microsoft.com/office/drawing/2014/main" id="{8A0C7FFB-DCC8-461A-B756-9F53B8E80260}"/>
+                <a16:creationId xmlns:a16="http://schemas.microsoft.com/office/drawing/2014/main" id="{2D1069FF-3C94-49DD-AA0C-5442E4E7E2B3}"/>
               </a:ext>
             </a:extLst>
           </p:cNvPr>
@@ -11171,7 +11171,7 @@
     </p:spTree>
     <p:extLst>
       <p:ext uri="{BB962C8B-B14F-4D97-AF65-F5344CB8AC3E}">
-        <p14:creationId xmlns:p14="http://schemas.microsoft.com/office/powerpoint/2010/main" val="1596447605"/>
+        <p14:creationId xmlns:p14="http://schemas.microsoft.com/office/powerpoint/2010/main" val="1977542362"/>
       </p:ext>
     </p:extLst>
   </p:cSld>
@@ -11202,7 +11202,7 @@
           <p:cNvPr id="9" name="text-0">
             <a:extLst xmlns:a="http://schemas.openxmlformats.org/drawingml/2006/main">
               <a:ext uri="{FF2B5EF4-FFF2-40B4-BE49-F238E27FC236}">
-                <a16:creationId xmlns:a16="http://schemas.microsoft.com/office/drawing/2014/main" id="{CE59C65C-141A-4E25-BC79-903DECB41E6C}"/>
+                <a16:creationId xmlns:a16="http://schemas.microsoft.com/office/drawing/2014/main" id="{A4464EB4-9F0D-4D9D-984C-A362AAD2F0A7}"/>
               </a:ext>
             </a:extLst>
           </p:cNvPr>
@@ -11361,7 +11361,7 @@
           <p:cNvPr id="2" name="text-1">
             <a:extLst xmlns:a="http://schemas.openxmlformats.org/drawingml/2006/main">
               <a:ext uri="{FF2B5EF4-FFF2-40B4-BE49-F238E27FC236}">
-                <a16:creationId xmlns:a16="http://schemas.microsoft.com/office/drawing/2014/main" id="{883DBB6E-53A9-4D2D-A607-11B5B1B98073}"/>
+                <a16:creationId xmlns:a16="http://schemas.microsoft.com/office/drawing/2014/main" id="{BF3D0EC9-5E26-4ED1-9AD6-6141FF65C902}"/>
               </a:ext>
             </a:extLst>
           </p:cNvPr>
@@ -11520,7 +11520,7 @@
           <p:cNvPr id="3" name="text-2">
             <a:extLst xmlns:a="http://schemas.openxmlformats.org/drawingml/2006/main">
               <a:ext uri="{FF2B5EF4-FFF2-40B4-BE49-F238E27FC236}">
-                <a16:creationId xmlns:a16="http://schemas.microsoft.com/office/drawing/2014/main" id="{851B1186-CD00-41B0-8049-B38C15AF6889}"/>
+                <a16:creationId xmlns:a16="http://schemas.microsoft.com/office/drawing/2014/main" id="{C7205840-C11A-4F2E-A349-501AFDFA7490}"/>
               </a:ext>
             </a:extLst>
           </p:cNvPr>
@@ -11679,7 +11679,7 @@
           <p:cNvPr id="4" name="text-3">
             <a:extLst xmlns:a="http://schemas.openxmlformats.org/drawingml/2006/main">
               <a:ext uri="{FF2B5EF4-FFF2-40B4-BE49-F238E27FC236}">
-                <a16:creationId xmlns:a16="http://schemas.microsoft.com/office/drawing/2014/main" id="{0F2ADA5C-87DC-419C-A10A-714C7AEE156A}"/>
+                <a16:creationId xmlns:a16="http://schemas.microsoft.com/office/drawing/2014/main" id="{311B92CC-326B-4EEE-AE03-DDEC560F7CB3}"/>
               </a:ext>
             </a:extLst>
           </p:cNvPr>
@@ -11866,7 +11866,7 @@
           <p:cNvPr id="5" name="text-4">
             <a:extLst xmlns:a="http://schemas.openxmlformats.org/drawingml/2006/main">
               <a:ext uri="{FF2B5EF4-FFF2-40B4-BE49-F238E27FC236}">
-                <a16:creationId xmlns:a16="http://schemas.microsoft.com/office/drawing/2014/main" id="{E51446C7-102D-4C4D-B4BE-A935A4423D44}"/>
+                <a16:creationId xmlns:a16="http://schemas.microsoft.com/office/drawing/2014/main" id="{3BBF4EC9-2AA4-4F07-9DB9-600345E41D2A}"/>
               </a:ext>
             </a:extLst>
           </p:cNvPr>
@@ -12025,7 +12025,7 @@
           <p:cNvPr id="6" name="text-5">
             <a:extLst xmlns:a="http://schemas.openxmlformats.org/drawingml/2006/main">
               <a:ext uri="{FF2B5EF4-FFF2-40B4-BE49-F238E27FC236}">
-                <a16:creationId xmlns:a16="http://schemas.microsoft.com/office/drawing/2014/main" id="{5F683C5B-78EB-4233-A873-AC0369FC6996}"/>
+                <a16:creationId xmlns:a16="http://schemas.microsoft.com/office/drawing/2014/main" id="{F102EE6D-B0D7-40CE-974F-74B28EA2536C}"/>
               </a:ext>
             </a:extLst>
           </p:cNvPr>
@@ -12212,7 +12212,7 @@
           <p:cNvPr id="7" name="text-6">
             <a:extLst xmlns:a="http://schemas.openxmlformats.org/drawingml/2006/main">
               <a:ext uri="{FF2B5EF4-FFF2-40B4-BE49-F238E27FC236}">
-                <a16:creationId xmlns:a16="http://schemas.microsoft.com/office/drawing/2014/main" id="{66103B27-A27A-42EF-9787-3C11FFF6D167}"/>
+                <a16:creationId xmlns:a16="http://schemas.microsoft.com/office/drawing/2014/main" id="{B69C443B-0F2F-4658-8A37-31373C6D095B}"/>
               </a:ext>
             </a:extLst>
           </p:cNvPr>
@@ -12371,7 +12371,7 @@
           <p:cNvPr id="8" name="text-7">
             <a:extLst xmlns:a="http://schemas.openxmlformats.org/drawingml/2006/main">
               <a:ext uri="{FF2B5EF4-FFF2-40B4-BE49-F238E27FC236}">
-                <a16:creationId xmlns:a16="http://schemas.microsoft.com/office/drawing/2014/main" id="{42D432A5-8D50-4DDC-9F51-EA0B4DACB61C}"/>
+                <a16:creationId xmlns:a16="http://schemas.microsoft.com/office/drawing/2014/main" id="{F2FEB201-C350-482D-92A6-DD5F234E49B1}"/>
               </a:ext>
             </a:extLst>
           </p:cNvPr>
@@ -12520,7 +12520,7 @@
                 <a:ea typeface="DejaVu Sans"/>
                 <a:cs typeface="DejaVu Sans"/>
               </a:rPr>
-              <a:t>Pendientes de esta entrega: ajuste WAN de A, grabación y revisión del video, envío de video y PPT por AVA.</a:t>
+              <a:t>Pendientes de esta entrega: grabación y revisión del video, envío de video y PPT por AVA.</a:t>
             </a:r>
           </a:p>
         </p:txBody>
@@ -12528,7 +12528,7 @@
     </p:spTree>
     <p:extLst>
       <p:ext uri="{BB962C8B-B14F-4D97-AF65-F5344CB8AC3E}">
-        <p14:creationId xmlns:p14="http://schemas.microsoft.com/office/powerpoint/2010/main" val="1784033521"/>
+        <p14:creationId xmlns:p14="http://schemas.microsoft.com/office/powerpoint/2010/main" val="672301099"/>
       </p:ext>
     </p:extLst>
   </p:cSld>
@@ -12559,7 +12559,7 @@
           <p:cNvPr id="8" name="text-0">
             <a:extLst xmlns:a="http://schemas.openxmlformats.org/drawingml/2006/main">
               <a:ext uri="{FF2B5EF4-FFF2-40B4-BE49-F238E27FC236}">
-                <a16:creationId xmlns:a16="http://schemas.microsoft.com/office/drawing/2014/main" id="{9B601BEC-76E5-4BD2-AD13-C1C60CC49040}"/>
+                <a16:creationId xmlns:a16="http://schemas.microsoft.com/office/drawing/2014/main" id="{AC9DA80F-C300-4939-8D0B-CECB52572EB4}"/>
               </a:ext>
             </a:extLst>
           </p:cNvPr>
@@ -12718,7 +12718,7 @@
           <p:cNvPr id="2" name="text-1">
             <a:extLst xmlns:a="http://schemas.openxmlformats.org/drawingml/2006/main">
               <a:ext uri="{FF2B5EF4-FFF2-40B4-BE49-F238E27FC236}">
-                <a16:creationId xmlns:a16="http://schemas.microsoft.com/office/drawing/2014/main" id="{B3E2027C-8EBB-44E9-8106-7C57630B5AF0}"/>
+                <a16:creationId xmlns:a16="http://schemas.microsoft.com/office/drawing/2014/main" id="{38B20E09-0F2F-4D75-8505-ED42E4778C90}"/>
               </a:ext>
             </a:extLst>
           </p:cNvPr>
@@ -12877,7 +12877,7 @@
           <p:cNvPr id="3" name="text-2">
             <a:extLst xmlns:a="http://schemas.openxmlformats.org/drawingml/2006/main">
               <a:ext uri="{FF2B5EF4-FFF2-40B4-BE49-F238E27FC236}">
-                <a16:creationId xmlns:a16="http://schemas.microsoft.com/office/drawing/2014/main" id="{43AEEFE5-D040-4D79-BDA8-92688A861283}"/>
+                <a16:creationId xmlns:a16="http://schemas.microsoft.com/office/drawing/2014/main" id="{8A10B46E-4642-4E5B-9C16-C8562F4474D7}"/>
               </a:ext>
             </a:extLst>
           </p:cNvPr>
@@ -13036,7 +13036,7 @@
           <p:cNvPr id="4" name="text-3">
             <a:extLst xmlns:a="http://schemas.openxmlformats.org/drawingml/2006/main">
               <a:ext uri="{FF2B5EF4-FFF2-40B4-BE49-F238E27FC236}">
-                <a16:creationId xmlns:a16="http://schemas.microsoft.com/office/drawing/2014/main" id="{64824920-4109-4C12-B96B-9CC4A49E3DA1}"/>
+                <a16:creationId xmlns:a16="http://schemas.microsoft.com/office/drawing/2014/main" id="{6DAEBF1F-74DF-40BB-8662-415F2C29E634}"/>
               </a:ext>
             </a:extLst>
           </p:cNvPr>
@@ -13251,7 +13251,7 @@
           <p:cNvPr id="5" name="text-4">
             <a:extLst xmlns:a="http://schemas.openxmlformats.org/drawingml/2006/main">
               <a:ext uri="{FF2B5EF4-FFF2-40B4-BE49-F238E27FC236}">
-                <a16:creationId xmlns:a16="http://schemas.microsoft.com/office/drawing/2014/main" id="{29FFAAC6-9CFE-4DD8-9D25-03E666327BEC}"/>
+                <a16:creationId xmlns:a16="http://schemas.microsoft.com/office/drawing/2014/main" id="{9929D680-EF56-49F5-BE4E-55FC4FB6B22B}"/>
               </a:ext>
             </a:extLst>
           </p:cNvPr>
@@ -13410,7 +13410,7 @@
           <p:cNvPr id="6" name="text-5">
             <a:extLst xmlns:a="http://schemas.openxmlformats.org/drawingml/2006/main">
               <a:ext uri="{FF2B5EF4-FFF2-40B4-BE49-F238E27FC236}">
-                <a16:creationId xmlns:a16="http://schemas.microsoft.com/office/drawing/2014/main" id="{85315AB0-36E8-4A35-9059-39F25C534756}"/>
+                <a16:creationId xmlns:a16="http://schemas.microsoft.com/office/drawing/2014/main" id="{7DECEA33-B2C8-4391-80D0-35DE1A5804CD}"/>
               </a:ext>
             </a:extLst>
           </p:cNvPr>
@@ -13625,7 +13625,7 @@
           <p:cNvPr id="7" name="text-6">
             <a:extLst xmlns:a="http://schemas.openxmlformats.org/drawingml/2006/main">
               <a:ext uri="{FF2B5EF4-FFF2-40B4-BE49-F238E27FC236}">
-                <a16:creationId xmlns:a16="http://schemas.microsoft.com/office/drawing/2014/main" id="{1C2C5F41-A4CE-41B4-A450-5A5ACF559A86}"/>
+                <a16:creationId xmlns:a16="http://schemas.microsoft.com/office/drawing/2014/main" id="{155BCB47-CC8B-4430-8997-CF187B107B6D}"/>
               </a:ext>
             </a:extLst>
           </p:cNvPr>
@@ -13782,7 +13782,7 @@
     </p:spTree>
     <p:extLst>
       <p:ext uri="{BB962C8B-B14F-4D97-AF65-F5344CB8AC3E}">
-        <p14:creationId xmlns:p14="http://schemas.microsoft.com/office/powerpoint/2010/main" val="341326297"/>
+        <p14:creationId xmlns:p14="http://schemas.microsoft.com/office/powerpoint/2010/main" val="571669159"/>
       </p:ext>
     </p:extLst>
   </p:cSld>
@@ -13813,7 +13813,7 @@
           <p:cNvPr id="5" name="text-0">
             <a:extLst xmlns:a="http://schemas.openxmlformats.org/drawingml/2006/main">
               <a:ext uri="{FF2B5EF4-FFF2-40B4-BE49-F238E27FC236}">
-                <a16:creationId xmlns:a16="http://schemas.microsoft.com/office/drawing/2014/main" id="{C93ECC1F-E340-48A9-B759-983E0B01D026}"/>
+                <a16:creationId xmlns:a16="http://schemas.microsoft.com/office/drawing/2014/main" id="{65C969E9-7E24-43F4-9F3D-1541EA4DE387}"/>
               </a:ext>
             </a:extLst>
           </p:cNvPr>
@@ -13972,7 +13972,7 @@
           <p:cNvPr id="2" name="text-1">
             <a:extLst xmlns:a="http://schemas.openxmlformats.org/drawingml/2006/main">
               <a:ext uri="{FF2B5EF4-FFF2-40B4-BE49-F238E27FC236}">
-                <a16:creationId xmlns:a16="http://schemas.microsoft.com/office/drawing/2014/main" id="{63FBDAF7-EC9A-418E-B66C-C24E8022C889}"/>
+                <a16:creationId xmlns:a16="http://schemas.microsoft.com/office/drawing/2014/main" id="{DF23105E-659B-4255-986E-063D1AABE84D}"/>
               </a:ext>
             </a:extLst>
           </p:cNvPr>
@@ -14131,7 +14131,7 @@
           <p:cNvPr id="3" name="">
             <a:extLst xmlns:a="http://schemas.openxmlformats.org/drawingml/2006/main">
               <a:ext uri="{FF2B5EF4-FFF2-40B4-BE49-F238E27FC236}">
-                <a16:creationId xmlns:a16="http://schemas.microsoft.com/office/drawing/2014/main" id="{312D8F18-D8F6-48EB-822F-37FA33A851C2}"/>
+                <a16:creationId xmlns:a16="http://schemas.microsoft.com/office/drawing/2014/main" id="{06997678-3B5E-4A7A-8457-D26809B1EAD8}"/>
               </a:ext>
             </a:extLst>
           </p:cNvPr>
@@ -14491,7 +14491,7 @@
           <p:cNvPr id="4" name="text-2">
             <a:extLst xmlns:a="http://schemas.openxmlformats.org/drawingml/2006/main">
               <a:ext uri="{FF2B5EF4-FFF2-40B4-BE49-F238E27FC236}">
-                <a16:creationId xmlns:a16="http://schemas.microsoft.com/office/drawing/2014/main" id="{C6E33796-9229-4C92-ADAA-31090CB0B423}"/>
+                <a16:creationId xmlns:a16="http://schemas.microsoft.com/office/drawing/2014/main" id="{2613C4B0-A5C1-475D-B0F4-684DCAF93F12}"/>
               </a:ext>
             </a:extLst>
           </p:cNvPr>
@@ -14648,7 +14648,7 @@
     </p:spTree>
     <p:extLst>
       <p:ext uri="{BB962C8B-B14F-4D97-AF65-F5344CB8AC3E}">
-        <p14:creationId xmlns:p14="http://schemas.microsoft.com/office/powerpoint/2010/main" val="1159261813"/>
+        <p14:creationId xmlns:p14="http://schemas.microsoft.com/office/powerpoint/2010/main" val="956373861"/>
       </p:ext>
     </p:extLst>
   </p:cSld>
@@ -14679,7 +14679,7 @@
           <p:cNvPr id="6" name="text-0">
             <a:extLst xmlns:a="http://schemas.openxmlformats.org/drawingml/2006/main">
               <a:ext uri="{FF2B5EF4-FFF2-40B4-BE49-F238E27FC236}">
-                <a16:creationId xmlns:a16="http://schemas.microsoft.com/office/drawing/2014/main" id="{80223423-8642-4EF1-B10A-5FD69A03FC0C}"/>
+                <a16:creationId xmlns:a16="http://schemas.microsoft.com/office/drawing/2014/main" id="{318142DD-5E09-4FF5-A23C-BDAAC46ECBAD}"/>
               </a:ext>
             </a:extLst>
           </p:cNvPr>
@@ -14838,7 +14838,7 @@
           <p:cNvPr id="2" name="text-1">
             <a:extLst xmlns:a="http://schemas.openxmlformats.org/drawingml/2006/main">
               <a:ext uri="{FF2B5EF4-FFF2-40B4-BE49-F238E27FC236}">
-                <a16:creationId xmlns:a16="http://schemas.microsoft.com/office/drawing/2014/main" id="{F7A73F17-78F2-483E-AE7B-2C5F096B8183}"/>
+                <a16:creationId xmlns:a16="http://schemas.microsoft.com/office/drawing/2014/main" id="{260EBB74-998D-410F-BDF6-37B68EFCE4D9}"/>
               </a:ext>
             </a:extLst>
           </p:cNvPr>
@@ -14997,7 +14997,7 @@
           <p:cNvPr id="3" name="">
             <a:extLst xmlns:a="http://schemas.openxmlformats.org/drawingml/2006/main">
               <a:ext uri="{FF2B5EF4-FFF2-40B4-BE49-F238E27FC236}">
-                <a16:creationId xmlns:a16="http://schemas.microsoft.com/office/drawing/2014/main" id="{BAFA4DF9-E897-4AF3-89B4-612F7A69CDAB}"/>
+                <a16:creationId xmlns:a16="http://schemas.microsoft.com/office/drawing/2014/main" id="{84D7E6B0-B2ED-4D10-94AC-764A18C45A7A}"/>
               </a:ext>
             </a:extLst>
           </p:cNvPr>
@@ -15007,7 +15007,7 @@
           <p:nvPr/>
         </p:nvPicPr>
         <p:blipFill>
-          <a:blip xmlns:r="http://schemas.openxmlformats.org/officeDocument/2006/relationships" xmlns:a="http://schemas.openxmlformats.org/drawingml/2006/main" r:embed="R84b66c4f9da643fc"/>
+          <a:blip xmlns:r="http://schemas.openxmlformats.org/officeDocument/2006/relationships" xmlns:a="http://schemas.openxmlformats.org/drawingml/2006/main" r:embed="R7c2cd2e13e814a17"/>
           <a:stretch xmlns:a="http://schemas.openxmlformats.org/drawingml/2006/main"/>
         </p:blipFill>
         <p:spPr>
@@ -15025,7 +15025,7 @@
           <p:cNvPr id="4" name="text-2">
             <a:extLst xmlns:a="http://schemas.openxmlformats.org/drawingml/2006/main">
               <a:ext uri="{FF2B5EF4-FFF2-40B4-BE49-F238E27FC236}">
-                <a16:creationId xmlns:a16="http://schemas.microsoft.com/office/drawing/2014/main" id="{16C3FE3A-C171-4F14-86A2-5314A888763A}"/>
+                <a16:creationId xmlns:a16="http://schemas.microsoft.com/office/drawing/2014/main" id="{54F3FCFA-A0E6-451F-8295-D0D5897959C7}"/>
               </a:ext>
             </a:extLst>
           </p:cNvPr>
@@ -15184,7 +15184,7 @@
           <p:cNvPr id="5" name="text-3">
             <a:extLst xmlns:a="http://schemas.openxmlformats.org/drawingml/2006/main">
               <a:ext uri="{FF2B5EF4-FFF2-40B4-BE49-F238E27FC236}">
-                <a16:creationId xmlns:a16="http://schemas.microsoft.com/office/drawing/2014/main" id="{AD885E96-83B9-45D6-B156-2F38BF497463}"/>
+                <a16:creationId xmlns:a16="http://schemas.microsoft.com/office/drawing/2014/main" id="{B7EB25AB-AE7D-4314-BF59-0080EF98A56B}"/>
               </a:ext>
             </a:extLst>
           </p:cNvPr>
@@ -15341,7 +15341,7 @@
     </p:spTree>
     <p:extLst>
       <p:ext uri="{BB962C8B-B14F-4D97-AF65-F5344CB8AC3E}">
-        <p14:creationId xmlns:p14="http://schemas.microsoft.com/office/powerpoint/2010/main" val="1474988300"/>
+        <p14:creationId xmlns:p14="http://schemas.microsoft.com/office/powerpoint/2010/main" val="969651781"/>
       </p:ext>
     </p:extLst>
   </p:cSld>
@@ -15372,7 +15372,7 @@
           <p:cNvPr id="5" name="text-0">
             <a:extLst xmlns:a="http://schemas.openxmlformats.org/drawingml/2006/main">
               <a:ext uri="{FF2B5EF4-FFF2-40B4-BE49-F238E27FC236}">
-                <a16:creationId xmlns:a16="http://schemas.microsoft.com/office/drawing/2014/main" id="{9DDF1343-12C3-44DF-A6EE-D9169092749A}"/>
+                <a16:creationId xmlns:a16="http://schemas.microsoft.com/office/drawing/2014/main" id="{B503FEEB-1584-451B-B7C1-D2ECB0CFE653}"/>
               </a:ext>
             </a:extLst>
           </p:cNvPr>
@@ -15531,7 +15531,7 @@
           <p:cNvPr id="2" name="text-1">
             <a:extLst xmlns:a="http://schemas.openxmlformats.org/drawingml/2006/main">
               <a:ext uri="{FF2B5EF4-FFF2-40B4-BE49-F238E27FC236}">
-                <a16:creationId xmlns:a16="http://schemas.microsoft.com/office/drawing/2014/main" id="{07F79653-A327-4901-9EA0-829DA4B12287}"/>
+                <a16:creationId xmlns:a16="http://schemas.microsoft.com/office/drawing/2014/main" id="{D0572C7A-2BA2-4F8A-9255-FC7AEF8A5664}"/>
               </a:ext>
             </a:extLst>
           </p:cNvPr>
@@ -15690,7 +15690,7 @@
           <p:cNvPr id="3" name="">
             <a:extLst xmlns:a="http://schemas.openxmlformats.org/drawingml/2006/main">
               <a:ext uri="{FF2B5EF4-FFF2-40B4-BE49-F238E27FC236}">
-                <a16:creationId xmlns:a16="http://schemas.microsoft.com/office/drawing/2014/main" id="{37B8B981-553F-47AF-8FF1-E629A04CBF78}"/>
+                <a16:creationId xmlns:a16="http://schemas.microsoft.com/office/drawing/2014/main" id="{DFC67B83-FD8C-4F2E-9754-1E494ACEB33D}"/>
               </a:ext>
             </a:extLst>
           </p:cNvPr>
@@ -16275,20 +16275,7 @@
                           <a:ea typeface="DejaVu Sans"/>
                           <a:cs typeface="DejaVu Sans"/>
                         </a:rPr>
-                        <a:t>45 C1300 GE y 1 multigig</a:t>
-                      </a:r>
-                    </a:p>
-                    <a:p>
-                      <a:r>
-                        <a:rPr sz="1725">
-                          <a:solidFill>
-                            <a:srgbClr val="102638"/>
-                          </a:solidFill>
-                          <a:latin typeface="DejaVu Sans"/>
-                          <a:ea typeface="DejaVu Sans"/>
-                          <a:cs typeface="DejaVu Sans"/>
-                        </a:rPr>
-                        <a:t>Cambio de marca pendiente</a:t>
+                        <a:t>45 hEX E50UG y 1 CRS310</a:t>
                       </a:r>
                     </a:p>
                   </a:txBody>
@@ -16356,7 +16343,7 @@
           <p:cNvPr id="4" name="text-2">
             <a:extLst xmlns:a="http://schemas.openxmlformats.org/drawingml/2006/main">
               <a:ext uri="{FF2B5EF4-FFF2-40B4-BE49-F238E27FC236}">
-                <a16:creationId xmlns:a16="http://schemas.microsoft.com/office/drawing/2014/main" id="{AE402265-25FC-4FFF-81AF-B2321D4C3CBF}"/>
+                <a16:creationId xmlns:a16="http://schemas.microsoft.com/office/drawing/2014/main" id="{48770BC2-9BCD-49FE-B907-D140BA72AD87}"/>
               </a:ext>
             </a:extLst>
           </p:cNvPr>
@@ -16513,7 +16500,7 @@
     </p:spTree>
     <p:extLst>
       <p:ext uri="{BB962C8B-B14F-4D97-AF65-F5344CB8AC3E}">
-        <p14:creationId xmlns:p14="http://schemas.microsoft.com/office/powerpoint/2010/main" val="1493202071"/>
+        <p14:creationId xmlns:p14="http://schemas.microsoft.com/office/powerpoint/2010/main" val="581809988"/>
       </p:ext>
     </p:extLst>
   </p:cSld>
@@ -16544,7 +16531,7 @@
           <p:cNvPr id="5" name="text-0">
             <a:extLst xmlns:a="http://schemas.openxmlformats.org/drawingml/2006/main">
               <a:ext uri="{FF2B5EF4-FFF2-40B4-BE49-F238E27FC236}">
-                <a16:creationId xmlns:a16="http://schemas.microsoft.com/office/drawing/2014/main" id="{CB108B3D-D59B-403A-AAE7-004B700A1EBE}"/>
+                <a16:creationId xmlns:a16="http://schemas.microsoft.com/office/drawing/2014/main" id="{54799513-7A3D-4348-B658-34F05001F6E0}"/>
               </a:ext>
             </a:extLst>
           </p:cNvPr>
@@ -16703,7 +16690,7 @@
           <p:cNvPr id="2" name="text-1">
             <a:extLst xmlns:a="http://schemas.openxmlformats.org/drawingml/2006/main">
               <a:ext uri="{FF2B5EF4-FFF2-40B4-BE49-F238E27FC236}">
-                <a16:creationId xmlns:a16="http://schemas.microsoft.com/office/drawing/2014/main" id="{B41885ED-E777-4D85-9CBD-04DB61B1739E}"/>
+                <a16:creationId xmlns:a16="http://schemas.microsoft.com/office/drawing/2014/main" id="{5916F03B-48F4-4883-B911-0003EC8E7A59}"/>
               </a:ext>
             </a:extLst>
           </p:cNvPr>
@@ -16862,7 +16849,7 @@
           <p:cNvPr id="3" name="">
             <a:extLst xmlns:a="http://schemas.openxmlformats.org/drawingml/2006/main">
               <a:ext uri="{FF2B5EF4-FFF2-40B4-BE49-F238E27FC236}">
-                <a16:creationId xmlns:a16="http://schemas.microsoft.com/office/drawing/2014/main" id="{1F52A53B-E0C0-403A-80B2-8FCF3C83C31B}"/>
+                <a16:creationId xmlns:a16="http://schemas.microsoft.com/office/drawing/2014/main" id="{C0C328E5-A076-49A7-9CDC-2C5617152A55}"/>
               </a:ext>
             </a:extLst>
           </p:cNvPr>
@@ -17515,7 +17502,7 @@
           <p:cNvPr id="4" name="text-2">
             <a:extLst xmlns:a="http://schemas.openxmlformats.org/drawingml/2006/main">
               <a:ext uri="{FF2B5EF4-FFF2-40B4-BE49-F238E27FC236}">
-                <a16:creationId xmlns:a16="http://schemas.microsoft.com/office/drawing/2014/main" id="{862460EA-80F0-48AF-BB07-352214B6920A}"/>
+                <a16:creationId xmlns:a16="http://schemas.microsoft.com/office/drawing/2014/main" id="{088E488D-964E-4335-8B21-E49B1DF2B59E}"/>
               </a:ext>
             </a:extLst>
           </p:cNvPr>
@@ -17672,7 +17659,7 @@
     </p:spTree>
     <p:extLst>
       <p:ext uri="{BB962C8B-B14F-4D97-AF65-F5344CB8AC3E}">
-        <p14:creationId xmlns:p14="http://schemas.microsoft.com/office/powerpoint/2010/main" val="1126393499"/>
+        <p14:creationId xmlns:p14="http://schemas.microsoft.com/office/powerpoint/2010/main" val="1746162918"/>
       </p:ext>
     </p:extLst>
   </p:cSld>
@@ -17703,7 +17690,7 @@
           <p:cNvPr id="9" name="text-0">
             <a:extLst xmlns:a="http://schemas.openxmlformats.org/drawingml/2006/main">
               <a:ext uri="{FF2B5EF4-FFF2-40B4-BE49-F238E27FC236}">
-                <a16:creationId xmlns:a16="http://schemas.microsoft.com/office/drawing/2014/main" id="{C03D8C1D-E559-4C16-80BD-68FE2F10F1E8}"/>
+                <a16:creationId xmlns:a16="http://schemas.microsoft.com/office/drawing/2014/main" id="{727886E3-7B5C-4B4C-89D2-5EC10D58E9C6}"/>
               </a:ext>
             </a:extLst>
           </p:cNvPr>
@@ -17862,7 +17849,7 @@
           <p:cNvPr id="2" name="text-1">
             <a:extLst xmlns:a="http://schemas.openxmlformats.org/drawingml/2006/main">
               <a:ext uri="{FF2B5EF4-FFF2-40B4-BE49-F238E27FC236}">
-                <a16:creationId xmlns:a16="http://schemas.microsoft.com/office/drawing/2014/main" id="{9BB842EE-BACD-4CF3-8B13-1FE8ECEB6EE9}"/>
+                <a16:creationId xmlns:a16="http://schemas.microsoft.com/office/drawing/2014/main" id="{BBF3DB2A-3E08-47FF-8270-3259FF4D4B82}"/>
               </a:ext>
             </a:extLst>
           </p:cNvPr>
@@ -18021,7 +18008,7 @@
           <p:cNvPr id="3" name="text-2">
             <a:extLst xmlns:a="http://schemas.openxmlformats.org/drawingml/2006/main">
               <a:ext uri="{FF2B5EF4-FFF2-40B4-BE49-F238E27FC236}">
-                <a16:creationId xmlns:a16="http://schemas.microsoft.com/office/drawing/2014/main" id="{BF374E86-0680-4F66-9285-5348268B0C60}"/>
+                <a16:creationId xmlns:a16="http://schemas.microsoft.com/office/drawing/2014/main" id="{C51DD794-8DCF-4AA7-86A1-32D35A14E64E}"/>
               </a:ext>
             </a:extLst>
           </p:cNvPr>
@@ -18180,7 +18167,7 @@
           <p:cNvPr id="4" name="text-3">
             <a:extLst xmlns:a="http://schemas.openxmlformats.org/drawingml/2006/main">
               <a:ext uri="{FF2B5EF4-FFF2-40B4-BE49-F238E27FC236}">
-                <a16:creationId xmlns:a16="http://schemas.microsoft.com/office/drawing/2014/main" id="{41A2CBBE-13A8-47B4-A084-A3D659A2B9E2}"/>
+                <a16:creationId xmlns:a16="http://schemas.microsoft.com/office/drawing/2014/main" id="{4F490D54-9642-4B8E-8B42-DCB1082E2D1D}"/>
               </a:ext>
             </a:extLst>
           </p:cNvPr>
@@ -18367,7 +18354,7 @@
           <p:cNvPr id="5" name="text-4">
             <a:extLst xmlns:a="http://schemas.openxmlformats.org/drawingml/2006/main">
               <a:ext uri="{FF2B5EF4-FFF2-40B4-BE49-F238E27FC236}">
-                <a16:creationId xmlns:a16="http://schemas.microsoft.com/office/drawing/2014/main" id="{00E3E81C-AF1F-4536-A36F-F729C076E18E}"/>
+                <a16:creationId xmlns:a16="http://schemas.microsoft.com/office/drawing/2014/main" id="{B5F0578B-B712-42EB-BEB7-226871E1E083}"/>
               </a:ext>
             </a:extLst>
           </p:cNvPr>
@@ -18526,7 +18513,7 @@
           <p:cNvPr id="6" name="text-5">
             <a:extLst xmlns:a="http://schemas.openxmlformats.org/drawingml/2006/main">
               <a:ext uri="{FF2B5EF4-FFF2-40B4-BE49-F238E27FC236}">
-                <a16:creationId xmlns:a16="http://schemas.microsoft.com/office/drawing/2014/main" id="{A8524952-F597-48AD-957E-17848D89A64D}"/>
+                <a16:creationId xmlns:a16="http://schemas.microsoft.com/office/drawing/2014/main" id="{8636CD48-5BD6-4395-8F38-0C9FF24DB1D1}"/>
               </a:ext>
             </a:extLst>
           </p:cNvPr>
@@ -18713,7 +18700,7 @@
           <p:cNvPr id="7" name="text-6">
             <a:extLst xmlns:a="http://schemas.openxmlformats.org/drawingml/2006/main">
               <a:ext uri="{FF2B5EF4-FFF2-40B4-BE49-F238E27FC236}">
-                <a16:creationId xmlns:a16="http://schemas.microsoft.com/office/drawing/2014/main" id="{D75C2A90-8DDC-4A9A-B172-C60BFEA13785}"/>
+                <a16:creationId xmlns:a16="http://schemas.microsoft.com/office/drawing/2014/main" id="{E9385689-DA2F-4377-8FD1-0384FEB5438E}"/>
               </a:ext>
             </a:extLst>
           </p:cNvPr>
@@ -18872,7 +18859,7 @@
           <p:cNvPr id="8" name="text-7">
             <a:extLst xmlns:a="http://schemas.openxmlformats.org/drawingml/2006/main">
               <a:ext uri="{FF2B5EF4-FFF2-40B4-BE49-F238E27FC236}">
-                <a16:creationId xmlns:a16="http://schemas.microsoft.com/office/drawing/2014/main" id="{033CF077-F9CA-43D0-9016-DBBE129070FC}"/>
+                <a16:creationId xmlns:a16="http://schemas.microsoft.com/office/drawing/2014/main" id="{7238FC74-7C06-493A-843E-B7E4785C1D6D}"/>
               </a:ext>
             </a:extLst>
           </p:cNvPr>
@@ -19029,7 +19016,7 @@
     </p:spTree>
     <p:extLst>
       <p:ext uri="{BB962C8B-B14F-4D97-AF65-F5344CB8AC3E}">
-        <p14:creationId xmlns:p14="http://schemas.microsoft.com/office/powerpoint/2010/main" val="573535855"/>
+        <p14:creationId xmlns:p14="http://schemas.microsoft.com/office/powerpoint/2010/main" val="1192892186"/>
       </p:ext>
     </p:extLst>
   </p:cSld>
@@ -19060,7 +19047,7 @@
           <p:cNvPr id="6" name="text-0">
             <a:extLst xmlns:a="http://schemas.openxmlformats.org/drawingml/2006/main">
               <a:ext uri="{FF2B5EF4-FFF2-40B4-BE49-F238E27FC236}">
-                <a16:creationId xmlns:a16="http://schemas.microsoft.com/office/drawing/2014/main" id="{94EEDC29-437A-4641-9232-3FB762BCF46E}"/>
+                <a16:creationId xmlns:a16="http://schemas.microsoft.com/office/drawing/2014/main" id="{B064DFD7-B409-4E4B-AE30-7425D02AF5E1}"/>
               </a:ext>
             </a:extLst>
           </p:cNvPr>
@@ -19219,7 +19206,7 @@
           <p:cNvPr id="2" name="text-1">
             <a:extLst xmlns:a="http://schemas.openxmlformats.org/drawingml/2006/main">
               <a:ext uri="{FF2B5EF4-FFF2-40B4-BE49-F238E27FC236}">
-                <a16:creationId xmlns:a16="http://schemas.microsoft.com/office/drawing/2014/main" id="{312C146D-7BFA-4CD7-84EF-5D58E92A91A3}"/>
+                <a16:creationId xmlns:a16="http://schemas.microsoft.com/office/drawing/2014/main" id="{B77155C4-8753-499C-A5FC-B6C6FF4423B0}"/>
               </a:ext>
             </a:extLst>
           </p:cNvPr>
@@ -19378,7 +19365,7 @@
           <p:cNvPr id="3" name="">
             <a:extLst xmlns:a="http://schemas.openxmlformats.org/drawingml/2006/main">
               <a:ext uri="{FF2B5EF4-FFF2-40B4-BE49-F238E27FC236}">
-                <a16:creationId xmlns:a16="http://schemas.microsoft.com/office/drawing/2014/main" id="{253CE978-A2BF-464A-AAE7-C2C3757558CB}"/>
+                <a16:creationId xmlns:a16="http://schemas.microsoft.com/office/drawing/2014/main" id="{9609310D-657B-4D94-81D2-7BD013D32E95}"/>
               </a:ext>
             </a:extLst>
           </p:cNvPr>
@@ -19818,7 +19805,7 @@
           <p:cNvPr id="4" name="text-2">
             <a:extLst xmlns:a="http://schemas.openxmlformats.org/drawingml/2006/main">
               <a:ext uri="{FF2B5EF4-FFF2-40B4-BE49-F238E27FC236}">
-                <a16:creationId xmlns:a16="http://schemas.microsoft.com/office/drawing/2014/main" id="{F9051673-64BD-4438-8C46-6D3A0657534A}"/>
+                <a16:creationId xmlns:a16="http://schemas.microsoft.com/office/drawing/2014/main" id="{61037176-034C-4E05-BA7F-8E5A0EE9FD06}"/>
               </a:ext>
             </a:extLst>
           </p:cNvPr>
@@ -19966,7 +19953,7 @@
                 <a:latin typeface="DejaVu Sans"/>
                 <a:ea typeface="DejaVu Sans"/>
                 <a:cs typeface="DejaVu Sans"/>
-                <a:hlinkClick xmlns:r="http://schemas.openxmlformats.org/officeDocument/2006/relationships" r:id="Rb48e0d6d04d74070"/>
+                <a:hlinkClick xmlns:r="http://schemas.openxmlformats.org/officeDocument/2006/relationships" r:id="R7dee3f55b8854e8f"/>
               </a:rPr>
               <a:t>Abrir simulador</a:t>
             </a:r>
@@ -19978,7 +19965,7 @@
           <p:cNvPr id="5" name="text-3">
             <a:extLst xmlns:a="http://schemas.openxmlformats.org/drawingml/2006/main">
               <a:ext uri="{FF2B5EF4-FFF2-40B4-BE49-F238E27FC236}">
-                <a16:creationId xmlns:a16="http://schemas.microsoft.com/office/drawing/2014/main" id="{FBD798C3-E17D-4427-B41F-D8E1C0C3F0CD}"/>
+                <a16:creationId xmlns:a16="http://schemas.microsoft.com/office/drawing/2014/main" id="{3EE3AE0C-E48E-4659-B48E-3AAB87D781D9}"/>
               </a:ext>
             </a:extLst>
           </p:cNvPr>
@@ -20135,7 +20122,7 @@
     </p:spTree>
     <p:extLst>
       <p:ext uri="{BB962C8B-B14F-4D97-AF65-F5344CB8AC3E}">
-        <p14:creationId xmlns:p14="http://schemas.microsoft.com/office/powerpoint/2010/main" val="421397231"/>
+        <p14:creationId xmlns:p14="http://schemas.microsoft.com/office/powerpoint/2010/main" val="1396155895"/>
       </p:ext>
     </p:extLst>
   </p:cSld>

</xml_diff>

<commit_message>
Actualizar fuentes de las notas del PowerPoint al repositorio docente vigente
Conserva las 14 láminas, diagramas y tablas. Notas con fuentes públicas actuales y alcance de la política de admisión. ZIP y manifiesto conciliados.
</commit_message>
<xml_diff>
--- a/Presentacion/Avance_Financiera_Pacifico_30_oct_2026.pptx
+++ b/Presentacion/Avance_Financiera_Pacifico_30_oct_2026.pptx
@@ -2,26 +2,26 @@
 <file path=ppt/presentation.xml><?xml version="1.0" encoding="utf-8"?>
 <p:presentation xmlns:p="http://schemas.openxmlformats.org/presentationml/2006/main">
   <p:sldMasterIdLst>
-    <p:sldMasterId xmlns:r="http://schemas.openxmlformats.org/officeDocument/2006/relationships" id="2147483648" r:id="R4194250760f1496e"/>
+    <p:sldMasterId xmlns:r="http://schemas.openxmlformats.org/officeDocument/2006/relationships" id="2147483648" r:id="R2426cf42b274414d"/>
   </p:sldMasterIdLst>
   <p:notesMasterIdLst>
-    <p:notesMasterId xmlns:r="http://schemas.openxmlformats.org/officeDocument/2006/relationships" r:id="R6800d4dd78f74b75"/>
+    <p:notesMasterId xmlns:r="http://schemas.openxmlformats.org/officeDocument/2006/relationships" r:id="R0099701976364e86"/>
   </p:notesMasterIdLst>
   <p:sldIdLst>
-    <p:sldId xmlns:r="http://schemas.openxmlformats.org/officeDocument/2006/relationships" id="256" r:id="Rdc8a833493c5495b"/>
-    <p:sldId xmlns:r="http://schemas.openxmlformats.org/officeDocument/2006/relationships" id="257" r:id="Ra61ab16fc3c24ad1"/>
-    <p:sldId xmlns:r="http://schemas.openxmlformats.org/officeDocument/2006/relationships" id="258" r:id="Rbea6848bb9694cc0"/>
-    <p:sldId xmlns:r="http://schemas.openxmlformats.org/officeDocument/2006/relationships" id="259" r:id="Rc8490331ed0a4248"/>
-    <p:sldId xmlns:r="http://schemas.openxmlformats.org/officeDocument/2006/relationships" id="260" r:id="R0d7f5b678c1943e3"/>
-    <p:sldId xmlns:r="http://schemas.openxmlformats.org/officeDocument/2006/relationships" id="261" r:id="R9f46d9a3632442ba"/>
-    <p:sldId xmlns:r="http://schemas.openxmlformats.org/officeDocument/2006/relationships" id="262" r:id="R6d854621f4bb48fe"/>
-    <p:sldId xmlns:r="http://schemas.openxmlformats.org/officeDocument/2006/relationships" id="263" r:id="R980d1c69d5bd4119"/>
-    <p:sldId xmlns:r="http://schemas.openxmlformats.org/officeDocument/2006/relationships" id="264" r:id="R109199951c134ff4"/>
-    <p:sldId xmlns:r="http://schemas.openxmlformats.org/officeDocument/2006/relationships" id="265" r:id="Rb1c78414f18b43be"/>
-    <p:sldId xmlns:r="http://schemas.openxmlformats.org/officeDocument/2006/relationships" id="266" r:id="Rc928f2831ece4646"/>
-    <p:sldId xmlns:r="http://schemas.openxmlformats.org/officeDocument/2006/relationships" id="267" r:id="R72c9c9547ffa4959"/>
-    <p:sldId xmlns:r="http://schemas.openxmlformats.org/officeDocument/2006/relationships" id="268" r:id="R268228a686b84254"/>
-    <p:sldId xmlns:r="http://schemas.openxmlformats.org/officeDocument/2006/relationships" id="269" r:id="Rcd35af32d4b64e49"/>
+    <p:sldId xmlns:r="http://schemas.openxmlformats.org/officeDocument/2006/relationships" id="256" r:id="R6b9bcfe8ed9f4198"/>
+    <p:sldId xmlns:r="http://schemas.openxmlformats.org/officeDocument/2006/relationships" id="257" r:id="R6d73c6e6a71f434b"/>
+    <p:sldId xmlns:r="http://schemas.openxmlformats.org/officeDocument/2006/relationships" id="258" r:id="Rb85a1ef04f97420b"/>
+    <p:sldId xmlns:r="http://schemas.openxmlformats.org/officeDocument/2006/relationships" id="259" r:id="R5e5c988fe3454b88"/>
+    <p:sldId xmlns:r="http://schemas.openxmlformats.org/officeDocument/2006/relationships" id="260" r:id="R4ac866e75b824053"/>
+    <p:sldId xmlns:r="http://schemas.openxmlformats.org/officeDocument/2006/relationships" id="261" r:id="R5cc3bea3ff0c4a08"/>
+    <p:sldId xmlns:r="http://schemas.openxmlformats.org/officeDocument/2006/relationships" id="262" r:id="Rbfb1b700ff5d4a8c"/>
+    <p:sldId xmlns:r="http://schemas.openxmlformats.org/officeDocument/2006/relationships" id="263" r:id="R00a8153f18194ed0"/>
+    <p:sldId xmlns:r="http://schemas.openxmlformats.org/officeDocument/2006/relationships" id="264" r:id="R5e6a9b189c9c4b2f"/>
+    <p:sldId xmlns:r="http://schemas.openxmlformats.org/officeDocument/2006/relationships" id="265" r:id="R75faf32fc9094834"/>
+    <p:sldId xmlns:r="http://schemas.openxmlformats.org/officeDocument/2006/relationships" id="266" r:id="R697f7770760640eb"/>
+    <p:sldId xmlns:r="http://schemas.openxmlformats.org/officeDocument/2006/relationships" id="267" r:id="Rf13310b468a9467b"/>
+    <p:sldId xmlns:r="http://schemas.openxmlformats.org/officeDocument/2006/relationships" id="268" r:id="Rcd6c1636b84f403c"/>
+    <p:sldId xmlns:r="http://schemas.openxmlformats.org/officeDocument/2006/relationships" id="269" r:id="R4156cc30ff474c53"/>
   </p:sldIdLst>
   <p:sldSz cx="12192000" cy="6858000"/>
   <p:notesSz cx="6858000" cy="9144000"/>
@@ -455,7 +455,7 @@
           <a:lstStyle xmlns:a="http://schemas.openxmlformats.org/drawingml/2006/main"/>
           <a:p xmlns:a="http://schemas.openxmlformats.org/drawingml/2006/main">
             <a:r>
-              <a:t>Fuentes y alcance: https://github.com/hu-herrera/fin/blob/main/docs/entrega-profesor-fuentes/01_Informe_Diagnostico_Propuesta.md</a:t>
+              <a:t>Fuentes y alcance: https://github.com/hu-herrera/financiera-pacifico-entrega-docente/blob/main/01_Informe_Diagnostico_Propuesta.pdf</a:t>
             </a:r>
           </a:p>
         </p:txBody>
@@ -525,7 +525,12 @@
           <a:lstStyle xmlns:a="http://schemas.openxmlformats.org/drawingml/2006/main"/>
           <a:p xmlns:a="http://schemas.openxmlformats.org/drawingml/2006/main">
             <a:r>
-              <a:t>Fuentes y alcance: https://github.com/hu-herrera/fin/blob/main/docs/entrega-profesor-fuentes/Entregable-6.md. Commit de red 228ec2674d2b784b4cb67dab1128e969f681d3aa.</a:t>
+              <a:t>Fuentes y alcance: https://github.com/hu-herrera/financiera-pacifico-entrega-docente/blob/main/02_Entregables/Entregable_6.pdf. Commit de red 228ec2674d2b784b4cb67dab1128e969f681d3aa.</a:t>
+            </a:r>
+          </a:p>
+          <a:p xmlns:a="http://schemas.openxmlformats.org/drawingml/2006/main">
+            <a:r>
+              <a:t>Actualización del 25/10: https://github.com/hu-herrera/financiera-pacifico-entrega-docente/blob/main/Anexos/Cierre_25_oct_2026.md. Los resultados de 93 Node y 151 navegador tienen cortes y alcances separados. La admisión de video es política propuesta, sin control automático de una aplicación real.</a:t>
             </a:r>
           </a:p>
         </p:txBody>
@@ -595,7 +600,7 @@
           <a:lstStyle xmlns:a="http://schemas.openxmlformats.org/drawingml/2006/main"/>
           <a:p xmlns:a="http://schemas.openxmlformats.org/drawingml/2006/main">
             <a:r>
-              <a:t>Fuentes y alcance: https://github.com/hu-herrera/fin/blob/main/docs/entrega-profesor-fuentes/Entregable-7.md y Anexos/Presupuesto_Inventario.xlsx.</a:t>
+              <a:t>Fuentes y alcance: https://github.com/hu-herrera/financiera-pacifico-entrega-docente/blob/main/02_Entregables/Entregable_7.pdf y Anexos/Presupuesto_Inventario.xlsx.</a:t>
             </a:r>
           </a:p>
         </p:txBody>
@@ -665,7 +670,12 @@
           <a:lstStyle xmlns:a="http://schemas.openxmlformats.org/drawingml/2006/main"/>
           <a:p xmlns:a="http://schemas.openxmlformats.org/drawingml/2006/main">
             <a:r>
-              <a:t>Fuentes y alcance: https://github.com/hu-herrera/fin/blob/main/docs/entrega-profesor-fuentes/Entregable-3.md, https://github.com/hu-herrera/fin/blob/main/docs/entrega-profesor-fuentes/Entregable-7.md y solicitud de distribuidores de otra marca en ambas opciones.</a:t>
+              <a:t>Fuentes y alcance: https://github.com/hu-herrera/financiera-pacifico-entrega-docente/blob/main/02_Entregables/Entregable_3.pdf, https://github.com/hu-herrera/financiera-pacifico-entrega-docente/blob/main/02_Entregables/Entregable_7.pdf y solicitud de distribuidores de otra marca en ambas opciones.</a:t>
+            </a:r>
+          </a:p>
+          <a:p xmlns:a="http://schemas.openxmlformats.org/drawingml/2006/main">
+            <a:r>
+              <a:t>Actualización del 25/10: https://github.com/hu-herrera/financiera-pacifico-entrega-docente/blob/main/Anexos/Cierre_25_oct_2026.md. Los resultados de 93 Node y 151 navegador tienen cortes y alcances separados. La admisión de video es política propuesta, sin control automático de una aplicación real.</a:t>
             </a:r>
           </a:p>
         </p:txBody>
@@ -735,7 +745,7 @@
           <a:lstStyle xmlns:a="http://schemas.openxmlformats.org/drawingml/2006/main"/>
           <a:p xmlns:a="http://schemas.openxmlformats.org/drawingml/2006/main">
             <a:r>
-              <a:t>Fuentes y alcance: https://github.com/hu-herrera/fin/blob/main/docs/entrega-profesor-fuentes/Entregable-7.md</a:t>
+              <a:t>Fuentes y alcance: https://github.com/hu-herrera/financiera-pacifico-entrega-docente/blob/main/02_Entregables/Entregable_7.pdf</a:t>
             </a:r>
           </a:p>
         </p:txBody>
@@ -875,7 +885,7 @@
           <a:lstStyle xmlns:a="http://schemas.openxmlformats.org/drawingml/2006/main"/>
           <a:p xmlns:a="http://schemas.openxmlformats.org/drawingml/2006/main">
             <a:r>
-              <a:t>Fuentes y alcance: https://github.com/hu-herrera/fin/blob/main/docs/entrega-profesor-fuentes/Entregable-6.md y https://github.com/hu-herrera/fin/blob/main/docs/entrega-profesor-fuentes/03_Bitacora.md</a:t>
+              <a:t>Fuentes y alcance: https://github.com/hu-herrera/financiera-pacifico-entrega-docente/blob/main/02_Entregables/Entregable_6.pdf y https://github.com/hu-herrera/financiera-pacifico-entrega-docente/blob/main/03_Bitacora.pdf</a:t>
             </a:r>
           </a:p>
         </p:txBody>
@@ -945,7 +955,7 @@
           <a:lstStyle xmlns:a="http://schemas.openxmlformats.org/drawingml/2006/main"/>
           <a:p xmlns:a="http://schemas.openxmlformats.org/drawingml/2006/main">
             <a:r>
-              <a:t>Fuentes y alcance: https://github.com/hu-herrera/fin/blob/main/docs/entrega-profesor-fuentes/00_Caso_Oficial.md y https://github.com/hu-herrera/fin/blob/main/docs/entrega-profesor-fuentes/01_Informe_Diagnostico_Propuesta.md</a:t>
+              <a:t>Fuentes y alcance: https://github.com/hu-herrera/financiera-pacifico-entrega-docente/blob/main/00_Caso_Oficial.pdf y https://github.com/hu-herrera/financiera-pacifico-entrega-docente/blob/main/01_Informe_Diagnostico_Propuesta.pdf</a:t>
             </a:r>
           </a:p>
         </p:txBody>
@@ -1015,7 +1025,7 @@
           <a:lstStyle xmlns:a="http://schemas.openxmlformats.org/drawingml/2006/main"/>
           <a:p xmlns:a="http://schemas.openxmlformats.org/drawingml/2006/main">
             <a:r>
-              <a:t>Fuentes y alcance: https://github.com/hu-herrera/fin/blob/main/docs/entrega-profesor-fuentes/Entregable-1.md y https://github.com/hu-herrera/fin/blob/main/docs/entrega-profesor-fuentes/Entregable-3.md</a:t>
+              <a:t>Fuentes y alcance: https://github.com/hu-herrera/financiera-pacifico-entrega-docente/blob/main/02_Entregables/Entregable_1.pdf y https://github.com/hu-herrera/financiera-pacifico-entrega-docente/blob/main/02_Entregables/Entregable_3.pdf</a:t>
             </a:r>
           </a:p>
         </p:txBody>
@@ -1085,7 +1095,7 @@
           <a:lstStyle xmlns:a="http://schemas.openxmlformats.org/drawingml/2006/main"/>
           <a:p xmlns:a="http://schemas.openxmlformats.org/drawingml/2006/main">
             <a:r>
-              <a:t>Fuentes y alcance: https://github.com/hu-herrera/fin/blob/main/docs/entrega-profesor-fuentes/Entregable-3.md. Extracto del plano S06, alternativa B, Anexos/Topologias_ANTES_A_B.pdf.</a:t>
+              <a:t>Fuentes y alcance: https://github.com/hu-herrera/financiera-pacifico-entrega-docente/blob/main/02_Entregables/Entregable_3.pdf. Extracto del plano S06, alternativa B, Anexos/Topologias_ANTES_A_B.pdf.</a:t>
             </a:r>
           </a:p>
         </p:txBody>
@@ -1155,7 +1165,7 @@
           <a:lstStyle xmlns:a="http://schemas.openxmlformats.org/drawingml/2006/main"/>
           <a:p xmlns:a="http://schemas.openxmlformats.org/drawingml/2006/main">
             <a:r>
-              <a:t>Fuentes y alcance: https://github.com/hu-herrera/fin/blob/main/docs/entrega-profesor-fuentes/Entregable-2.md y https://github.com/hu-herrera/fin/blob/main/docs/entrega-profesor-fuentes/Entregable-7.md</a:t>
+              <a:t>Fuentes y alcance: https://github.com/hu-herrera/financiera-pacifico-entrega-docente/blob/main/02_Entregables/Entregable_2.pdf y https://github.com/hu-herrera/financiera-pacifico-entrega-docente/blob/main/02_Entregables/Entregable_7.pdf</a:t>
             </a:r>
           </a:p>
         </p:txBody>
@@ -1225,7 +1235,7 @@
           <a:lstStyle xmlns:a="http://schemas.openxmlformats.org/drawingml/2006/main"/>
           <a:p xmlns:a="http://schemas.openxmlformats.org/drawingml/2006/main">
             <a:r>
-              <a:t>Fuentes y alcance: https://github.com/hu-herrera/fin/blob/main/docs/entrega-profesor-fuentes/Entregable-4.md</a:t>
+              <a:t>Fuentes y alcance: https://github.com/hu-herrera/financiera-pacifico-entrega-docente/blob/main/02_Entregables/Entregable_4.pdf</a:t>
             </a:r>
           </a:p>
         </p:txBody>
@@ -1295,7 +1305,7 @@
           <a:lstStyle xmlns:a="http://schemas.openxmlformats.org/drawingml/2006/main"/>
           <a:p xmlns:a="http://schemas.openxmlformats.org/drawingml/2006/main">
             <a:r>
-              <a:t>Fuentes y alcance: https://github.com/hu-herrera/fin/blob/main/docs/entrega-profesor-fuentes/Entregable-3.md y https://github.com/hu-herrera/fin/blob/main/docs/entrega-profesor-fuentes/Entregable-4.md</a:t>
+              <a:t>Fuentes y alcance: https://github.com/hu-herrera/financiera-pacifico-entrega-docente/blob/main/02_Entregables/Entregable_3.pdf y https://github.com/hu-herrera/financiera-pacifico-entrega-docente/blob/main/02_Entregables/Entregable_4.pdf</a:t>
             </a:r>
           </a:p>
         </p:txBody>
@@ -1365,7 +1375,7 @@
           <a:lstStyle xmlns:a="http://schemas.openxmlformats.org/drawingml/2006/main"/>
           <a:p xmlns:a="http://schemas.openxmlformats.org/drawingml/2006/main">
             <a:r>
-              <a:t>Fuentes y alcance: https://github.com/hu-herrera/fin/blob/main/docs/entrega-profesor-fuentes/Entregable-5.md y https://github.com/hu-herrera/fin/blob/main/docs/entrega-profesor-fuentes/Entregable-6.md</a:t>
+              <a:t>Fuentes y alcance: https://github.com/hu-herrera/financiera-pacifico-entrega-docente/blob/main/02_Entregables/Entregable_5.pdf y https://github.com/hu-herrera/financiera-pacifico-entrega-docente/blob/main/02_Entregables/Entregable_6.pdf</a:t>
             </a:r>
           </a:p>
         </p:txBody>
@@ -3808,12 +3818,12 @@
   </p:cSld>
   <p:clrMap bg1="lt1" tx1="dk1" bg2="lt2" tx2="dk2" accent1="accent1" accent2="accent2" accent3="accent3" accent4="accent4" accent5="accent5" accent6="accent6" hlink="hlink" folHlink="folHlink"/>
   <p:sldLayoutIdLst>
-    <p:sldLayoutId xmlns:r="http://schemas.openxmlformats.org/officeDocument/2006/relationships" id="2147483649" r:id="R8c9c75c0fa814769"/>
-    <p:sldLayoutId xmlns:r="http://schemas.openxmlformats.org/officeDocument/2006/relationships" id="2147483650" r:id="Re54f8c1ea9db4c01"/>
-    <p:sldLayoutId xmlns:r="http://schemas.openxmlformats.org/officeDocument/2006/relationships" id="2147483651" r:id="Rfaa6b279bd0649df"/>
-    <p:sldLayoutId xmlns:r="http://schemas.openxmlformats.org/officeDocument/2006/relationships" id="2147483652" r:id="R3ee270e1cac34c50"/>
-    <p:sldLayoutId xmlns:r="http://schemas.openxmlformats.org/officeDocument/2006/relationships" id="2147483653" r:id="R8c5ddb07b9514e1e"/>
-    <p:sldLayoutId xmlns:r="http://schemas.openxmlformats.org/officeDocument/2006/relationships" id="2147483654" r:id="R2bc3785d87234d5d"/>
+    <p:sldLayoutId xmlns:r="http://schemas.openxmlformats.org/officeDocument/2006/relationships" id="2147483649" r:id="R95ea0e5c5e25448f"/>
+    <p:sldLayoutId xmlns:r="http://schemas.openxmlformats.org/officeDocument/2006/relationships" id="2147483650" r:id="Re13105d7362f4e78"/>
+    <p:sldLayoutId xmlns:r="http://schemas.openxmlformats.org/officeDocument/2006/relationships" id="2147483651" r:id="Rb70f73a2f9014486"/>
+    <p:sldLayoutId xmlns:r="http://schemas.openxmlformats.org/officeDocument/2006/relationships" id="2147483652" r:id="R0e004ae721bf4537"/>
+    <p:sldLayoutId xmlns:r="http://schemas.openxmlformats.org/officeDocument/2006/relationships" id="2147483653" r:id="R9376881f133140ff"/>
+    <p:sldLayoutId xmlns:r="http://schemas.openxmlformats.org/officeDocument/2006/relationships" id="2147483654" r:id="Rd581e3a0471c4549"/>
   </p:sldLayoutIdLst>
   <p:txStyles>
     <p:titleStyle>
@@ -7198,7 +7208,7 @@
           <p:cNvPr id="3" name="">
             <a:extLst xmlns:a="http://schemas.openxmlformats.org/drawingml/2006/main">
               <a:ext uri="{FF2B5EF4-FFF2-40B4-BE49-F238E27FC236}">
-                <a16:creationId xmlns:a16="http://schemas.microsoft.com/office/drawing/2014/main" id="{F46F360E-4600-4DFD-B1E4-7A5AD475DEF6}"/>
+                <a16:creationId xmlns:a16="http://schemas.microsoft.com/office/drawing/2014/main" id="{C1419A5E-A742-4158-AE22-0BDCBE0625C9}"/>
               </a:ext>
             </a:extLst>
           </p:cNvPr>
@@ -9911,7 +9921,7 @@
           <p:cNvPr id="3" name="">
             <a:extLst xmlns:a="http://schemas.openxmlformats.org/drawingml/2006/main">
               <a:ext uri="{FF2B5EF4-FFF2-40B4-BE49-F238E27FC236}">
-                <a16:creationId xmlns:a16="http://schemas.microsoft.com/office/drawing/2014/main" id="{EA0E5162-0247-4ACF-9595-18D42FA79D3C}"/>
+                <a16:creationId xmlns:a16="http://schemas.microsoft.com/office/drawing/2014/main" id="{8428CC72-24AC-4035-9212-323D33020BDB}"/>
               </a:ext>
             </a:extLst>
           </p:cNvPr>
@@ -10807,7 +10817,7 @@
           <p:cNvPr id="3" name="">
             <a:extLst xmlns:a="http://schemas.openxmlformats.org/drawingml/2006/main">
               <a:ext uri="{FF2B5EF4-FFF2-40B4-BE49-F238E27FC236}">
-                <a16:creationId xmlns:a16="http://schemas.microsoft.com/office/drawing/2014/main" id="{0D36082B-F320-4230-9C2E-B5A9ED483774}"/>
+                <a16:creationId xmlns:a16="http://schemas.microsoft.com/office/drawing/2014/main" id="{0AAE8C88-E4A8-412A-A030-6F516A80497D}"/>
               </a:ext>
             </a:extLst>
           </p:cNvPr>
@@ -14630,7 +14640,7 @@
           <p:cNvPr id="3" name="">
             <a:extLst xmlns:a="http://schemas.openxmlformats.org/drawingml/2006/main">
               <a:ext uri="{FF2B5EF4-FFF2-40B4-BE49-F238E27FC236}">
-                <a16:creationId xmlns:a16="http://schemas.microsoft.com/office/drawing/2014/main" id="{0FC5E5EB-57C5-4CA5-8A6F-DC73F0627014}"/>
+                <a16:creationId xmlns:a16="http://schemas.microsoft.com/office/drawing/2014/main" id="{4741B710-BECF-4BD7-BA09-5B203699E257}"/>
               </a:ext>
             </a:extLst>
           </p:cNvPr>
@@ -15526,7 +15536,7 @@
           <p:cNvPr id="3" name="">
             <a:extLst xmlns:a="http://schemas.openxmlformats.org/drawingml/2006/main">
               <a:ext uri="{FF2B5EF4-FFF2-40B4-BE49-F238E27FC236}">
-                <a16:creationId xmlns:a16="http://schemas.microsoft.com/office/drawing/2014/main" id="{44D5990C-D816-46BD-98C1-E0F1D006D72E}"/>
+                <a16:creationId xmlns:a16="http://schemas.microsoft.com/office/drawing/2014/main" id="{BDAD1A1A-70C3-4870-A9F9-9F6AB225D683}"/>
               </a:ext>
             </a:extLst>
           </p:cNvPr>
@@ -15536,7 +15546,7 @@
           <p:nvPr/>
         </p:nvPicPr>
         <p:blipFill>
-          <a:blip xmlns:r="http://schemas.openxmlformats.org/officeDocument/2006/relationships" xmlns:a="http://schemas.openxmlformats.org/drawingml/2006/main" r:embed="Rb644e37ffee04c07"/>
+          <a:blip xmlns:r="http://schemas.openxmlformats.org/officeDocument/2006/relationships" xmlns:a="http://schemas.openxmlformats.org/drawingml/2006/main" r:embed="R6ef150b843ae4dc0"/>
           <a:stretch xmlns:a="http://schemas.openxmlformats.org/drawingml/2006/main"/>
         </p:blipFill>
         <p:spPr>
@@ -16259,7 +16269,7 @@
           <p:cNvPr id="3" name="">
             <a:extLst xmlns:a="http://schemas.openxmlformats.org/drawingml/2006/main">
               <a:ext uri="{FF2B5EF4-FFF2-40B4-BE49-F238E27FC236}">
-                <a16:creationId xmlns:a16="http://schemas.microsoft.com/office/drawing/2014/main" id="{41027567-6C69-49E5-9F15-F71E90F03BCC}"/>
+                <a16:creationId xmlns:a16="http://schemas.microsoft.com/office/drawing/2014/main" id="{9F325825-EBFF-43D6-8FC1-53439A445821}"/>
               </a:ext>
             </a:extLst>
           </p:cNvPr>
@@ -17448,7 +17458,7 @@
           <p:cNvPr id="3" name="">
             <a:extLst xmlns:a="http://schemas.openxmlformats.org/drawingml/2006/main">
               <a:ext uri="{FF2B5EF4-FFF2-40B4-BE49-F238E27FC236}">
-                <a16:creationId xmlns:a16="http://schemas.microsoft.com/office/drawing/2014/main" id="{3E31069A-2BC1-43B1-BC7F-C0D021ACD509}"/>
+                <a16:creationId xmlns:a16="http://schemas.microsoft.com/office/drawing/2014/main" id="{B09C9EE7-C46A-431C-8351-1A0DB313404D}"/>
               </a:ext>
             </a:extLst>
           </p:cNvPr>
@@ -20076,7 +20086,7 @@
           <p:cNvPr id="3" name="">
             <a:extLst xmlns:a="http://schemas.openxmlformats.org/drawingml/2006/main">
               <a:ext uri="{FF2B5EF4-FFF2-40B4-BE49-F238E27FC236}">
-                <a16:creationId xmlns:a16="http://schemas.microsoft.com/office/drawing/2014/main" id="{F0D9DCE3-B152-43E9-8732-9B7832B12BC9}"/>
+                <a16:creationId xmlns:a16="http://schemas.microsoft.com/office/drawing/2014/main" id="{E6E8DA35-D29F-4DC9-8150-101E24936C6C}"/>
               </a:ext>
             </a:extLst>
           </p:cNvPr>
@@ -20674,7 +20684,7 @@
                 <a:latin typeface="DejaVu Sans"/>
                 <a:ea typeface="DejaVu Sans"/>
                 <a:cs typeface="DejaVu Sans"/>
-                <a:hlinkClick xmlns:r="http://schemas.openxmlformats.org/officeDocument/2006/relationships" r:id="Rb40bdec3a1244a95"/>
+                <a:hlinkClick xmlns:r="http://schemas.openxmlformats.org/officeDocument/2006/relationships" r:id="R082913b5666544ec"/>
               </a:rPr>
               <a:t>Abrir simulador</a:t>
             </a:r>

</xml_diff>

<commit_message>
Completar cuatro accesos WAN en todas las sedes, incluida Casa Matriz
E6 conserva conectividad móvil y la presentación muestra respaldos sucesivos hasta WOM. WAN-3 concilia interfaces, túneles, inventario y presupuesto. Validación: 99 pruebas Node, 44 de navegador y 9.900 combinaciones del modelo.
</commit_message>
<xml_diff>
--- a/Presentacion/Avance_Financiera_Pacifico_30_oct_2026.pptx
+++ b/Presentacion/Avance_Financiera_Pacifico_30_oct_2026.pptx
@@ -2,26 +2,26 @@
 <file path=ppt/presentation.xml><?xml version="1.0" encoding="utf-8"?>
 <p:presentation xmlns:p="http://schemas.openxmlformats.org/presentationml/2006/main">
   <p:sldMasterIdLst>
-    <p:sldMasterId xmlns:r="http://schemas.openxmlformats.org/officeDocument/2006/relationships" id="2147483648" r:id="R2426cf42b274414d"/>
+    <p:sldMasterId xmlns:r="http://schemas.openxmlformats.org/officeDocument/2006/relationships" id="2147483648" r:id="R2891c5164fd449a0"/>
   </p:sldMasterIdLst>
   <p:notesMasterIdLst>
-    <p:notesMasterId xmlns:r="http://schemas.openxmlformats.org/officeDocument/2006/relationships" r:id="R0099701976364e86"/>
+    <p:notesMasterId xmlns:r="http://schemas.openxmlformats.org/officeDocument/2006/relationships" r:id="R6e919be1fee64b82"/>
   </p:notesMasterIdLst>
   <p:sldIdLst>
-    <p:sldId xmlns:r="http://schemas.openxmlformats.org/officeDocument/2006/relationships" id="256" r:id="R6b9bcfe8ed9f4198"/>
-    <p:sldId xmlns:r="http://schemas.openxmlformats.org/officeDocument/2006/relationships" id="257" r:id="R6d73c6e6a71f434b"/>
-    <p:sldId xmlns:r="http://schemas.openxmlformats.org/officeDocument/2006/relationships" id="258" r:id="Rb85a1ef04f97420b"/>
-    <p:sldId xmlns:r="http://schemas.openxmlformats.org/officeDocument/2006/relationships" id="259" r:id="R5e5c988fe3454b88"/>
-    <p:sldId xmlns:r="http://schemas.openxmlformats.org/officeDocument/2006/relationships" id="260" r:id="R4ac866e75b824053"/>
-    <p:sldId xmlns:r="http://schemas.openxmlformats.org/officeDocument/2006/relationships" id="261" r:id="R5cc3bea3ff0c4a08"/>
-    <p:sldId xmlns:r="http://schemas.openxmlformats.org/officeDocument/2006/relationships" id="262" r:id="Rbfb1b700ff5d4a8c"/>
-    <p:sldId xmlns:r="http://schemas.openxmlformats.org/officeDocument/2006/relationships" id="263" r:id="R00a8153f18194ed0"/>
-    <p:sldId xmlns:r="http://schemas.openxmlformats.org/officeDocument/2006/relationships" id="264" r:id="R5e6a9b189c9c4b2f"/>
-    <p:sldId xmlns:r="http://schemas.openxmlformats.org/officeDocument/2006/relationships" id="265" r:id="R75faf32fc9094834"/>
-    <p:sldId xmlns:r="http://schemas.openxmlformats.org/officeDocument/2006/relationships" id="266" r:id="R697f7770760640eb"/>
-    <p:sldId xmlns:r="http://schemas.openxmlformats.org/officeDocument/2006/relationships" id="267" r:id="Rf13310b468a9467b"/>
-    <p:sldId xmlns:r="http://schemas.openxmlformats.org/officeDocument/2006/relationships" id="268" r:id="Rcd6c1636b84f403c"/>
-    <p:sldId xmlns:r="http://schemas.openxmlformats.org/officeDocument/2006/relationships" id="269" r:id="R4156cc30ff474c53"/>
+    <p:sldId xmlns:r="http://schemas.openxmlformats.org/officeDocument/2006/relationships" id="256" r:id="R7dd5a2e4a4434026"/>
+    <p:sldId xmlns:r="http://schemas.openxmlformats.org/officeDocument/2006/relationships" id="257" r:id="R5b564ddf205c4ee5"/>
+    <p:sldId xmlns:r="http://schemas.openxmlformats.org/officeDocument/2006/relationships" id="258" r:id="Rfa2a1cfb49f94742"/>
+    <p:sldId xmlns:r="http://schemas.openxmlformats.org/officeDocument/2006/relationships" id="259" r:id="R7a1b4ad4db9e4bcb"/>
+    <p:sldId xmlns:r="http://schemas.openxmlformats.org/officeDocument/2006/relationships" id="260" r:id="R9b37edb6cfb24f71"/>
+    <p:sldId xmlns:r="http://schemas.openxmlformats.org/officeDocument/2006/relationships" id="261" r:id="R66cf02a52bd744a3"/>
+    <p:sldId xmlns:r="http://schemas.openxmlformats.org/officeDocument/2006/relationships" id="262" r:id="R0ade0ea8c03f4a01"/>
+    <p:sldId xmlns:r="http://schemas.openxmlformats.org/officeDocument/2006/relationships" id="263" r:id="Rc5806a58639241f2"/>
+    <p:sldId xmlns:r="http://schemas.openxmlformats.org/officeDocument/2006/relationships" id="264" r:id="R0c6c1d96a5f746ac"/>
+    <p:sldId xmlns:r="http://schemas.openxmlformats.org/officeDocument/2006/relationships" id="265" r:id="Rd7a5d9c5be4f4128"/>
+    <p:sldId xmlns:r="http://schemas.openxmlformats.org/officeDocument/2006/relationships" id="266" r:id="Rd70ef328d5484118"/>
+    <p:sldId xmlns:r="http://schemas.openxmlformats.org/officeDocument/2006/relationships" id="267" r:id="R6d387f63cbf44361"/>
+    <p:sldId xmlns:r="http://schemas.openxmlformats.org/officeDocument/2006/relationships" id="268" r:id="R0ccd83569c444ed9"/>
+    <p:sldId xmlns:r="http://schemas.openxmlformats.org/officeDocument/2006/relationships" id="269" r:id="R8606a73d627e4a56"/>
   </p:sldIdLst>
   <p:sldSz cx="12192000" cy="6858000"/>
   <p:notesSz cx="6858000" cy="9144000"/>
@@ -458,6 +458,11 @@
               <a:t>Fuentes y alcance: https://github.com/hu-herrera/financiera-pacifico-entrega-docente/blob/main/01_Informe_Diagnostico_Propuesta.pdf</a:t>
             </a:r>
           </a:p>
+          <a:p xmlns:a="http://schemas.openxmlformats.org/drawingml/2006/main">
+            <a:r>
+              <a:t>Revisión WAN-3: cuatro transportes en central y sucursales. Fuente: https://github.com/hu-herrera/financiera-pacifico-entrega-docente/blob/main/Anexos/Continuidad_Cuatro_WAN_25_oct_2026.md</a:t>
+            </a:r>
+          </a:p>
         </p:txBody>
       </p:sp>
       <p:sp>
@@ -533,6 +538,11 @@
               <a:t>Actualización del 25/10: https://github.com/hu-herrera/financiera-pacifico-entrega-docente/blob/main/Anexos/Cierre_25_oct_2026.md. Los resultados de 93 Node y 151 navegador tienen cortes y alcances separados. La admisión de video es política propuesta, sin control automático de una aplicación real.</a:t>
             </a:r>
           </a:p>
+          <a:p xmlns:a="http://schemas.openxmlformats.org/drawingml/2006/main">
+            <a:r>
+              <a:t>Revisión WAN-3: cuatro transportes en central y sucursales. Fuente: https://github.com/hu-herrera/financiera-pacifico-entrega-docente/blob/main/Anexos/Continuidad_Cuatro_WAN_25_oct_2026.md</a:t>
+            </a:r>
+          </a:p>
         </p:txBody>
       </p:sp>
       <p:sp>
@@ -601,6 +611,11 @@
           <a:p xmlns:a="http://schemas.openxmlformats.org/drawingml/2006/main">
             <a:r>
               <a:t>Fuentes y alcance: https://github.com/hu-herrera/financiera-pacifico-entrega-docente/blob/main/02_Entregables/Entregable_7.pdf y Anexos/Presupuesto_Inventario.xlsx.</a:t>
+            </a:r>
+          </a:p>
+          <a:p xmlns:a="http://schemas.openxmlformats.org/drawingml/2006/main">
+            <a:r>
+              <a:t>Revisión WAN-3: cuatro transportes en central y sucursales. Fuente: https://github.com/hu-herrera/financiera-pacifico-entrega-docente/blob/main/Anexos/Continuidad_Cuatro_WAN_25_oct_2026.md</a:t>
             </a:r>
           </a:p>
         </p:txBody>
@@ -678,6 +693,11 @@
               <a:t>Actualización del 25/10: https://github.com/hu-herrera/financiera-pacifico-entrega-docente/blob/main/Anexos/Cierre_25_oct_2026.md. Los resultados de 93 Node y 151 navegador tienen cortes y alcances separados. La admisión de video es política propuesta, sin control automático de una aplicación real.</a:t>
             </a:r>
           </a:p>
+          <a:p xmlns:a="http://schemas.openxmlformats.org/drawingml/2006/main">
+            <a:r>
+              <a:t>Revisión WAN-3: cuatro transportes en central y sucursales. Fuente: https://github.com/hu-herrera/financiera-pacifico-entrega-docente/blob/main/Anexos/Continuidad_Cuatro_WAN_25_oct_2026.md</a:t>
+            </a:r>
+          </a:p>
         </p:txBody>
       </p:sp>
       <p:sp>
@@ -746,6 +766,11 @@
           <a:p xmlns:a="http://schemas.openxmlformats.org/drawingml/2006/main">
             <a:r>
               <a:t>Fuentes y alcance: https://github.com/hu-herrera/financiera-pacifico-entrega-docente/blob/main/02_Entregables/Entregable_7.pdf</a:t>
+            </a:r>
+          </a:p>
+          <a:p xmlns:a="http://schemas.openxmlformats.org/drawingml/2006/main">
+            <a:r>
+              <a:t>Revisión WAN-3: cuatro transportes en central y sucursales. Fuente: https://github.com/hu-herrera/financiera-pacifico-entrega-docente/blob/main/Anexos/Continuidad_Cuatro_WAN_25_oct_2026.md</a:t>
             </a:r>
           </a:p>
         </p:txBody>
@@ -818,6 +843,11 @@
               <a:t>Fuentes y alcance: Aviso docente recibido el 23/10/2026: video y PPT por AVA, plazo viernes 30/10/2026. Fechas intermedias propuestas para organizar el trabajo.</a:t>
             </a:r>
           </a:p>
+          <a:p xmlns:a="http://schemas.openxmlformats.org/drawingml/2006/main">
+            <a:r>
+              <a:t>Revisión WAN-3: cuatro transportes en central y sucursales. Fuente: https://github.com/hu-herrera/financiera-pacifico-entrega-docente/blob/main/Anexos/Continuidad_Cuatro_WAN_25_oct_2026.md</a:t>
+            </a:r>
+          </a:p>
         </p:txBody>
       </p:sp>
       <p:sp>
@@ -886,6 +916,11 @@
           <a:p xmlns:a="http://schemas.openxmlformats.org/drawingml/2006/main">
             <a:r>
               <a:t>Fuentes y alcance: https://github.com/hu-herrera/financiera-pacifico-entrega-docente/blob/main/02_Entregables/Entregable_6.pdf y https://github.com/hu-herrera/financiera-pacifico-entrega-docente/blob/main/03_Bitacora.pdf</a:t>
+            </a:r>
+          </a:p>
+          <a:p xmlns:a="http://schemas.openxmlformats.org/drawingml/2006/main">
+            <a:r>
+              <a:t>Revisión WAN-3: cuatro transportes en central y sucursales. Fuente: https://github.com/hu-herrera/financiera-pacifico-entrega-docente/blob/main/Anexos/Continuidad_Cuatro_WAN_25_oct_2026.md</a:t>
             </a:r>
           </a:p>
         </p:txBody>
@@ -958,6 +993,11 @@
               <a:t>Fuentes y alcance: https://github.com/hu-herrera/financiera-pacifico-entrega-docente/blob/main/00_Caso_Oficial.pdf y https://github.com/hu-herrera/financiera-pacifico-entrega-docente/blob/main/01_Informe_Diagnostico_Propuesta.pdf</a:t>
             </a:r>
           </a:p>
+          <a:p xmlns:a="http://schemas.openxmlformats.org/drawingml/2006/main">
+            <a:r>
+              <a:t>Revisión WAN-3: cuatro transportes en central y sucursales. Fuente: https://github.com/hu-herrera/financiera-pacifico-entrega-docente/blob/main/Anexos/Continuidad_Cuatro_WAN_25_oct_2026.md</a:t>
+            </a:r>
+          </a:p>
         </p:txBody>
       </p:sp>
       <p:sp>
@@ -1026,6 +1066,11 @@
           <a:p xmlns:a="http://schemas.openxmlformats.org/drawingml/2006/main">
             <a:r>
               <a:t>Fuentes y alcance: https://github.com/hu-herrera/financiera-pacifico-entrega-docente/blob/main/02_Entregables/Entregable_1.pdf y https://github.com/hu-herrera/financiera-pacifico-entrega-docente/blob/main/02_Entregables/Entregable_3.pdf</a:t>
+            </a:r>
+          </a:p>
+          <a:p xmlns:a="http://schemas.openxmlformats.org/drawingml/2006/main">
+            <a:r>
+              <a:t>Revisión WAN-3: cuatro transportes en central y sucursales. Fuente: https://github.com/hu-herrera/financiera-pacifico-entrega-docente/blob/main/Anexos/Continuidad_Cuatro_WAN_25_oct_2026.md</a:t>
             </a:r>
           </a:p>
         </p:txBody>
@@ -1098,6 +1143,11 @@
               <a:t>Fuentes y alcance: https://github.com/hu-herrera/financiera-pacifico-entrega-docente/blob/main/02_Entregables/Entregable_3.pdf. Extracto del plano S06, alternativa B, Anexos/Topologias_ANTES_A_B.pdf.</a:t>
             </a:r>
           </a:p>
+          <a:p xmlns:a="http://schemas.openxmlformats.org/drawingml/2006/main">
+            <a:r>
+              <a:t>Revisión WAN-3: cuatro transportes en central y sucursales. Fuente: https://github.com/hu-herrera/financiera-pacifico-entrega-docente/blob/main/Anexos/Continuidad_Cuatro_WAN_25_oct_2026.md</a:t>
+            </a:r>
+          </a:p>
         </p:txBody>
       </p:sp>
       <p:sp>
@@ -1166,6 +1216,11 @@
           <a:p xmlns:a="http://schemas.openxmlformats.org/drawingml/2006/main">
             <a:r>
               <a:t>Fuentes y alcance: https://github.com/hu-herrera/financiera-pacifico-entrega-docente/blob/main/02_Entregables/Entregable_2.pdf y https://github.com/hu-herrera/financiera-pacifico-entrega-docente/blob/main/02_Entregables/Entregable_7.pdf</a:t>
+            </a:r>
+          </a:p>
+          <a:p xmlns:a="http://schemas.openxmlformats.org/drawingml/2006/main">
+            <a:r>
+              <a:t>Revisión WAN-3: cuatro transportes en central y sucursales. Fuente: https://github.com/hu-herrera/financiera-pacifico-entrega-docente/blob/main/Anexos/Continuidad_Cuatro_WAN_25_oct_2026.md</a:t>
             </a:r>
           </a:p>
         </p:txBody>
@@ -1238,6 +1293,11 @@
               <a:t>Fuentes y alcance: https://github.com/hu-herrera/financiera-pacifico-entrega-docente/blob/main/02_Entregables/Entregable_4.pdf</a:t>
             </a:r>
           </a:p>
+          <a:p xmlns:a="http://schemas.openxmlformats.org/drawingml/2006/main">
+            <a:r>
+              <a:t>Revisión WAN-3: cuatro transportes en central y sucursales. Fuente: https://github.com/hu-herrera/financiera-pacifico-entrega-docente/blob/main/Anexos/Continuidad_Cuatro_WAN_25_oct_2026.md</a:t>
+            </a:r>
+          </a:p>
         </p:txBody>
       </p:sp>
       <p:sp>
@@ -1308,6 +1368,11 @@
               <a:t>Fuentes y alcance: https://github.com/hu-herrera/financiera-pacifico-entrega-docente/blob/main/02_Entregables/Entregable_3.pdf y https://github.com/hu-herrera/financiera-pacifico-entrega-docente/blob/main/02_Entregables/Entregable_4.pdf</a:t>
             </a:r>
           </a:p>
+          <a:p xmlns:a="http://schemas.openxmlformats.org/drawingml/2006/main">
+            <a:r>
+              <a:t>Revisión WAN-3: cuatro transportes en central y sucursales. Fuente: https://github.com/hu-herrera/financiera-pacifico-entrega-docente/blob/main/Anexos/Continuidad_Cuatro_WAN_25_oct_2026.md</a:t>
+            </a:r>
+          </a:p>
         </p:txBody>
       </p:sp>
       <p:sp>
@@ -1376,6 +1441,11 @@
           <a:p xmlns:a="http://schemas.openxmlformats.org/drawingml/2006/main">
             <a:r>
               <a:t>Fuentes y alcance: https://github.com/hu-herrera/financiera-pacifico-entrega-docente/blob/main/02_Entregables/Entregable_5.pdf y https://github.com/hu-herrera/financiera-pacifico-entrega-docente/blob/main/02_Entregables/Entregable_6.pdf</a:t>
+            </a:r>
+          </a:p>
+          <a:p xmlns:a="http://schemas.openxmlformats.org/drawingml/2006/main">
+            <a:r>
+              <a:t>Revisión WAN-3: cuatro transportes en central y sucursales. Fuente: https://github.com/hu-herrera/financiera-pacifico-entrega-docente/blob/main/Anexos/Continuidad_Cuatro_WAN_25_oct_2026.md</a:t>
             </a:r>
           </a:p>
         </p:txBody>
@@ -3818,12 +3888,12 @@
   </p:cSld>
   <p:clrMap bg1="lt1" tx1="dk1" bg2="lt2" tx2="dk2" accent1="accent1" accent2="accent2" accent3="accent3" accent4="accent4" accent5="accent5" accent6="accent6" hlink="hlink" folHlink="folHlink"/>
   <p:sldLayoutIdLst>
-    <p:sldLayoutId xmlns:r="http://schemas.openxmlformats.org/officeDocument/2006/relationships" id="2147483649" r:id="R95ea0e5c5e25448f"/>
-    <p:sldLayoutId xmlns:r="http://schemas.openxmlformats.org/officeDocument/2006/relationships" id="2147483650" r:id="Re13105d7362f4e78"/>
-    <p:sldLayoutId xmlns:r="http://schemas.openxmlformats.org/officeDocument/2006/relationships" id="2147483651" r:id="Rb70f73a2f9014486"/>
-    <p:sldLayoutId xmlns:r="http://schemas.openxmlformats.org/officeDocument/2006/relationships" id="2147483652" r:id="R0e004ae721bf4537"/>
-    <p:sldLayoutId xmlns:r="http://schemas.openxmlformats.org/officeDocument/2006/relationships" id="2147483653" r:id="R9376881f133140ff"/>
-    <p:sldLayoutId xmlns:r="http://schemas.openxmlformats.org/officeDocument/2006/relationships" id="2147483654" r:id="Rd581e3a0471c4549"/>
+    <p:sldLayoutId xmlns:r="http://schemas.openxmlformats.org/officeDocument/2006/relationships" id="2147483649" r:id="R425b135a31f44906"/>
+    <p:sldLayoutId xmlns:r="http://schemas.openxmlformats.org/officeDocument/2006/relationships" id="2147483650" r:id="Rfe0936ba58554621"/>
+    <p:sldLayoutId xmlns:r="http://schemas.openxmlformats.org/officeDocument/2006/relationships" id="2147483651" r:id="Rd565e80b8ff6449d"/>
+    <p:sldLayoutId xmlns:r="http://schemas.openxmlformats.org/officeDocument/2006/relationships" id="2147483652" r:id="Rb2f942bbaeb6492a"/>
+    <p:sldLayoutId xmlns:r="http://schemas.openxmlformats.org/officeDocument/2006/relationships" id="2147483653" r:id="Rec3727f1fbef44b7"/>
+    <p:sldLayoutId xmlns:r="http://schemas.openxmlformats.org/officeDocument/2006/relationships" id="2147483654" r:id="R0bb65f2a5880480d"/>
   </p:sldLayoutIdLst>
   <p:txStyles>
     <p:titleStyle>
@@ -5793,7 +5863,7 @@
                 <a:ea typeface="DejaVu Sans"/>
                 <a:cs typeface="DejaVu Sans"/>
               </a:rPr>
-              <a:t>93</a:t>
+              <a:t>99</a:t>
             </a:r>
           </a:p>
         </p:txBody>
@@ -6131,7 +6201,7 @@
                 <a:ea typeface="DejaVu Sans"/>
                 <a:cs typeface="DejaVu Sans"/>
               </a:rPr>
-              <a:t>151</a:t>
+              <a:t>44</a:t>
             </a:r>
           </a:p>
         </p:txBody>
@@ -6300,7 +6370,7 @@
                 <a:ea typeface="DejaVu Sans"/>
                 <a:cs typeface="DejaVu Sans"/>
               </a:rPr>
-              <a:t>pruebas de navegador en la pasada general</a:t>
+              <a:t>pruebas de navegador en esta revisión</a:t>
             </a:r>
           </a:p>
         </p:txBody>
@@ -7208,7 +7278,7 @@
           <p:cNvPr id="3" name="">
             <a:extLst xmlns:a="http://schemas.openxmlformats.org/drawingml/2006/main">
               <a:ext uri="{FF2B5EF4-FFF2-40B4-BE49-F238E27FC236}">
-                <a16:creationId xmlns:a16="http://schemas.microsoft.com/office/drawing/2014/main" id="{C1419A5E-A742-4158-AE22-0BDCBE0625C9}"/>
+                <a16:creationId xmlns:a16="http://schemas.microsoft.com/office/drawing/2014/main" id="{DFDCAC1B-6449-4D53-B254-B60816088A6D}"/>
               </a:ext>
             </a:extLst>
           </p:cNvPr>
@@ -7419,7 +7489,7 @@
                           <a:ea typeface="DejaVu Sans"/>
                           <a:cs typeface="DejaVu Sans"/>
                         </a:rPr>
-                        <a:t>792.550.011</a:t>
+                        <a:t>793.126.897</a:t>
                       </a:r>
                     </a:p>
                   </a:txBody>
@@ -7455,7 +7525,7 @@
                           <a:ea typeface="DejaVu Sans"/>
                           <a:cs typeface="DejaVu Sans"/>
                         </a:rPr>
-                        <a:t>280.617.592</a:t>
+                        <a:t>281.194.478</a:t>
                       </a:r>
                     </a:p>
                   </a:txBody>
@@ -7535,7 +7605,7 @@
                           <a:ea typeface="DejaVu Sans"/>
                           <a:cs typeface="DejaVu Sans"/>
                         </a:rPr>
-                        <a:t>658.885.320</a:t>
+                        <a:t>660.607.380</a:t>
                       </a:r>
                     </a:p>
                   </a:txBody>
@@ -7571,7 +7641,7 @@
                           <a:ea typeface="DejaVu Sans"/>
                           <a:cs typeface="DejaVu Sans"/>
                         </a:rPr>
-                        <a:t>658.885.320</a:t>
+                        <a:t>660.607.380</a:t>
                       </a:r>
                     </a:p>
                   </a:txBody>
@@ -7767,7 +7837,7 @@
                           <a:ea typeface="DejaVu Sans"/>
                           <a:cs typeface="DejaVu Sans"/>
                         </a:rPr>
-                        <a:t>1.501.435.331</a:t>
+                        <a:t>1.503.734.277</a:t>
                       </a:r>
                     </a:p>
                   </a:txBody>
@@ -7803,7 +7873,7 @@
                           <a:ea typeface="DejaVu Sans"/>
                           <a:cs typeface="DejaVu Sans"/>
                         </a:rPr>
-                        <a:t>964.502.912</a:t>
+                        <a:t>966.801.858</a:t>
                       </a:r>
                     </a:p>
                   </a:txBody>
@@ -8163,7 +8233,29 @@
                 <a:ea typeface="DejaVu Sans"/>
                 <a:cs typeface="DejaVu Sans"/>
               </a:rPr>
-              <a:t>Incluye el inicial una vez. WAN común: CLP 10.981.422/mes. Valores referenciales, no contratos ni compras ejecutadas.</a:t>
+              <a:t>Incluye el inicial una vez. WAN común: CLP </a:t>
+            </a:r>
+            <a:r>
+              <a:rPr sz="1350" b="0">
+                <a:solidFill>
+                  <a:srgbClr val="476071"/>
+                </a:solidFill>
+                <a:latin typeface="DejaVu Sans"/>
+                <a:ea typeface="DejaVu Sans"/>
+                <a:cs typeface="DejaVu Sans"/>
+              </a:rPr>
+              <a:t>11.010.123</a:t>
+            </a:r>
+            <a:r>
+              <a:rPr sz="1350" b="0">
+                <a:solidFill>
+                  <a:srgbClr val="476071"/>
+                </a:solidFill>
+                <a:latin typeface="DejaVu Sans"/>
+                <a:ea typeface="DejaVu Sans"/>
+                <a:cs typeface="DejaVu Sans"/>
+              </a:rPr>
+              <a:t>/mes. Valores referenciales, no contratos ni compras ejecutadas.</a:t>
             </a:r>
           </a:p>
         </p:txBody>
@@ -8699,7 +8791,7 @@
                 <a:ea typeface="DejaVu Sans"/>
                 <a:cs typeface="DejaVu Sans"/>
               </a:rPr>
-              <a:t>Ajuste WAN cerrado</a:t>
+              <a:t>Cuatro accesos de extremo a extremo</a:t>
             </a:r>
           </a:p>
         </p:txBody>
@@ -8868,7 +8960,7 @@
                 <a:ea typeface="DejaVu Sans"/>
                 <a:cs typeface="DejaVu Sans"/>
               </a:rPr>
-              <a:t>A y B ya usan distribuidores MikroTik. La revisión WAN-2 concilia modelos, puertos, inventario y presupuesto.</a:t>
+              <a:t>Casa Matriz también tiene Starlink, Leo, Entel y WOM. El diseño conserva camino con un acceso disponible en cada extremo, incluso de distinto proveedor.</a:t>
             </a:r>
           </a:p>
         </p:txBody>
@@ -9921,7 +10013,7 @@
           <p:cNvPr id="3" name="">
             <a:extLst xmlns:a="http://schemas.openxmlformats.org/drawingml/2006/main">
               <a:ext uri="{FF2B5EF4-FFF2-40B4-BE49-F238E27FC236}">
-                <a16:creationId xmlns:a16="http://schemas.microsoft.com/office/drawing/2014/main" id="{8428CC72-24AC-4035-9212-323D33020BDB}"/>
+                <a16:creationId xmlns:a16="http://schemas.microsoft.com/office/drawing/2014/main" id="{5244B5C5-0D36-4744-8B62-FD1F83B4A6CE}"/>
               </a:ext>
             </a:extLst>
           </p:cNvPr>
@@ -10817,7 +10909,7 @@
           <p:cNvPr id="3" name="">
             <a:extLst xmlns:a="http://schemas.openxmlformats.org/drawingml/2006/main">
               <a:ext uri="{FF2B5EF4-FFF2-40B4-BE49-F238E27FC236}">
-                <a16:creationId xmlns:a16="http://schemas.microsoft.com/office/drawing/2014/main" id="{0AAE8C88-E4A8-412A-A030-6F516A80497D}"/>
+                <a16:creationId xmlns:a16="http://schemas.microsoft.com/office/drawing/2014/main" id="{6339AED5-155E-4D1E-8FEB-3C8368E155BE}"/>
               </a:ext>
             </a:extLst>
           </p:cNvPr>
@@ -14640,7 +14732,7 @@
           <p:cNvPr id="3" name="">
             <a:extLst xmlns:a="http://schemas.openxmlformats.org/drawingml/2006/main">
               <a:ext uri="{FF2B5EF4-FFF2-40B4-BE49-F238E27FC236}">
-                <a16:creationId xmlns:a16="http://schemas.microsoft.com/office/drawing/2014/main" id="{4741B710-BECF-4BD7-BA09-5B203699E257}"/>
+                <a16:creationId xmlns:a16="http://schemas.microsoft.com/office/drawing/2014/main" id="{3DE0469C-7CEB-43AE-B8F5-3821C2211175}"/>
               </a:ext>
             </a:extLst>
           </p:cNvPr>
@@ -15536,7 +15628,7 @@
           <p:cNvPr id="3" name="">
             <a:extLst xmlns:a="http://schemas.openxmlformats.org/drawingml/2006/main">
               <a:ext uri="{FF2B5EF4-FFF2-40B4-BE49-F238E27FC236}">
-                <a16:creationId xmlns:a16="http://schemas.microsoft.com/office/drawing/2014/main" id="{BDAD1A1A-70C3-4870-A9F9-9F6AB225D683}"/>
+                <a16:creationId xmlns:a16="http://schemas.microsoft.com/office/drawing/2014/main" id="{8427292D-BC60-4F05-BA41-CC772F013530}"/>
               </a:ext>
             </a:extLst>
           </p:cNvPr>
@@ -15546,7 +15638,7 @@
           <p:nvPr/>
         </p:nvPicPr>
         <p:blipFill>
-          <a:blip xmlns:r="http://schemas.openxmlformats.org/officeDocument/2006/relationships" xmlns:a="http://schemas.openxmlformats.org/drawingml/2006/main" r:embed="R6ef150b843ae4dc0"/>
+          <a:blip xmlns:r="http://schemas.openxmlformats.org/officeDocument/2006/relationships" xmlns:a="http://schemas.openxmlformats.org/drawingml/2006/main" r:embed="R5edf9c0a27ae4908"/>
           <a:stretch xmlns:a="http://schemas.openxmlformats.org/drawingml/2006/main"/>
         </p:blipFill>
         <p:spPr>
@@ -16269,7 +16361,7 @@
           <p:cNvPr id="3" name="">
             <a:extLst xmlns:a="http://schemas.openxmlformats.org/drawingml/2006/main">
               <a:ext uri="{FF2B5EF4-FFF2-40B4-BE49-F238E27FC236}">
-                <a16:creationId xmlns:a16="http://schemas.microsoft.com/office/drawing/2014/main" id="{9F325825-EBFF-43D6-8FC1-53439A445821}"/>
+                <a16:creationId xmlns:a16="http://schemas.microsoft.com/office/drawing/2014/main" id="{7DC68A18-420E-4403-A9F9-47F172B3F9F4}"/>
               </a:ext>
             </a:extLst>
           </p:cNvPr>
@@ -17458,7 +17550,7 @@
           <p:cNvPr id="3" name="">
             <a:extLst xmlns:a="http://schemas.openxmlformats.org/drawingml/2006/main">
               <a:ext uri="{FF2B5EF4-FFF2-40B4-BE49-F238E27FC236}">
-                <a16:creationId xmlns:a16="http://schemas.microsoft.com/office/drawing/2014/main" id="{B09C9EE7-C46A-431C-8351-1A0DB313404D}"/>
+                <a16:creationId xmlns:a16="http://schemas.microsoft.com/office/drawing/2014/main" id="{DBEE6D71-5664-486B-9B53-F18E25C5EBF6}"/>
               </a:ext>
             </a:extLst>
           </p:cNvPr>
@@ -20086,7 +20178,7 @@
           <p:cNvPr id="3" name="">
             <a:extLst xmlns:a="http://schemas.openxmlformats.org/drawingml/2006/main">
               <a:ext uri="{FF2B5EF4-FFF2-40B4-BE49-F238E27FC236}">
-                <a16:creationId xmlns:a16="http://schemas.microsoft.com/office/drawing/2014/main" id="{E6E8DA35-D29F-4DC9-8150-101E24936C6C}"/>
+                <a16:creationId xmlns:a16="http://schemas.microsoft.com/office/drawing/2014/main" id="{710FFCC5-17A8-4EE2-BE55-0E1BA9EADFA4}"/>
               </a:ext>
             </a:extLst>
           </p:cNvPr>
@@ -20684,7 +20776,7 @@
                 <a:latin typeface="DejaVu Sans"/>
                 <a:ea typeface="DejaVu Sans"/>
                 <a:cs typeface="DejaVu Sans"/>
-                <a:hlinkClick xmlns:r="http://schemas.openxmlformats.org/officeDocument/2006/relationships" r:id="R082913b5666544ec"/>
+                <a:hlinkClick xmlns:r="http://schemas.openxmlformats.org/officeDocument/2006/relationships" r:id="Rfe17472e1059402f"/>
               </a:rPr>
               <a:t>Abrir simulador</a:t>
             </a:r>

</xml_diff>

<commit_message>
Consolidar entrega académica, presupuesto y verificación pública por SHA
Corrige cifras residuales del informe y flujo anual, cierre de bitácora, E4/E6 y enlaces privados u obsoletos. Publica fuentes académicas y anexos consultables, preservando cantidades y totales WAN-3. Actualiza la presentación, ZIP y manifiesto.

Añade 30 pruebas públicas de modelo y 16 casos Chromium de E1–E7/escena 10 contra fina 9b5139e. Los conteos históricos permanecen separados de esta ejecución y sus límites se documentan explícitamente.
</commit_message>
<xml_diff>
--- a/Presentacion/Avance_Financiera_Pacifico_30_oct_2026.pptx
+++ b/Presentacion/Avance_Financiera_Pacifico_30_oct_2026.pptx
@@ -2,26 +2,26 @@
 <file path=ppt/presentation.xml><?xml version="1.0" encoding="utf-8"?>
 <p:presentation xmlns:p="http://schemas.openxmlformats.org/presentationml/2006/main">
   <p:sldMasterIdLst>
-    <p:sldMasterId xmlns:r="http://schemas.openxmlformats.org/officeDocument/2006/relationships" id="2147483648" r:id="R2891c5164fd449a0"/>
+    <p:sldMasterId xmlns:r="http://schemas.openxmlformats.org/officeDocument/2006/relationships" id="2147483648" r:id="R9f1b36d94fe04497"/>
   </p:sldMasterIdLst>
   <p:notesMasterIdLst>
-    <p:notesMasterId xmlns:r="http://schemas.openxmlformats.org/officeDocument/2006/relationships" r:id="R6e919be1fee64b82"/>
+    <p:notesMasterId xmlns:r="http://schemas.openxmlformats.org/officeDocument/2006/relationships" r:id="R6bb2ffd53c8f4e22"/>
   </p:notesMasterIdLst>
   <p:sldIdLst>
-    <p:sldId xmlns:r="http://schemas.openxmlformats.org/officeDocument/2006/relationships" id="256" r:id="R7dd5a2e4a4434026"/>
-    <p:sldId xmlns:r="http://schemas.openxmlformats.org/officeDocument/2006/relationships" id="257" r:id="R5b564ddf205c4ee5"/>
-    <p:sldId xmlns:r="http://schemas.openxmlformats.org/officeDocument/2006/relationships" id="258" r:id="Rfa2a1cfb49f94742"/>
-    <p:sldId xmlns:r="http://schemas.openxmlformats.org/officeDocument/2006/relationships" id="259" r:id="R7a1b4ad4db9e4bcb"/>
-    <p:sldId xmlns:r="http://schemas.openxmlformats.org/officeDocument/2006/relationships" id="260" r:id="R9b37edb6cfb24f71"/>
-    <p:sldId xmlns:r="http://schemas.openxmlformats.org/officeDocument/2006/relationships" id="261" r:id="R66cf02a52bd744a3"/>
-    <p:sldId xmlns:r="http://schemas.openxmlformats.org/officeDocument/2006/relationships" id="262" r:id="R0ade0ea8c03f4a01"/>
-    <p:sldId xmlns:r="http://schemas.openxmlformats.org/officeDocument/2006/relationships" id="263" r:id="Rc5806a58639241f2"/>
-    <p:sldId xmlns:r="http://schemas.openxmlformats.org/officeDocument/2006/relationships" id="264" r:id="R0c6c1d96a5f746ac"/>
-    <p:sldId xmlns:r="http://schemas.openxmlformats.org/officeDocument/2006/relationships" id="265" r:id="Rd7a5d9c5be4f4128"/>
-    <p:sldId xmlns:r="http://schemas.openxmlformats.org/officeDocument/2006/relationships" id="266" r:id="Rd70ef328d5484118"/>
-    <p:sldId xmlns:r="http://schemas.openxmlformats.org/officeDocument/2006/relationships" id="267" r:id="R6d387f63cbf44361"/>
-    <p:sldId xmlns:r="http://schemas.openxmlformats.org/officeDocument/2006/relationships" id="268" r:id="R0ccd83569c444ed9"/>
-    <p:sldId xmlns:r="http://schemas.openxmlformats.org/officeDocument/2006/relationships" id="269" r:id="R8606a73d627e4a56"/>
+    <p:sldId xmlns:r="http://schemas.openxmlformats.org/officeDocument/2006/relationships" id="256" r:id="R2b64bd8c9a954ac7"/>
+    <p:sldId xmlns:r="http://schemas.openxmlformats.org/officeDocument/2006/relationships" id="257" r:id="R99f25bf119df49ea"/>
+    <p:sldId xmlns:r="http://schemas.openxmlformats.org/officeDocument/2006/relationships" id="258" r:id="R777caa8094dd4cec"/>
+    <p:sldId xmlns:r="http://schemas.openxmlformats.org/officeDocument/2006/relationships" id="259" r:id="R43287bd3c32f4108"/>
+    <p:sldId xmlns:r="http://schemas.openxmlformats.org/officeDocument/2006/relationships" id="260" r:id="Rcca6e4e416ab4b15"/>
+    <p:sldId xmlns:r="http://schemas.openxmlformats.org/officeDocument/2006/relationships" id="261" r:id="R950f7c73b0854698"/>
+    <p:sldId xmlns:r="http://schemas.openxmlformats.org/officeDocument/2006/relationships" id="262" r:id="R3cdfbed6db1248af"/>
+    <p:sldId xmlns:r="http://schemas.openxmlformats.org/officeDocument/2006/relationships" id="263" r:id="R70e1df89794b4f7d"/>
+    <p:sldId xmlns:r="http://schemas.openxmlformats.org/officeDocument/2006/relationships" id="264" r:id="R9b20bad75f85410c"/>
+    <p:sldId xmlns:r="http://schemas.openxmlformats.org/officeDocument/2006/relationships" id="265" r:id="R622a98de7ec84c73"/>
+    <p:sldId xmlns:r="http://schemas.openxmlformats.org/officeDocument/2006/relationships" id="266" r:id="R32b433a851294ade"/>
+    <p:sldId xmlns:r="http://schemas.openxmlformats.org/officeDocument/2006/relationships" id="267" r:id="Rdd363cadc9ca4be7"/>
+    <p:sldId xmlns:r="http://schemas.openxmlformats.org/officeDocument/2006/relationships" id="268" r:id="R6bbc11dbffed459e"/>
+    <p:sldId xmlns:r="http://schemas.openxmlformats.org/officeDocument/2006/relationships" id="269" r:id="R0579ea71abdf4821"/>
   </p:sldIdLst>
   <p:sldSz cx="12192000" cy="6858000"/>
   <p:notesSz cx="6858000" cy="9144000"/>
@@ -463,6 +463,11 @@
               <a:t>Revisión WAN-3: cuatro transportes en central y sucursales. Fuente: https://github.com/hu-herrera/financiera-pacifico-entrega-docente/blob/main/Anexos/Continuidad_Cuatro_WAN_25_oct_2026.md</a:t>
             </a:r>
           </a:p>
+          <a:p xmlns:a="http://schemas.openxmlformats.org/drawingml/2006/main">
+            <a:r>
+              <a:t>Cierre documental 27/10/2026. Verificación pública: https://github.com/hu-herrera/financiera-pacifico-entrega-docente/blob/main/Anexos/Evidencia_Pruebas_27_oct_2026.md. Las 30 pruebas de modelo incluyen la matriz WAN, recuperación e inventario. Los 16 casos de interfaz tienen ejecución y resultado identificados por SHA en ese anexo. No se suman con las pasadas históricas ni certifican hardware.</a:t>
+            </a:r>
+          </a:p>
         </p:txBody>
       </p:sp>
       <p:sp>
@@ -541,6 +546,11 @@
           <a:p xmlns:a="http://schemas.openxmlformats.org/drawingml/2006/main">
             <a:r>
               <a:t>Revisión WAN-3: cuatro transportes en central y sucursales. Fuente: https://github.com/hu-herrera/financiera-pacifico-entrega-docente/blob/main/Anexos/Continuidad_Cuatro_WAN_25_oct_2026.md</a:t>
+            </a:r>
+          </a:p>
+          <a:p xmlns:a="http://schemas.openxmlformats.org/drawingml/2006/main">
+            <a:r>
+              <a:t>Cierre documental 27/10/2026. Verificación pública: https://github.com/hu-herrera/financiera-pacifico-entrega-docente/blob/main/Anexos/Evidencia_Pruebas_27_oct_2026.md. Las 30 pruebas de modelo incluyen la matriz WAN, recuperación e inventario. Los 16 casos de interfaz tienen ejecución y resultado identificados por SHA en ese anexo. No se suman con las pasadas históricas ni certifican hardware.</a:t>
             </a:r>
           </a:p>
         </p:txBody>
@@ -3888,12 +3898,12 @@
   </p:cSld>
   <p:clrMap bg1="lt1" tx1="dk1" bg2="lt2" tx2="dk2" accent1="accent1" accent2="accent2" accent3="accent3" accent4="accent4" accent5="accent5" accent6="accent6" hlink="hlink" folHlink="folHlink"/>
   <p:sldLayoutIdLst>
-    <p:sldLayoutId xmlns:r="http://schemas.openxmlformats.org/officeDocument/2006/relationships" id="2147483649" r:id="R425b135a31f44906"/>
-    <p:sldLayoutId xmlns:r="http://schemas.openxmlformats.org/officeDocument/2006/relationships" id="2147483650" r:id="Rfe0936ba58554621"/>
-    <p:sldLayoutId xmlns:r="http://schemas.openxmlformats.org/officeDocument/2006/relationships" id="2147483651" r:id="Rd565e80b8ff6449d"/>
-    <p:sldLayoutId xmlns:r="http://schemas.openxmlformats.org/officeDocument/2006/relationships" id="2147483652" r:id="Rb2f942bbaeb6492a"/>
-    <p:sldLayoutId xmlns:r="http://schemas.openxmlformats.org/officeDocument/2006/relationships" id="2147483653" r:id="Rec3727f1fbef44b7"/>
-    <p:sldLayoutId xmlns:r="http://schemas.openxmlformats.org/officeDocument/2006/relationships" id="2147483654" r:id="R0bb65f2a5880480d"/>
+    <p:sldLayoutId xmlns:r="http://schemas.openxmlformats.org/officeDocument/2006/relationships" id="2147483649" r:id="R2ef964131fab4995"/>
+    <p:sldLayoutId xmlns:r="http://schemas.openxmlformats.org/officeDocument/2006/relationships" id="2147483650" r:id="Reae22f9b6c53488a"/>
+    <p:sldLayoutId xmlns:r="http://schemas.openxmlformats.org/officeDocument/2006/relationships" id="2147483651" r:id="R28ddd3462d854559"/>
+    <p:sldLayoutId xmlns:r="http://schemas.openxmlformats.org/officeDocument/2006/relationships" id="2147483652" r:id="Rf989c59553864179"/>
+    <p:sldLayoutId xmlns:r="http://schemas.openxmlformats.org/officeDocument/2006/relationships" id="2147483653" r:id="Ra6a4ef02936b40d1"/>
+    <p:sldLayoutId xmlns:r="http://schemas.openxmlformats.org/officeDocument/2006/relationships" id="2147483654" r:id="R76e6133889324e86"/>
   </p:sldLayoutIdLst>
   <p:txStyles>
     <p:titleStyle>
@@ -5134,7 +5144,7 @@
                 <a:ea typeface="DejaVu Sans"/>
                 <a:cs typeface="DejaVu Sans"/>
               </a:rPr>
-              <a:t>Avance Capstone al 25 de octubre de 2026</a:t>
+              <a:t>Avance Capstone al 27 de octubre de 2026</a:t>
             </a:r>
           </a:p>
         </p:txBody>
@@ -5863,7 +5873,7 @@
                 <a:ea typeface="DejaVu Sans"/>
                 <a:cs typeface="DejaVu Sans"/>
               </a:rPr>
-              <a:t>99</a:t>
+              <a:t>30</a:t>
             </a:r>
           </a:p>
         </p:txBody>
@@ -6032,7 +6042,7 @@
                 <a:ea typeface="DejaVu Sans"/>
                 <a:cs typeface="DejaVu Sans"/>
               </a:rPr>
-              <a:t>pruebas de lógica aprobadas</a:t>
+              <a:t>pruebas públicas de modelo aprobadas</a:t>
             </a:r>
           </a:p>
         </p:txBody>
@@ -6201,7 +6211,7 @@
                 <a:ea typeface="DejaVu Sans"/>
                 <a:cs typeface="DejaVu Sans"/>
               </a:rPr>
-              <a:t>44</a:t>
+              <a:t>16</a:t>
             </a:r>
           </a:p>
         </p:txBody>
@@ -6370,7 +6380,7 @@
                 <a:ea typeface="DejaVu Sans"/>
                 <a:cs typeface="DejaVu Sans"/>
               </a:rPr>
-              <a:t>pruebas de navegador en esta revisión</a:t>
+              <a:t>casos de interfaz publicados</a:t>
             </a:r>
           </a:p>
         </p:txBody>
@@ -6539,7 +6549,7 @@
                 <a:ea typeface="DejaVu Sans"/>
                 <a:cs typeface="DejaVu Sans"/>
               </a:rPr>
-              <a:t>1.351 comprobaciones adicionales de caminos A/B</a:t>
+              <a:t>9.900 combinaciones WAN dentro de las pruebas de modelo</a:t>
             </a:r>
           </a:p>
         </p:txBody>
@@ -6708,7 +6718,7 @@
                 <a:ea typeface="DejaVu Sans"/>
                 <a:cs typeface="DejaVu Sans"/>
               </a:rPr>
-              <a:t>QoS, VPN y HA cuentan con regresiones adicionales.</a:t>
+              <a:t>Los registros históricos tienen cortes distintos.</a:t>
             </a:r>
           </a:p>
           <a:p xmlns:a="http://schemas.openxmlformats.org/drawingml/2006/main">
@@ -6732,7 +6742,7 @@
                 <a:ea typeface="DejaVu Sans"/>
                 <a:cs typeface="DejaVu Sans"/>
               </a:rPr>
-              <a:t>Los conteos describen pasadas de software, sin sumarlas.</a:t>
+              <a:t>Los resultados por SHA están en el anexo público de evidencia.</a:t>
             </a:r>
           </a:p>
         </p:txBody>
@@ -7278,7 +7288,7 @@
           <p:cNvPr id="3" name="">
             <a:extLst xmlns:a="http://schemas.openxmlformats.org/drawingml/2006/main">
               <a:ext uri="{FF2B5EF4-FFF2-40B4-BE49-F238E27FC236}">
-                <a16:creationId xmlns:a16="http://schemas.microsoft.com/office/drawing/2014/main" id="{DFDCAC1B-6449-4D53-B254-B60816088A6D}"/>
+                <a16:creationId xmlns:a16="http://schemas.microsoft.com/office/drawing/2014/main" id="{B6FF6D45-E115-44AD-84B4-73BE26B149CF}"/>
               </a:ext>
             </a:extLst>
           </p:cNvPr>
@@ -10013,7 +10023,7 @@
           <p:cNvPr id="3" name="">
             <a:extLst xmlns:a="http://schemas.openxmlformats.org/drawingml/2006/main">
               <a:ext uri="{FF2B5EF4-FFF2-40B4-BE49-F238E27FC236}">
-                <a16:creationId xmlns:a16="http://schemas.microsoft.com/office/drawing/2014/main" id="{5244B5C5-0D36-4744-8B62-FD1F83B4A6CE}"/>
+                <a16:creationId xmlns:a16="http://schemas.microsoft.com/office/drawing/2014/main" id="{10796B85-5EB4-4B77-8C42-026C980E2BBC}"/>
               </a:ext>
             </a:extLst>
           </p:cNvPr>
@@ -10909,7 +10919,7 @@
           <p:cNvPr id="3" name="">
             <a:extLst xmlns:a="http://schemas.openxmlformats.org/drawingml/2006/main">
               <a:ext uri="{FF2B5EF4-FFF2-40B4-BE49-F238E27FC236}">
-                <a16:creationId xmlns:a16="http://schemas.microsoft.com/office/drawing/2014/main" id="{6339AED5-155E-4D1E-8FEB-3C8368E155BE}"/>
+                <a16:creationId xmlns:a16="http://schemas.microsoft.com/office/drawing/2014/main" id="{1FE30422-4A1E-46E7-819B-0484007EF0C4}"/>
               </a:ext>
             </a:extLst>
           </p:cNvPr>
@@ -14732,7 +14742,7 @@
           <p:cNvPr id="3" name="">
             <a:extLst xmlns:a="http://schemas.openxmlformats.org/drawingml/2006/main">
               <a:ext uri="{FF2B5EF4-FFF2-40B4-BE49-F238E27FC236}">
-                <a16:creationId xmlns:a16="http://schemas.microsoft.com/office/drawing/2014/main" id="{3DE0469C-7CEB-43AE-B8F5-3821C2211175}"/>
+                <a16:creationId xmlns:a16="http://schemas.microsoft.com/office/drawing/2014/main" id="{735B11CB-B044-47FF-BF99-45F8DFD85DBA}"/>
               </a:ext>
             </a:extLst>
           </p:cNvPr>
@@ -15628,7 +15638,7 @@
           <p:cNvPr id="3" name="">
             <a:extLst xmlns:a="http://schemas.openxmlformats.org/drawingml/2006/main">
               <a:ext uri="{FF2B5EF4-FFF2-40B4-BE49-F238E27FC236}">
-                <a16:creationId xmlns:a16="http://schemas.microsoft.com/office/drawing/2014/main" id="{8427292D-BC60-4F05-BA41-CC772F013530}"/>
+                <a16:creationId xmlns:a16="http://schemas.microsoft.com/office/drawing/2014/main" id="{09DB58CC-0121-42BD-9454-BE545040389D}"/>
               </a:ext>
             </a:extLst>
           </p:cNvPr>
@@ -15638,7 +15648,7 @@
           <p:nvPr/>
         </p:nvPicPr>
         <p:blipFill>
-          <a:blip xmlns:r="http://schemas.openxmlformats.org/officeDocument/2006/relationships" xmlns:a="http://schemas.openxmlformats.org/drawingml/2006/main" r:embed="R5edf9c0a27ae4908"/>
+          <a:blip xmlns:r="http://schemas.openxmlformats.org/officeDocument/2006/relationships" xmlns:a="http://schemas.openxmlformats.org/drawingml/2006/main" r:embed="Re1186f7c508c4aa8"/>
           <a:stretch xmlns:a="http://schemas.openxmlformats.org/drawingml/2006/main"/>
         </p:blipFill>
         <p:spPr>
@@ -16361,7 +16371,7 @@
           <p:cNvPr id="3" name="">
             <a:extLst xmlns:a="http://schemas.openxmlformats.org/drawingml/2006/main">
               <a:ext uri="{FF2B5EF4-FFF2-40B4-BE49-F238E27FC236}">
-                <a16:creationId xmlns:a16="http://schemas.microsoft.com/office/drawing/2014/main" id="{7DC68A18-420E-4403-A9F9-47F172B3F9F4}"/>
+                <a16:creationId xmlns:a16="http://schemas.microsoft.com/office/drawing/2014/main" id="{1DD59EB0-37C5-4552-A690-DEA74CEEB0CC}"/>
               </a:ext>
             </a:extLst>
           </p:cNvPr>
@@ -17550,7 +17560,7 @@
           <p:cNvPr id="3" name="">
             <a:extLst xmlns:a="http://schemas.openxmlformats.org/drawingml/2006/main">
               <a:ext uri="{FF2B5EF4-FFF2-40B4-BE49-F238E27FC236}">
-                <a16:creationId xmlns:a16="http://schemas.microsoft.com/office/drawing/2014/main" id="{DBEE6D71-5664-486B-9B53-F18E25C5EBF6}"/>
+                <a16:creationId xmlns:a16="http://schemas.microsoft.com/office/drawing/2014/main" id="{14101F32-475C-4087-A488-F935E64134B2}"/>
               </a:ext>
             </a:extLst>
           </p:cNvPr>
@@ -20178,7 +20188,7 @@
           <p:cNvPr id="3" name="">
             <a:extLst xmlns:a="http://schemas.openxmlformats.org/drawingml/2006/main">
               <a:ext uri="{FF2B5EF4-FFF2-40B4-BE49-F238E27FC236}">
-                <a16:creationId xmlns:a16="http://schemas.microsoft.com/office/drawing/2014/main" id="{710FFCC5-17A8-4EE2-BE55-0E1BA9EADFA4}"/>
+                <a16:creationId xmlns:a16="http://schemas.microsoft.com/office/drawing/2014/main" id="{4FBAA30C-62B4-4DED-85CE-8A935022B5CE}"/>
               </a:ext>
             </a:extLst>
           </p:cNvPr>
@@ -20776,7 +20786,7 @@
                 <a:latin typeface="DejaVu Sans"/>
                 <a:ea typeface="DejaVu Sans"/>
                 <a:cs typeface="DejaVu Sans"/>
-                <a:hlinkClick xmlns:r="http://schemas.openxmlformats.org/officeDocument/2006/relationships" r:id="Rfe17472e1059402f"/>
+                <a:hlinkClick xmlns:r="http://schemas.openxmlformats.org/officeDocument/2006/relationships" r:id="Rb2294dfe434949fb"/>
               </a:rPr>
               <a:t>Abrir simulador</a:t>
             </a:r>

</xml_diff>

<commit_message>
Sincronizar entrega de defensa C5-OPERACION-2
Actualiza PPT con conclusión adicional, fuentes/PDF, guion de 13 escenas, matriz de protocolos y recuperación por eventos. Publica 60 pruebas de modelo, 52 de interfaz y el recorrido completo A/B. Regenera manifiesto y ZIP con 69 archivos y fija el simulador publicado en 3598d23.
</commit_message>
<xml_diff>
--- a/Presentacion/Avance_Financiera_Pacifico_30_oct_2026.pptx
+++ b/Presentacion/Avance_Financiera_Pacifico_30_oct_2026.pptx
@@ -2,26 +2,27 @@
 <file path=ppt/presentation.xml><?xml version="1.0" encoding="utf-8"?>
 <p:presentation xmlns:p="http://schemas.openxmlformats.org/presentationml/2006/main">
   <p:sldMasterIdLst>
-    <p:sldMasterId xmlns:r="http://schemas.openxmlformats.org/officeDocument/2006/relationships" id="2147483648" r:id="R9f1b36d94fe04497"/>
+    <p:sldMasterId xmlns:r="http://schemas.openxmlformats.org/officeDocument/2006/relationships" id="2147483648" r:id="R53f694a1267b4e9f"/>
   </p:sldMasterIdLst>
   <p:notesMasterIdLst>
-    <p:notesMasterId xmlns:r="http://schemas.openxmlformats.org/officeDocument/2006/relationships" r:id="R6bb2ffd53c8f4e22"/>
+    <p:notesMasterId xmlns:r="http://schemas.openxmlformats.org/officeDocument/2006/relationships" r:id="R036b62ef53074137"/>
   </p:notesMasterIdLst>
   <p:sldIdLst>
-    <p:sldId xmlns:r="http://schemas.openxmlformats.org/officeDocument/2006/relationships" id="256" r:id="R2b64bd8c9a954ac7"/>
-    <p:sldId xmlns:r="http://schemas.openxmlformats.org/officeDocument/2006/relationships" id="257" r:id="R99f25bf119df49ea"/>
-    <p:sldId xmlns:r="http://schemas.openxmlformats.org/officeDocument/2006/relationships" id="258" r:id="R777caa8094dd4cec"/>
-    <p:sldId xmlns:r="http://schemas.openxmlformats.org/officeDocument/2006/relationships" id="259" r:id="R43287bd3c32f4108"/>
-    <p:sldId xmlns:r="http://schemas.openxmlformats.org/officeDocument/2006/relationships" id="260" r:id="Rcca6e4e416ab4b15"/>
-    <p:sldId xmlns:r="http://schemas.openxmlformats.org/officeDocument/2006/relationships" id="261" r:id="R950f7c73b0854698"/>
-    <p:sldId xmlns:r="http://schemas.openxmlformats.org/officeDocument/2006/relationships" id="262" r:id="R3cdfbed6db1248af"/>
-    <p:sldId xmlns:r="http://schemas.openxmlformats.org/officeDocument/2006/relationships" id="263" r:id="R70e1df89794b4f7d"/>
-    <p:sldId xmlns:r="http://schemas.openxmlformats.org/officeDocument/2006/relationships" id="264" r:id="R9b20bad75f85410c"/>
-    <p:sldId xmlns:r="http://schemas.openxmlformats.org/officeDocument/2006/relationships" id="265" r:id="R622a98de7ec84c73"/>
-    <p:sldId xmlns:r="http://schemas.openxmlformats.org/officeDocument/2006/relationships" id="266" r:id="R32b433a851294ade"/>
-    <p:sldId xmlns:r="http://schemas.openxmlformats.org/officeDocument/2006/relationships" id="267" r:id="Rdd363cadc9ca4be7"/>
-    <p:sldId xmlns:r="http://schemas.openxmlformats.org/officeDocument/2006/relationships" id="268" r:id="R6bbc11dbffed459e"/>
-    <p:sldId xmlns:r="http://schemas.openxmlformats.org/officeDocument/2006/relationships" id="269" r:id="R0579ea71abdf4821"/>
+    <p:sldId xmlns:r="http://schemas.openxmlformats.org/officeDocument/2006/relationships" id="256" r:id="R28348abfcc02438c"/>
+    <p:sldId xmlns:r="http://schemas.openxmlformats.org/officeDocument/2006/relationships" id="257" r:id="Rd114121f39c64dd7"/>
+    <p:sldId xmlns:r="http://schemas.openxmlformats.org/officeDocument/2006/relationships" id="258" r:id="Rcc3b089c93854733"/>
+    <p:sldId xmlns:r="http://schemas.openxmlformats.org/officeDocument/2006/relationships" id="259" r:id="R377019ac3782431a"/>
+    <p:sldId xmlns:r="http://schemas.openxmlformats.org/officeDocument/2006/relationships" id="260" r:id="Rcb357d0db9124e4f"/>
+    <p:sldId xmlns:r="http://schemas.openxmlformats.org/officeDocument/2006/relationships" id="261" r:id="R9ce8df91c2c94dd9"/>
+    <p:sldId xmlns:r="http://schemas.openxmlformats.org/officeDocument/2006/relationships" id="262" r:id="R92a3fb970e5547ff"/>
+    <p:sldId xmlns:r="http://schemas.openxmlformats.org/officeDocument/2006/relationships" id="263" r:id="Rc40eeaf135f14153"/>
+    <p:sldId xmlns:r="http://schemas.openxmlformats.org/officeDocument/2006/relationships" id="264" r:id="R47589fe4a92e4971"/>
+    <p:sldId xmlns:r="http://schemas.openxmlformats.org/officeDocument/2006/relationships" id="265" r:id="R7112d9fe97f9425a"/>
+    <p:sldId xmlns:r="http://schemas.openxmlformats.org/officeDocument/2006/relationships" id="266" r:id="Rb007af21902e42f8"/>
+    <p:sldId xmlns:r="http://schemas.openxmlformats.org/officeDocument/2006/relationships" id="267" r:id="R5e19e5b04c684532"/>
+    <p:sldId xmlns:r="http://schemas.openxmlformats.org/officeDocument/2006/relationships" id="268" r:id="R5fc50320a2ca435d"/>
+    <p:sldId xmlns:r="http://schemas.openxmlformats.org/officeDocument/2006/relationships" id="269" r:id="Rfb8e495ca97148eb"/>
+    <p:sldId xmlns:r="http://schemas.openxmlformats.org/officeDocument/2006/relationships" id="270" r:id="Re0578db8e86d4b24"/>
   </p:sldIdLst>
   <p:sldSz cx="12192000" cy="6858000"/>
   <p:notesSz cx="6858000" cy="9144000"/>
@@ -535,22 +536,7 @@
           <a:lstStyle xmlns:a="http://schemas.openxmlformats.org/drawingml/2006/main"/>
           <a:p xmlns:a="http://schemas.openxmlformats.org/drawingml/2006/main">
             <a:r>
-              <a:t>Fuentes y alcance: https://github.com/hu-herrera/financiera-pacifico-entrega-docente/blob/main/02_Entregables/Entregable_6.pdf. Commit de red 228ec2674d2b784b4cb67dab1128e969f681d3aa.</a:t>
-            </a:r>
-          </a:p>
-          <a:p xmlns:a="http://schemas.openxmlformats.org/drawingml/2006/main">
-            <a:r>
-              <a:t>Actualización del 25/10: https://github.com/hu-herrera/financiera-pacifico-entrega-docente/blob/main/Anexos/Cierre_25_oct_2026.md. Los resultados de 93 Node y 151 navegador tienen cortes y alcances separados. La admisión de video es política propuesta, sin control automático de una aplicación real.</a:t>
-            </a:r>
-          </a:p>
-          <a:p xmlns:a="http://schemas.openxmlformats.org/drawingml/2006/main">
-            <a:r>
-              <a:t>Revisión WAN-3: cuatro transportes en central y sucursales. Fuente: https://github.com/hu-herrera/financiera-pacifico-entrega-docente/blob/main/Anexos/Continuidad_Cuatro_WAN_25_oct_2026.md</a:t>
-            </a:r>
-          </a:p>
-          <a:p xmlns:a="http://schemas.openxmlformats.org/drawingml/2006/main">
-            <a:r>
-              <a:t>Cierre documental 27/10/2026. Verificación pública: https://github.com/hu-herrera/financiera-pacifico-entrega-docente/blob/main/Anexos/Evidencia_Pruebas_27_oct_2026.md. Las 30 pruebas de modelo incluyen la matriz WAN, recuperación e inventario. Los 16 casos de interfaz tienen ejecución y resultado identificados por SHA en ese anexo. No se suman con las pasadas históricas ni certifican hardware.</a:t>
+              <a:t>Evidencia C5-OPERACION-2: 60 pruebas de modelo, incluidas 9.900 combinaciones de accesos WAN, y 52 pruebas de navegador A/B. Las pruebas acreditan la simulación funcional y la interfaz. No constituyen mediciones de firmware ni certificación de hardware. Fuentes: Verificacion/modelo.test.cjs, protocolos.test.cjs, interfaz.spec.cjs y operacion.spec.cjs.</a:t>
             </a:r>
           </a:p>
         </p:txBody>
@@ -856,6 +842,76 @@
           <a:p xmlns:a="http://schemas.openxmlformats.org/drawingml/2006/main">
             <a:r>
               <a:t>Revisión WAN-3: cuatro transportes en central y sucursales. Fuente: https://github.com/hu-herrera/financiera-pacifico-entrega-docente/blob/main/Anexos/Continuidad_Cuatro_WAN_25_oct_2026.md</a:t>
+            </a:r>
+          </a:p>
+        </p:txBody>
+      </p:sp>
+      <p:sp>
+        <p:nvSpPr>
+          <p:cNvPr id="4" name="Slide Number Placeholder 3"/>
+          <p:cNvSpPr>
+            <a:spLocks xmlns:a="http://schemas.openxmlformats.org/drawingml/2006/main" noGrp="1"/>
+          </p:cNvSpPr>
+          <p:nvPr>
+            <p:ph type="sldNum" idx="5"/>
+          </p:nvPr>
+        </p:nvSpPr>
+        <p:spPr/>
+        <p:txBody>
+          <a:bodyPr xmlns:a="http://schemas.openxmlformats.org/drawingml/2006/main"/>
+          <a:lstStyle xmlns:a="http://schemas.openxmlformats.org/drawingml/2006/main"/>
+          <a:p xmlns:a="http://schemas.openxmlformats.org/drawingml/2006/main"/>
+        </p:txBody>
+      </p:sp>
+    </p:spTree>
+  </p:cSld>
+  <p:clrMapOvr>
+    <a:masterClrMapping xmlns:a="http://schemas.openxmlformats.org/drawingml/2006/main"/>
+  </p:clrMapOvr>
+</p:notes>
+</file>
+
+<file path=ppt/notesSlides/notesSlide15.xml><?xml version="1.0" encoding="utf-8"?>
+<p:notes xmlns:p="http://schemas.openxmlformats.org/presentationml/2006/main">
+  <p:cSld>
+    <p:spTree>
+      <p:nvGrpSpPr>
+        <p:cNvPr id="1" name=""/>
+        <p:cNvGrpSpPr/>
+        <p:nvPr/>
+      </p:nvGrpSpPr>
+      <p:grpSpPr>
+        <a:xfrm xmlns:a="http://schemas.openxmlformats.org/drawingml/2006/main"/>
+      </p:grpSpPr>
+      <p:sp>
+        <p:nvSpPr>
+          <p:cNvPr id="2" name="Slide Image Placeholder 1"/>
+          <p:cNvSpPr>
+            <a:spLocks xmlns:a="http://schemas.openxmlformats.org/drawingml/2006/main" noGrp="1"/>
+          </p:cNvSpPr>
+          <p:nvPr>
+            <p:ph type="sldImg" idx="0"/>
+          </p:nvPr>
+        </p:nvSpPr>
+        <p:spPr/>
+      </p:sp>
+      <p:sp>
+        <p:nvSpPr>
+          <p:cNvPr id="3" name="Notes Placeholder 2"/>
+          <p:cNvSpPr>
+            <a:spLocks xmlns:a="http://schemas.openxmlformats.org/drawingml/2006/main" noGrp="1"/>
+          </p:cNvSpPr>
+          <p:nvPr>
+            <p:ph type="body" idx="1"/>
+          </p:nvPr>
+        </p:nvSpPr>
+        <p:spPr/>
+        <p:txBody>
+          <a:bodyPr xmlns:a="http://schemas.openxmlformats.org/drawingml/2006/main"/>
+          <a:lstStyle xmlns:a="http://schemas.openxmlformats.org/drawingml/2006/main"/>
+          <a:p xmlns:a="http://schemas.openxmlformats.org/drawingml/2006/main">
+            <a:r>
+              <a:t>Para finalizar, la propuesta busca sostener la atención mediante caminos alternativos, acceso controlado y recuperación de los servicios centrales. Cada decisión debe responder a una dependencia identificada y a una necesidad de operación. Presentamos dos alternativas de inversión para evaluar junto con su soporte y mantenimiento. Muchas gracias; quedamos disponibles para preguntas y pruebas sobre el simulador.</a:t>
             </a:r>
           </a:p>
         </p:txBody>
@@ -1375,12 +1431,7 @@
           <a:lstStyle xmlns:a="http://schemas.openxmlformats.org/drawingml/2006/main"/>
           <a:p xmlns:a="http://schemas.openxmlformats.org/drawingml/2006/main">
             <a:r>
-              <a:t>Fuentes y alcance: https://github.com/hu-herrera/financiera-pacifico-entrega-docente/blob/main/02_Entregables/Entregable_3.pdf y https://github.com/hu-herrera/financiera-pacifico-entrega-docente/blob/main/02_Entregables/Entregable_4.pdf</a:t>
-            </a:r>
-          </a:p>
-          <a:p xmlns:a="http://schemas.openxmlformats.org/drawingml/2006/main">
-            <a:r>
-              <a:t>Revisión WAN-3: cuatro transportes en central y sucursales. Fuente: https://github.com/hu-herrera/financiera-pacifico-entrega-docente/blob/main/Anexos/Continuidad_Cuatro_WAN_25_oct_2026.md</a:t>
+              <a:t>El ejercicio base inicia operaciones cada 10 s y réplica cada 60 s, con 4 s para completarla. Falla en t=157 s; conserva la copia de t=120 s completada en t=124 s. Quedan 12 de 15 operaciones y 3 por conciliar. RPO observado 150-120=30 s. Detección 5 s, aislamiento 5 s, arranque 30 s y validación HTTPS 10 s: RTO observado 50 s virtuales. Fuente: código y Anexos/Ejercicios_Recuperacion_C5.json del corte C5-OPERACION-2.</a:t>
             </a:r>
           </a:p>
         </p:txBody>
@@ -3898,12 +3949,12 @@
   </p:cSld>
   <p:clrMap bg1="lt1" tx1="dk1" bg2="lt2" tx2="dk2" accent1="accent1" accent2="accent2" accent3="accent3" accent4="accent4" accent5="accent5" accent6="accent6" hlink="hlink" folHlink="folHlink"/>
   <p:sldLayoutIdLst>
-    <p:sldLayoutId xmlns:r="http://schemas.openxmlformats.org/officeDocument/2006/relationships" id="2147483649" r:id="R2ef964131fab4995"/>
-    <p:sldLayoutId xmlns:r="http://schemas.openxmlformats.org/officeDocument/2006/relationships" id="2147483650" r:id="Reae22f9b6c53488a"/>
-    <p:sldLayoutId xmlns:r="http://schemas.openxmlformats.org/officeDocument/2006/relationships" id="2147483651" r:id="R28ddd3462d854559"/>
-    <p:sldLayoutId xmlns:r="http://schemas.openxmlformats.org/officeDocument/2006/relationships" id="2147483652" r:id="Rf989c59553864179"/>
-    <p:sldLayoutId xmlns:r="http://schemas.openxmlformats.org/officeDocument/2006/relationships" id="2147483653" r:id="Ra6a4ef02936b40d1"/>
-    <p:sldLayoutId xmlns:r="http://schemas.openxmlformats.org/officeDocument/2006/relationships" id="2147483654" r:id="R76e6133889324e86"/>
+    <p:sldLayoutId xmlns:r="http://schemas.openxmlformats.org/officeDocument/2006/relationships" id="2147483649" r:id="Re9d7c74ded1b486f"/>
+    <p:sldLayoutId xmlns:r="http://schemas.openxmlformats.org/officeDocument/2006/relationships" id="2147483650" r:id="R50c0ee8a59514125"/>
+    <p:sldLayoutId xmlns:r="http://schemas.openxmlformats.org/officeDocument/2006/relationships" id="2147483651" r:id="Re04823970be340f0"/>
+    <p:sldLayoutId xmlns:r="http://schemas.openxmlformats.org/officeDocument/2006/relationships" id="2147483652" r:id="Rdf8fce1d44234314"/>
+    <p:sldLayoutId xmlns:r="http://schemas.openxmlformats.org/officeDocument/2006/relationships" id="2147483653" r:id="R1f9fb0c2aa834846"/>
+    <p:sldLayoutId xmlns:r="http://schemas.openxmlformats.org/officeDocument/2006/relationships" id="2147483654" r:id="Rae2db2f5c6294545"/>
   </p:sldLayoutIdLst>
   <p:txStyles>
     <p:titleStyle>
@@ -5144,7 +5195,7 @@
                 <a:ea typeface="DejaVu Sans"/>
                 <a:cs typeface="DejaVu Sans"/>
               </a:rPr>
-              <a:t>Avance Capstone al 27 de octubre de 2026</a:t>
+              <a:t>Avance Capstone al 28 de octubre de 2026</a:t>
             </a:r>
           </a:p>
         </p:txBody>
@@ -5535,7 +5586,7 @@
                 <a:ea typeface="DejaVu Sans"/>
                 <a:cs typeface="DejaVu Sans"/>
               </a:rPr>
-              <a:t>Evidencia y límites de los resultados</a:t>
+              <a:t>Pruebas de operación del prototipo</a:t>
             </a:r>
           </a:p>
         </p:txBody>
@@ -5873,7 +5924,7 @@
                 <a:ea typeface="DejaVu Sans"/>
                 <a:cs typeface="DejaVu Sans"/>
               </a:rPr>
-              <a:t>30</a:t>
+              <a:t>60</a:t>
             </a:r>
           </a:p>
         </p:txBody>
@@ -6211,7 +6262,7 @@
                 <a:ea typeface="DejaVu Sans"/>
                 <a:cs typeface="DejaVu Sans"/>
               </a:rPr>
-              <a:t>16</a:t>
+              <a:t>52</a:t>
             </a:r>
           </a:p>
         </p:txBody>
@@ -6718,7 +6769,7 @@
                 <a:ea typeface="DejaVu Sans"/>
                 <a:cs typeface="DejaVu Sans"/>
               </a:rPr>
-              <a:t>Los registros históricos tienen cortes distintos.</a:t>
+              <a:t>Interfaces, OSPF, VPN, permisos, servicios y recuperación.</a:t>
             </a:r>
           </a:p>
           <a:p xmlns:a="http://schemas.openxmlformats.org/drawingml/2006/main">
@@ -6742,7 +6793,7 @@
                 <a:ea typeface="DejaVu Sans"/>
                 <a:cs typeface="DejaVu Sans"/>
               </a:rPr>
-              <a:t>Los resultados por SHA están en el anexo público de evidencia.</a:t>
+              <a:t>El cierre vigente conserva resultados y comandos reproducibles.</a:t>
             </a:r>
           </a:p>
         </p:txBody>
@@ -7288,7 +7339,7 @@
           <p:cNvPr id="3" name="">
             <a:extLst xmlns:a="http://schemas.openxmlformats.org/drawingml/2006/main">
               <a:ext uri="{FF2B5EF4-FFF2-40B4-BE49-F238E27FC236}">
-                <a16:creationId xmlns:a16="http://schemas.microsoft.com/office/drawing/2014/main" id="{B6FF6D45-E115-44AD-84B4-73BE26B149CF}"/>
+                <a16:creationId xmlns:a16="http://schemas.microsoft.com/office/drawing/2014/main" id="{70907D4D-1B45-4976-BA55-0156874B67FF}"/>
               </a:ext>
             </a:extLst>
           </p:cNvPr>
@@ -10023,7 +10074,7 @@
           <p:cNvPr id="3" name="">
             <a:extLst xmlns:a="http://schemas.openxmlformats.org/drawingml/2006/main">
               <a:ext uri="{FF2B5EF4-FFF2-40B4-BE49-F238E27FC236}">
-                <a16:creationId xmlns:a16="http://schemas.microsoft.com/office/drawing/2014/main" id="{10796B85-5EB4-4B77-8C42-026C980E2BBC}"/>
+                <a16:creationId xmlns:a16="http://schemas.microsoft.com/office/drawing/2014/main" id="{76D4C787-CB2E-4A00-836A-D3517C0F335F}"/>
               </a:ext>
             </a:extLst>
           </p:cNvPr>
@@ -10919,7 +10970,7 @@
           <p:cNvPr id="3" name="">
             <a:extLst xmlns:a="http://schemas.openxmlformats.org/drawingml/2006/main">
               <a:ext uri="{FF2B5EF4-FFF2-40B4-BE49-F238E27FC236}">
-                <a16:creationId xmlns:a16="http://schemas.microsoft.com/office/drawing/2014/main" id="{1FE30422-4A1E-46E7-819B-0484007EF0C4}"/>
+                <a16:creationId xmlns:a16="http://schemas.microsoft.com/office/drawing/2014/main" id="{B97CF428-0419-4CEB-8A57-750DA211087C}"/>
               </a:ext>
             </a:extLst>
           </p:cNvPr>
@@ -11613,6 +11664,977 @@
 </p:sld>
 </file>
 
+<file path=ppt/slides/slide15.xml><?xml version="1.0" encoding="utf-8"?>
+<p:sld xmlns:p="http://schemas.openxmlformats.org/presentationml/2006/main">
+  <p:cSld>
+    <p:bg>
+      <p:bgPr>
+        <a:solidFill xmlns:a="http://schemas.openxmlformats.org/drawingml/2006/main">
+          <a:srgbClr val="F5F7F5"/>
+        </a:solidFill>
+      </p:bgPr>
+    </p:bg>
+    <p:spTree>
+      <p:nvGrpSpPr>
+        <p:cNvPr id="1" name=""/>
+        <p:cNvGrpSpPr/>
+        <p:nvPr/>
+      </p:nvGrpSpPr>
+      <p:grpSpPr>
+        <a:xfrm xmlns:a="http://schemas.openxmlformats.org/drawingml/2006/main"/>
+      </p:grpSpPr>
+      <p:sp>
+        <p:nvSpPr>
+          <p:cNvPr id="7" name="closing-title">
+            <a:extLst xmlns:a="http://schemas.openxmlformats.org/drawingml/2006/main">
+              <a:ext uri="{FF2B5EF4-FFF2-40B4-BE49-F238E27FC236}">
+                <a16:creationId xmlns:a16="http://schemas.microsoft.com/office/drawing/2014/main" id="{3FF9DA87-A473-40FB-92B3-974B8014F5F9}"/>
+              </a:ext>
+            </a:extLst>
+          </p:cNvPr>
+          <p:cNvSpPr>
+            <a:spLocks xmlns:a="http://schemas.openxmlformats.org/drawingml/2006/main" noGrp="1"/>
+          </p:cNvSpPr>
+          <p:nvPr/>
+        </p:nvSpPr>
+        <p:spPr>
+          <a:xfrm xmlns:a="http://schemas.openxmlformats.org/drawingml/2006/main">
+            <a:off x="609600" y="428625"/>
+            <a:ext cx="10953750" cy="952500"/>
+          </a:xfrm>
+          <a:prstGeom xmlns:a="http://schemas.openxmlformats.org/drawingml/2006/main" prst="rect">
+            <a:avLst/>
+          </a:prstGeom>
+          <a:noFill xmlns:a="http://schemas.openxmlformats.org/drawingml/2006/main"/>
+          <a:ln xmlns:a="http://schemas.openxmlformats.org/drawingml/2006/main" w="0">
+            <a:noFill/>
+            <a:prstDash val="solid"/>
+          </a:ln>
+        </p:spPr>
+        <p:txBody>
+          <a:bodyPr xmlns:a="http://schemas.openxmlformats.org/drawingml/2006/main"/>
+          <a:lstStyle xmlns:a="http://schemas.openxmlformats.org/drawingml/2006/main">
+            <a:defPPr>
+              <a:defRPr sz="3600" b="1">
+                <a:solidFill>
+                  <a:srgbClr val="112A3A"/>
+                </a:solidFill>
+                <a:latin typeface="DejaVu Sans"/>
+                <a:ea typeface="DejaVu Sans"/>
+                <a:cs typeface="DejaVu Sans"/>
+              </a:defRPr>
+            </a:defPPr>
+            <a:lvl1pPr>
+              <a:defRPr sz="3600" b="1">
+                <a:solidFill>
+                  <a:srgbClr val="112A3A"/>
+                </a:solidFill>
+                <a:latin typeface="DejaVu Sans"/>
+                <a:ea typeface="DejaVu Sans"/>
+                <a:cs typeface="DejaVu Sans"/>
+              </a:defRPr>
+            </a:lvl1pPr>
+            <a:lvl2pPr>
+              <a:defRPr sz="3600" b="1">
+                <a:solidFill>
+                  <a:srgbClr val="112A3A"/>
+                </a:solidFill>
+                <a:latin typeface="DejaVu Sans"/>
+                <a:ea typeface="DejaVu Sans"/>
+                <a:cs typeface="DejaVu Sans"/>
+              </a:defRPr>
+            </a:lvl2pPr>
+            <a:lvl3pPr>
+              <a:defRPr sz="3600" b="1">
+                <a:solidFill>
+                  <a:srgbClr val="112A3A"/>
+                </a:solidFill>
+                <a:latin typeface="DejaVu Sans"/>
+                <a:ea typeface="DejaVu Sans"/>
+                <a:cs typeface="DejaVu Sans"/>
+              </a:defRPr>
+            </a:lvl3pPr>
+            <a:lvl4pPr>
+              <a:defRPr sz="3600" b="1">
+                <a:solidFill>
+                  <a:srgbClr val="112A3A"/>
+                </a:solidFill>
+                <a:latin typeface="DejaVu Sans"/>
+                <a:ea typeface="DejaVu Sans"/>
+                <a:cs typeface="DejaVu Sans"/>
+              </a:defRPr>
+            </a:lvl4pPr>
+            <a:lvl5pPr>
+              <a:defRPr sz="3600" b="1">
+                <a:solidFill>
+                  <a:srgbClr val="112A3A"/>
+                </a:solidFill>
+                <a:latin typeface="DejaVu Sans"/>
+                <a:ea typeface="DejaVu Sans"/>
+                <a:cs typeface="DejaVu Sans"/>
+              </a:defRPr>
+            </a:lvl5pPr>
+            <a:lvl6pPr>
+              <a:defRPr sz="3600" b="1">
+                <a:solidFill>
+                  <a:srgbClr val="112A3A"/>
+                </a:solidFill>
+                <a:latin typeface="DejaVu Sans"/>
+                <a:ea typeface="DejaVu Sans"/>
+                <a:cs typeface="DejaVu Sans"/>
+              </a:defRPr>
+            </a:lvl6pPr>
+            <a:lvl7pPr>
+              <a:defRPr sz="3600" b="1">
+                <a:solidFill>
+                  <a:srgbClr val="112A3A"/>
+                </a:solidFill>
+                <a:latin typeface="DejaVu Sans"/>
+                <a:ea typeface="DejaVu Sans"/>
+                <a:cs typeface="DejaVu Sans"/>
+              </a:defRPr>
+            </a:lvl7pPr>
+            <a:lvl8pPr>
+              <a:defRPr sz="3600" b="1">
+                <a:solidFill>
+                  <a:srgbClr val="112A3A"/>
+                </a:solidFill>
+                <a:latin typeface="DejaVu Sans"/>
+                <a:ea typeface="DejaVu Sans"/>
+                <a:cs typeface="DejaVu Sans"/>
+              </a:defRPr>
+            </a:lvl8pPr>
+            <a:lvl9pPr>
+              <a:defRPr sz="3600" b="1">
+                <a:solidFill>
+                  <a:srgbClr val="112A3A"/>
+                </a:solidFill>
+                <a:latin typeface="DejaVu Sans"/>
+                <a:ea typeface="DejaVu Sans"/>
+                <a:cs typeface="DejaVu Sans"/>
+              </a:defRPr>
+            </a:lvl9pPr>
+          </a:lstStyle>
+          <a:p xmlns:a="http://schemas.openxmlformats.org/drawingml/2006/main">
+            <a:pPr>
+              <a:defRPr sz="3600" b="1">
+                <a:solidFill>
+                  <a:srgbClr val="112A3A"/>
+                </a:solidFill>
+                <a:latin typeface="DejaVu Sans"/>
+                <a:ea typeface="DejaVu Sans"/>
+                <a:cs typeface="DejaVu Sans"/>
+              </a:defRPr>
+            </a:pPr>
+            <a:r>
+              <a:rPr sz="3600" b="1">
+                <a:solidFill>
+                  <a:srgbClr val="112A3A"/>
+                </a:solidFill>
+                <a:latin typeface="DejaVu Sans"/>
+                <a:ea typeface="DejaVu Sans"/>
+                <a:cs typeface="DejaVu Sans"/>
+              </a:rPr>
+              <a:t>Para finalizar</a:t>
+            </a:r>
+          </a:p>
+        </p:txBody>
+      </p:sp>
+      <p:sp>
+        <p:nvSpPr>
+          <p:cNvPr id="2" name="closing-statement">
+            <a:extLst xmlns:a="http://schemas.openxmlformats.org/drawingml/2006/main">
+              <a:ext uri="{FF2B5EF4-FFF2-40B4-BE49-F238E27FC236}">
+                <a16:creationId xmlns:a16="http://schemas.microsoft.com/office/drawing/2014/main" id="{777CE9EA-FBE8-4C7B-BEDA-5B7FDF0EA88E}"/>
+              </a:ext>
+            </a:extLst>
+          </p:cNvPr>
+          <p:cNvSpPr>
+            <a:spLocks xmlns:a="http://schemas.openxmlformats.org/drawingml/2006/main" noGrp="1"/>
+          </p:cNvSpPr>
+          <p:nvPr/>
+        </p:nvSpPr>
+        <p:spPr>
+          <a:xfrm xmlns:a="http://schemas.openxmlformats.org/drawingml/2006/main">
+            <a:off x="609600" y="1924050"/>
+            <a:ext cx="10668000" cy="838200"/>
+          </a:xfrm>
+          <a:prstGeom xmlns:a="http://schemas.openxmlformats.org/drawingml/2006/main" prst="rect">
+            <a:avLst/>
+          </a:prstGeom>
+          <a:noFill xmlns:a="http://schemas.openxmlformats.org/drawingml/2006/main"/>
+          <a:ln xmlns:a="http://schemas.openxmlformats.org/drawingml/2006/main" w="0">
+            <a:noFill/>
+            <a:prstDash val="solid"/>
+          </a:ln>
+        </p:spPr>
+        <p:txBody>
+          <a:bodyPr xmlns:a="http://schemas.openxmlformats.org/drawingml/2006/main"/>
+          <a:lstStyle xmlns:a="http://schemas.openxmlformats.org/drawingml/2006/main">
+            <a:defPPr>
+              <a:defRPr sz="3150" b="1">
+                <a:solidFill>
+                  <a:srgbClr val="00888A"/>
+                </a:solidFill>
+                <a:latin typeface="DejaVu Sans"/>
+                <a:ea typeface="DejaVu Sans"/>
+                <a:cs typeface="DejaVu Sans"/>
+              </a:defRPr>
+            </a:defPPr>
+            <a:lvl1pPr>
+              <a:defRPr sz="3150" b="1">
+                <a:solidFill>
+                  <a:srgbClr val="00888A"/>
+                </a:solidFill>
+                <a:latin typeface="DejaVu Sans"/>
+                <a:ea typeface="DejaVu Sans"/>
+                <a:cs typeface="DejaVu Sans"/>
+              </a:defRPr>
+            </a:lvl1pPr>
+            <a:lvl2pPr>
+              <a:defRPr sz="3150" b="1">
+                <a:solidFill>
+                  <a:srgbClr val="00888A"/>
+                </a:solidFill>
+                <a:latin typeface="DejaVu Sans"/>
+                <a:ea typeface="DejaVu Sans"/>
+                <a:cs typeface="DejaVu Sans"/>
+              </a:defRPr>
+            </a:lvl2pPr>
+            <a:lvl3pPr>
+              <a:defRPr sz="3150" b="1">
+                <a:solidFill>
+                  <a:srgbClr val="00888A"/>
+                </a:solidFill>
+                <a:latin typeface="DejaVu Sans"/>
+                <a:ea typeface="DejaVu Sans"/>
+                <a:cs typeface="DejaVu Sans"/>
+              </a:defRPr>
+            </a:lvl3pPr>
+            <a:lvl4pPr>
+              <a:defRPr sz="3150" b="1">
+                <a:solidFill>
+                  <a:srgbClr val="00888A"/>
+                </a:solidFill>
+                <a:latin typeface="DejaVu Sans"/>
+                <a:ea typeface="DejaVu Sans"/>
+                <a:cs typeface="DejaVu Sans"/>
+              </a:defRPr>
+            </a:lvl4pPr>
+            <a:lvl5pPr>
+              <a:defRPr sz="3150" b="1">
+                <a:solidFill>
+                  <a:srgbClr val="00888A"/>
+                </a:solidFill>
+                <a:latin typeface="DejaVu Sans"/>
+                <a:ea typeface="DejaVu Sans"/>
+                <a:cs typeface="DejaVu Sans"/>
+              </a:defRPr>
+            </a:lvl5pPr>
+            <a:lvl6pPr>
+              <a:defRPr sz="3150" b="1">
+                <a:solidFill>
+                  <a:srgbClr val="00888A"/>
+                </a:solidFill>
+                <a:latin typeface="DejaVu Sans"/>
+                <a:ea typeface="DejaVu Sans"/>
+                <a:cs typeface="DejaVu Sans"/>
+              </a:defRPr>
+            </a:lvl6pPr>
+            <a:lvl7pPr>
+              <a:defRPr sz="3150" b="1">
+                <a:solidFill>
+                  <a:srgbClr val="00888A"/>
+                </a:solidFill>
+                <a:latin typeface="DejaVu Sans"/>
+                <a:ea typeface="DejaVu Sans"/>
+                <a:cs typeface="DejaVu Sans"/>
+              </a:defRPr>
+            </a:lvl7pPr>
+            <a:lvl8pPr>
+              <a:defRPr sz="3150" b="1">
+                <a:solidFill>
+                  <a:srgbClr val="00888A"/>
+                </a:solidFill>
+                <a:latin typeface="DejaVu Sans"/>
+                <a:ea typeface="DejaVu Sans"/>
+                <a:cs typeface="DejaVu Sans"/>
+              </a:defRPr>
+            </a:lvl8pPr>
+            <a:lvl9pPr>
+              <a:defRPr sz="3150" b="1">
+                <a:solidFill>
+                  <a:srgbClr val="00888A"/>
+                </a:solidFill>
+                <a:latin typeface="DejaVu Sans"/>
+                <a:ea typeface="DejaVu Sans"/>
+                <a:cs typeface="DejaVu Sans"/>
+              </a:defRPr>
+            </a:lvl9pPr>
+          </a:lstStyle>
+          <a:p xmlns:a="http://schemas.openxmlformats.org/drawingml/2006/main">
+            <a:pPr>
+              <a:defRPr sz="3150" b="1">
+                <a:solidFill>
+                  <a:srgbClr val="00888A"/>
+                </a:solidFill>
+                <a:latin typeface="DejaVu Sans"/>
+                <a:ea typeface="DejaVu Sans"/>
+                <a:cs typeface="DejaVu Sans"/>
+              </a:defRPr>
+            </a:pPr>
+            <a:r>
+              <a:rPr sz="3150" b="1">
+                <a:solidFill>
+                  <a:srgbClr val="00888A"/>
+                </a:solidFill>
+                <a:latin typeface="DejaVu Sans"/>
+                <a:ea typeface="DejaVu Sans"/>
+                <a:cs typeface="DejaVu Sans"/>
+              </a:rPr>
+              <a:t>Continuidad con alternativas y control</a:t>
+            </a:r>
+          </a:p>
+        </p:txBody>
+      </p:sp>
+      <p:sp>
+        <p:nvSpPr>
+          <p:cNvPr id="3" name="closing-body">
+            <a:extLst xmlns:a="http://schemas.openxmlformats.org/drawingml/2006/main">
+              <a:ext uri="{FF2B5EF4-FFF2-40B4-BE49-F238E27FC236}">
+                <a16:creationId xmlns:a16="http://schemas.microsoft.com/office/drawing/2014/main" id="{E61E9815-14B6-4414-A1AE-DD61E472DFBC}"/>
+              </a:ext>
+            </a:extLst>
+          </p:cNvPr>
+          <p:cNvSpPr>
+            <a:spLocks xmlns:a="http://schemas.openxmlformats.org/drawingml/2006/main" noGrp="1"/>
+          </p:cNvSpPr>
+          <p:nvPr/>
+        </p:nvSpPr>
+        <p:spPr>
+          <a:xfrm xmlns:a="http://schemas.openxmlformats.org/drawingml/2006/main">
+            <a:off x="609600" y="3095625"/>
+            <a:ext cx="10477500" cy="1381125"/>
+          </a:xfrm>
+          <a:prstGeom xmlns:a="http://schemas.openxmlformats.org/drawingml/2006/main" prst="rect">
+            <a:avLst/>
+          </a:prstGeom>
+          <a:noFill xmlns:a="http://schemas.openxmlformats.org/drawingml/2006/main"/>
+          <a:ln xmlns:a="http://schemas.openxmlformats.org/drawingml/2006/main" w="0">
+            <a:noFill/>
+            <a:prstDash val="solid"/>
+          </a:ln>
+        </p:spPr>
+        <p:txBody>
+          <a:bodyPr xmlns:a="http://schemas.openxmlformats.org/drawingml/2006/main"/>
+          <a:lstStyle xmlns:a="http://schemas.openxmlformats.org/drawingml/2006/main">
+            <a:defPPr>
+              <a:defRPr sz="2250" b="0">
+                <a:solidFill>
+                  <a:srgbClr val="112A3A"/>
+                </a:solidFill>
+                <a:latin typeface="DejaVu Sans"/>
+                <a:ea typeface="DejaVu Sans"/>
+                <a:cs typeface="DejaVu Sans"/>
+              </a:defRPr>
+            </a:defPPr>
+            <a:lvl1pPr>
+              <a:defRPr sz="2250" b="0">
+                <a:solidFill>
+                  <a:srgbClr val="112A3A"/>
+                </a:solidFill>
+                <a:latin typeface="DejaVu Sans"/>
+                <a:ea typeface="DejaVu Sans"/>
+                <a:cs typeface="DejaVu Sans"/>
+              </a:defRPr>
+            </a:lvl1pPr>
+            <a:lvl2pPr>
+              <a:defRPr sz="2250" b="0">
+                <a:solidFill>
+                  <a:srgbClr val="112A3A"/>
+                </a:solidFill>
+                <a:latin typeface="DejaVu Sans"/>
+                <a:ea typeface="DejaVu Sans"/>
+                <a:cs typeface="DejaVu Sans"/>
+              </a:defRPr>
+            </a:lvl2pPr>
+            <a:lvl3pPr>
+              <a:defRPr sz="2250" b="0">
+                <a:solidFill>
+                  <a:srgbClr val="112A3A"/>
+                </a:solidFill>
+                <a:latin typeface="DejaVu Sans"/>
+                <a:ea typeface="DejaVu Sans"/>
+                <a:cs typeface="DejaVu Sans"/>
+              </a:defRPr>
+            </a:lvl3pPr>
+            <a:lvl4pPr>
+              <a:defRPr sz="2250" b="0">
+                <a:solidFill>
+                  <a:srgbClr val="112A3A"/>
+                </a:solidFill>
+                <a:latin typeface="DejaVu Sans"/>
+                <a:ea typeface="DejaVu Sans"/>
+                <a:cs typeface="DejaVu Sans"/>
+              </a:defRPr>
+            </a:lvl4pPr>
+            <a:lvl5pPr>
+              <a:defRPr sz="2250" b="0">
+                <a:solidFill>
+                  <a:srgbClr val="112A3A"/>
+                </a:solidFill>
+                <a:latin typeface="DejaVu Sans"/>
+                <a:ea typeface="DejaVu Sans"/>
+                <a:cs typeface="DejaVu Sans"/>
+              </a:defRPr>
+            </a:lvl5pPr>
+            <a:lvl6pPr>
+              <a:defRPr sz="2250" b="0">
+                <a:solidFill>
+                  <a:srgbClr val="112A3A"/>
+                </a:solidFill>
+                <a:latin typeface="DejaVu Sans"/>
+                <a:ea typeface="DejaVu Sans"/>
+                <a:cs typeface="DejaVu Sans"/>
+              </a:defRPr>
+            </a:lvl6pPr>
+            <a:lvl7pPr>
+              <a:defRPr sz="2250" b="0">
+                <a:solidFill>
+                  <a:srgbClr val="112A3A"/>
+                </a:solidFill>
+                <a:latin typeface="DejaVu Sans"/>
+                <a:ea typeface="DejaVu Sans"/>
+                <a:cs typeface="DejaVu Sans"/>
+              </a:defRPr>
+            </a:lvl7pPr>
+            <a:lvl8pPr>
+              <a:defRPr sz="2250" b="0">
+                <a:solidFill>
+                  <a:srgbClr val="112A3A"/>
+                </a:solidFill>
+                <a:latin typeface="DejaVu Sans"/>
+                <a:ea typeface="DejaVu Sans"/>
+                <a:cs typeface="DejaVu Sans"/>
+              </a:defRPr>
+            </a:lvl8pPr>
+            <a:lvl9pPr>
+              <a:defRPr sz="2250" b="0">
+                <a:solidFill>
+                  <a:srgbClr val="112A3A"/>
+                </a:solidFill>
+                <a:latin typeface="DejaVu Sans"/>
+                <a:ea typeface="DejaVu Sans"/>
+                <a:cs typeface="DejaVu Sans"/>
+              </a:defRPr>
+            </a:lvl9pPr>
+          </a:lstStyle>
+          <a:p xmlns:a="http://schemas.openxmlformats.org/drawingml/2006/main">
+            <a:pPr>
+              <a:defRPr sz="2250" b="0">
+                <a:solidFill>
+                  <a:srgbClr val="112A3A"/>
+                </a:solidFill>
+                <a:latin typeface="DejaVu Sans"/>
+                <a:ea typeface="DejaVu Sans"/>
+                <a:cs typeface="DejaVu Sans"/>
+              </a:defRPr>
+            </a:pPr>
+            <a:r>
+              <a:rPr sz="2250" b="0">
+                <a:solidFill>
+                  <a:srgbClr val="112A3A"/>
+                </a:solidFill>
+                <a:latin typeface="DejaVu Sans"/>
+                <a:ea typeface="DejaVu Sans"/>
+                <a:cs typeface="DejaVu Sans"/>
+              </a:rPr>
+              <a:t>La propuesta busca sostener la atención con caminos alternativos, permisos por servicio y recuperación condicionada de los sistemas centrales.</a:t>
+            </a:r>
+          </a:p>
+        </p:txBody>
+      </p:sp>
+      <p:sp>
+        <p:nvSpPr>
+          <p:cNvPr id="4" name="closing-scope">
+            <a:extLst xmlns:a="http://schemas.openxmlformats.org/drawingml/2006/main">
+              <a:ext uri="{FF2B5EF4-FFF2-40B4-BE49-F238E27FC236}">
+                <a16:creationId xmlns:a16="http://schemas.microsoft.com/office/drawing/2014/main" id="{C6E1F466-672D-45D3-869E-DF623654E6F5}"/>
+              </a:ext>
+            </a:extLst>
+          </p:cNvPr>
+          <p:cNvSpPr>
+            <a:spLocks xmlns:a="http://schemas.openxmlformats.org/drawingml/2006/main" noGrp="1"/>
+          </p:cNvSpPr>
+          <p:nvPr/>
+        </p:nvSpPr>
+        <p:spPr>
+          <a:xfrm xmlns:a="http://schemas.openxmlformats.org/drawingml/2006/main">
+            <a:off x="609600" y="4857750"/>
+            <a:ext cx="10572750" cy="523875"/>
+          </a:xfrm>
+          <a:prstGeom xmlns:a="http://schemas.openxmlformats.org/drawingml/2006/main" prst="rect">
+            <a:avLst/>
+          </a:prstGeom>
+          <a:noFill xmlns:a="http://schemas.openxmlformats.org/drawingml/2006/main"/>
+          <a:ln xmlns:a="http://schemas.openxmlformats.org/drawingml/2006/main" w="0">
+            <a:noFill/>
+            <a:prstDash val="solid"/>
+          </a:ln>
+        </p:spPr>
+        <p:txBody>
+          <a:bodyPr xmlns:a="http://schemas.openxmlformats.org/drawingml/2006/main"/>
+          <a:lstStyle xmlns:a="http://schemas.openxmlformats.org/drawingml/2006/main">
+            <a:defPPr>
+              <a:defRPr sz="2025" b="0">
+                <a:solidFill>
+                  <a:srgbClr val="112A3A"/>
+                </a:solidFill>
+                <a:latin typeface="DejaVu Sans"/>
+                <a:ea typeface="DejaVu Sans"/>
+                <a:cs typeface="DejaVu Sans"/>
+              </a:defRPr>
+            </a:defPPr>
+            <a:lvl1pPr>
+              <a:defRPr sz="2025" b="0">
+                <a:solidFill>
+                  <a:srgbClr val="112A3A"/>
+                </a:solidFill>
+                <a:latin typeface="DejaVu Sans"/>
+                <a:ea typeface="DejaVu Sans"/>
+                <a:cs typeface="DejaVu Sans"/>
+              </a:defRPr>
+            </a:lvl1pPr>
+            <a:lvl2pPr>
+              <a:defRPr sz="2025" b="0">
+                <a:solidFill>
+                  <a:srgbClr val="112A3A"/>
+                </a:solidFill>
+                <a:latin typeface="DejaVu Sans"/>
+                <a:ea typeface="DejaVu Sans"/>
+                <a:cs typeface="DejaVu Sans"/>
+              </a:defRPr>
+            </a:lvl2pPr>
+            <a:lvl3pPr>
+              <a:defRPr sz="2025" b="0">
+                <a:solidFill>
+                  <a:srgbClr val="112A3A"/>
+                </a:solidFill>
+                <a:latin typeface="DejaVu Sans"/>
+                <a:ea typeface="DejaVu Sans"/>
+                <a:cs typeface="DejaVu Sans"/>
+              </a:defRPr>
+            </a:lvl3pPr>
+            <a:lvl4pPr>
+              <a:defRPr sz="2025" b="0">
+                <a:solidFill>
+                  <a:srgbClr val="112A3A"/>
+                </a:solidFill>
+                <a:latin typeface="DejaVu Sans"/>
+                <a:ea typeface="DejaVu Sans"/>
+                <a:cs typeface="DejaVu Sans"/>
+              </a:defRPr>
+            </a:lvl4pPr>
+            <a:lvl5pPr>
+              <a:defRPr sz="2025" b="0">
+                <a:solidFill>
+                  <a:srgbClr val="112A3A"/>
+                </a:solidFill>
+                <a:latin typeface="DejaVu Sans"/>
+                <a:ea typeface="DejaVu Sans"/>
+                <a:cs typeface="DejaVu Sans"/>
+              </a:defRPr>
+            </a:lvl5pPr>
+            <a:lvl6pPr>
+              <a:defRPr sz="2025" b="0">
+                <a:solidFill>
+                  <a:srgbClr val="112A3A"/>
+                </a:solidFill>
+                <a:latin typeface="DejaVu Sans"/>
+                <a:ea typeface="DejaVu Sans"/>
+                <a:cs typeface="DejaVu Sans"/>
+              </a:defRPr>
+            </a:lvl6pPr>
+            <a:lvl7pPr>
+              <a:defRPr sz="2025" b="0">
+                <a:solidFill>
+                  <a:srgbClr val="112A3A"/>
+                </a:solidFill>
+                <a:latin typeface="DejaVu Sans"/>
+                <a:ea typeface="DejaVu Sans"/>
+                <a:cs typeface="DejaVu Sans"/>
+              </a:defRPr>
+            </a:lvl7pPr>
+            <a:lvl8pPr>
+              <a:defRPr sz="2025" b="0">
+                <a:solidFill>
+                  <a:srgbClr val="112A3A"/>
+                </a:solidFill>
+                <a:latin typeface="DejaVu Sans"/>
+                <a:ea typeface="DejaVu Sans"/>
+                <a:cs typeface="DejaVu Sans"/>
+              </a:defRPr>
+            </a:lvl8pPr>
+            <a:lvl9pPr>
+              <a:defRPr sz="2025" b="0">
+                <a:solidFill>
+                  <a:srgbClr val="112A3A"/>
+                </a:solidFill>
+                <a:latin typeface="DejaVu Sans"/>
+                <a:ea typeface="DejaVu Sans"/>
+                <a:cs typeface="DejaVu Sans"/>
+              </a:defRPr>
+            </a:lvl9pPr>
+          </a:lstStyle>
+          <a:p xmlns:a="http://schemas.openxmlformats.org/drawingml/2006/main">
+            <a:pPr>
+              <a:defRPr sz="2025" b="0">
+                <a:solidFill>
+                  <a:srgbClr val="112A3A"/>
+                </a:solidFill>
+                <a:latin typeface="DejaVu Sans"/>
+                <a:ea typeface="DejaVu Sans"/>
+                <a:cs typeface="DejaVu Sans"/>
+              </a:defRPr>
+            </a:pPr>
+            <a:r>
+              <a:rPr sz="2025" b="0">
+                <a:solidFill>
+                  <a:srgbClr val="112A3A"/>
+                </a:solidFill>
+                <a:latin typeface="DejaVu Sans"/>
+                <a:ea typeface="DejaVu Sans"/>
+                <a:cs typeface="DejaVu Sans"/>
+              </a:rPr>
+              <a:t>23 sedes · 650 puestos · alternativas A y B</a:t>
+            </a:r>
+          </a:p>
+        </p:txBody>
+      </p:sp>
+      <p:sp>
+        <p:nvSpPr>
+          <p:cNvPr id="5" name="closing-questions">
+            <a:extLst xmlns:a="http://schemas.openxmlformats.org/drawingml/2006/main">
+              <a:ext uri="{FF2B5EF4-FFF2-40B4-BE49-F238E27FC236}">
+                <a16:creationId xmlns:a16="http://schemas.microsoft.com/office/drawing/2014/main" id="{225DF9F7-0582-4F24-AFE8-05AE603CD844}"/>
+              </a:ext>
+            </a:extLst>
+          </p:cNvPr>
+          <p:cNvSpPr>
+            <a:spLocks xmlns:a="http://schemas.openxmlformats.org/drawingml/2006/main" noGrp="1"/>
+          </p:cNvSpPr>
+          <p:nvPr/>
+        </p:nvSpPr>
+        <p:spPr>
+          <a:xfrm xmlns:a="http://schemas.openxmlformats.org/drawingml/2006/main">
+            <a:off x="609600" y="5819775"/>
+            <a:ext cx="10668000" cy="476250"/>
+          </a:xfrm>
+          <a:prstGeom xmlns:a="http://schemas.openxmlformats.org/drawingml/2006/main" prst="rect">
+            <a:avLst/>
+          </a:prstGeom>
+          <a:noFill xmlns:a="http://schemas.openxmlformats.org/drawingml/2006/main"/>
+          <a:ln xmlns:a="http://schemas.openxmlformats.org/drawingml/2006/main" w="0">
+            <a:noFill/>
+            <a:prstDash val="solid"/>
+          </a:ln>
+        </p:spPr>
+        <p:txBody>
+          <a:bodyPr xmlns:a="http://schemas.openxmlformats.org/drawingml/2006/main"/>
+          <a:lstStyle xmlns:a="http://schemas.openxmlformats.org/drawingml/2006/main">
+            <a:defPPr>
+              <a:defRPr sz="1800" b="0">
+                <a:solidFill>
+                  <a:srgbClr val="112A3A"/>
+                </a:solidFill>
+                <a:latin typeface="DejaVu Sans"/>
+                <a:ea typeface="DejaVu Sans"/>
+                <a:cs typeface="DejaVu Sans"/>
+              </a:defRPr>
+            </a:defPPr>
+            <a:lvl1pPr>
+              <a:defRPr sz="1800" b="0">
+                <a:solidFill>
+                  <a:srgbClr val="112A3A"/>
+                </a:solidFill>
+                <a:latin typeface="DejaVu Sans"/>
+                <a:ea typeface="DejaVu Sans"/>
+                <a:cs typeface="DejaVu Sans"/>
+              </a:defRPr>
+            </a:lvl1pPr>
+            <a:lvl2pPr>
+              <a:defRPr sz="1800" b="0">
+                <a:solidFill>
+                  <a:srgbClr val="112A3A"/>
+                </a:solidFill>
+                <a:latin typeface="DejaVu Sans"/>
+                <a:ea typeface="DejaVu Sans"/>
+                <a:cs typeface="DejaVu Sans"/>
+              </a:defRPr>
+            </a:lvl2pPr>
+            <a:lvl3pPr>
+              <a:defRPr sz="1800" b="0">
+                <a:solidFill>
+                  <a:srgbClr val="112A3A"/>
+                </a:solidFill>
+                <a:latin typeface="DejaVu Sans"/>
+                <a:ea typeface="DejaVu Sans"/>
+                <a:cs typeface="DejaVu Sans"/>
+              </a:defRPr>
+            </a:lvl3pPr>
+            <a:lvl4pPr>
+              <a:defRPr sz="1800" b="0">
+                <a:solidFill>
+                  <a:srgbClr val="112A3A"/>
+                </a:solidFill>
+                <a:latin typeface="DejaVu Sans"/>
+                <a:ea typeface="DejaVu Sans"/>
+                <a:cs typeface="DejaVu Sans"/>
+              </a:defRPr>
+            </a:lvl4pPr>
+            <a:lvl5pPr>
+              <a:defRPr sz="1800" b="0">
+                <a:solidFill>
+                  <a:srgbClr val="112A3A"/>
+                </a:solidFill>
+                <a:latin typeface="DejaVu Sans"/>
+                <a:ea typeface="DejaVu Sans"/>
+                <a:cs typeface="DejaVu Sans"/>
+              </a:defRPr>
+            </a:lvl5pPr>
+            <a:lvl6pPr>
+              <a:defRPr sz="1800" b="0">
+                <a:solidFill>
+                  <a:srgbClr val="112A3A"/>
+                </a:solidFill>
+                <a:latin typeface="DejaVu Sans"/>
+                <a:ea typeface="DejaVu Sans"/>
+                <a:cs typeface="DejaVu Sans"/>
+              </a:defRPr>
+            </a:lvl6pPr>
+            <a:lvl7pPr>
+              <a:defRPr sz="1800" b="0">
+                <a:solidFill>
+                  <a:srgbClr val="112A3A"/>
+                </a:solidFill>
+                <a:latin typeface="DejaVu Sans"/>
+                <a:ea typeface="DejaVu Sans"/>
+                <a:cs typeface="DejaVu Sans"/>
+              </a:defRPr>
+            </a:lvl7pPr>
+            <a:lvl8pPr>
+              <a:defRPr sz="1800" b="0">
+                <a:solidFill>
+                  <a:srgbClr val="112A3A"/>
+                </a:solidFill>
+                <a:latin typeface="DejaVu Sans"/>
+                <a:ea typeface="DejaVu Sans"/>
+                <a:cs typeface="DejaVu Sans"/>
+              </a:defRPr>
+            </a:lvl8pPr>
+            <a:lvl9pPr>
+              <a:defRPr sz="1800" b="0">
+                <a:solidFill>
+                  <a:srgbClr val="112A3A"/>
+                </a:solidFill>
+                <a:latin typeface="DejaVu Sans"/>
+                <a:ea typeface="DejaVu Sans"/>
+                <a:cs typeface="DejaVu Sans"/>
+              </a:defRPr>
+            </a:lvl9pPr>
+          </a:lstStyle>
+          <a:p xmlns:a="http://schemas.openxmlformats.org/drawingml/2006/main">
+            <a:pPr>
+              <a:defRPr sz="1800" b="0">
+                <a:solidFill>
+                  <a:srgbClr val="112A3A"/>
+                </a:solidFill>
+                <a:latin typeface="DejaVu Sans"/>
+                <a:ea typeface="DejaVu Sans"/>
+                <a:cs typeface="DejaVu Sans"/>
+              </a:defRPr>
+            </a:pPr>
+            <a:r>
+              <a:rPr sz="1800" b="0">
+                <a:solidFill>
+                  <a:srgbClr val="112A3A"/>
+                </a:solidFill>
+                <a:latin typeface="DejaVu Sans"/>
+                <a:ea typeface="DejaVu Sans"/>
+                <a:cs typeface="DejaVu Sans"/>
+              </a:rPr>
+              <a:t>Muchas gracias. Preguntas y demostración del simulador.</a:t>
+            </a:r>
+          </a:p>
+        </p:txBody>
+      </p:sp>
+      <p:sp>
+        <p:nvSpPr>
+          <p:cNvPr id="6" name="closing-number">
+            <a:extLst xmlns:a="http://schemas.openxmlformats.org/drawingml/2006/main">
+              <a:ext uri="{FF2B5EF4-FFF2-40B4-BE49-F238E27FC236}">
+                <a16:creationId xmlns:a16="http://schemas.microsoft.com/office/drawing/2014/main" id="{3370B82D-7EE5-4225-8E2E-231FD3F38DE5}"/>
+              </a:ext>
+            </a:extLst>
+          </p:cNvPr>
+          <p:cNvSpPr>
+            <a:spLocks xmlns:a="http://schemas.openxmlformats.org/drawingml/2006/main" noGrp="1"/>
+          </p:cNvSpPr>
+          <p:nvPr/>
+        </p:nvSpPr>
+        <p:spPr>
+          <a:xfrm xmlns:a="http://schemas.openxmlformats.org/drawingml/2006/main">
+            <a:off x="11287125" y="6353175"/>
+            <a:ext cx="476250" cy="238125"/>
+          </a:xfrm>
+          <a:prstGeom xmlns:a="http://schemas.openxmlformats.org/drawingml/2006/main" prst="rect">
+            <a:avLst/>
+          </a:prstGeom>
+          <a:noFill xmlns:a="http://schemas.openxmlformats.org/drawingml/2006/main"/>
+          <a:ln xmlns:a="http://schemas.openxmlformats.org/drawingml/2006/main" w="0">
+            <a:noFill/>
+            <a:prstDash val="solid"/>
+          </a:ln>
+        </p:spPr>
+        <p:txBody>
+          <a:bodyPr xmlns:a="http://schemas.openxmlformats.org/drawingml/2006/main"/>
+          <a:lstStyle xmlns:a="http://schemas.openxmlformats.org/drawingml/2006/main">
+            <a:defPPr>
+              <a:defRPr sz="1350" b="0">
+                <a:solidFill>
+                  <a:srgbClr val="456278"/>
+                </a:solidFill>
+                <a:latin typeface="DejaVu Sans"/>
+                <a:ea typeface="DejaVu Sans"/>
+                <a:cs typeface="DejaVu Sans"/>
+              </a:defRPr>
+            </a:defPPr>
+            <a:lvl1pPr>
+              <a:defRPr sz="1350" b="0">
+                <a:solidFill>
+                  <a:srgbClr val="456278"/>
+                </a:solidFill>
+                <a:latin typeface="DejaVu Sans"/>
+                <a:ea typeface="DejaVu Sans"/>
+                <a:cs typeface="DejaVu Sans"/>
+              </a:defRPr>
+            </a:lvl1pPr>
+            <a:lvl2pPr>
+              <a:defRPr sz="1350" b="0">
+                <a:solidFill>
+                  <a:srgbClr val="456278"/>
+                </a:solidFill>
+                <a:latin typeface="DejaVu Sans"/>
+                <a:ea typeface="DejaVu Sans"/>
+                <a:cs typeface="DejaVu Sans"/>
+              </a:defRPr>
+            </a:lvl2pPr>
+            <a:lvl3pPr>
+              <a:defRPr sz="1350" b="0">
+                <a:solidFill>
+                  <a:srgbClr val="456278"/>
+                </a:solidFill>
+                <a:latin typeface="DejaVu Sans"/>
+                <a:ea typeface="DejaVu Sans"/>
+                <a:cs typeface="DejaVu Sans"/>
+              </a:defRPr>
+            </a:lvl3pPr>
+            <a:lvl4pPr>
+              <a:defRPr sz="1350" b="0">
+                <a:solidFill>
+                  <a:srgbClr val="456278"/>
+                </a:solidFill>
+                <a:latin typeface="DejaVu Sans"/>
+                <a:ea typeface="DejaVu Sans"/>
+                <a:cs typeface="DejaVu Sans"/>
+              </a:defRPr>
+            </a:lvl4pPr>
+            <a:lvl5pPr>
+              <a:defRPr sz="1350" b="0">
+                <a:solidFill>
+                  <a:srgbClr val="456278"/>
+                </a:solidFill>
+                <a:latin typeface="DejaVu Sans"/>
+                <a:ea typeface="DejaVu Sans"/>
+                <a:cs typeface="DejaVu Sans"/>
+              </a:defRPr>
+            </a:lvl5pPr>
+            <a:lvl6pPr>
+              <a:defRPr sz="1350" b="0">
+                <a:solidFill>
+                  <a:srgbClr val="456278"/>
+                </a:solidFill>
+                <a:latin typeface="DejaVu Sans"/>
+                <a:ea typeface="DejaVu Sans"/>
+                <a:cs typeface="DejaVu Sans"/>
+              </a:defRPr>
+            </a:lvl6pPr>
+            <a:lvl7pPr>
+              <a:defRPr sz="1350" b="0">
+                <a:solidFill>
+                  <a:srgbClr val="456278"/>
+                </a:solidFill>
+                <a:latin typeface="DejaVu Sans"/>
+                <a:ea typeface="DejaVu Sans"/>
+                <a:cs typeface="DejaVu Sans"/>
+              </a:defRPr>
+            </a:lvl7pPr>
+            <a:lvl8pPr>
+              <a:defRPr sz="1350" b="0">
+                <a:solidFill>
+                  <a:srgbClr val="456278"/>
+                </a:solidFill>
+                <a:latin typeface="DejaVu Sans"/>
+                <a:ea typeface="DejaVu Sans"/>
+                <a:cs typeface="DejaVu Sans"/>
+              </a:defRPr>
+            </a:lvl8pPr>
+            <a:lvl9pPr>
+              <a:defRPr sz="1350" b="0">
+                <a:solidFill>
+                  <a:srgbClr val="456278"/>
+                </a:solidFill>
+                <a:latin typeface="DejaVu Sans"/>
+                <a:ea typeface="DejaVu Sans"/>
+                <a:cs typeface="DejaVu Sans"/>
+              </a:defRPr>
+            </a:lvl9pPr>
+          </a:lstStyle>
+          <a:p xmlns:a="http://schemas.openxmlformats.org/drawingml/2006/main">
+            <a:pPr>
+              <a:defRPr sz="1350" b="0">
+                <a:solidFill>
+                  <a:srgbClr val="456278"/>
+                </a:solidFill>
+                <a:latin typeface="DejaVu Sans"/>
+                <a:ea typeface="DejaVu Sans"/>
+                <a:cs typeface="DejaVu Sans"/>
+              </a:defRPr>
+            </a:pPr>
+            <a:r>
+              <a:rPr sz="1350" b="0">
+                <a:solidFill>
+                  <a:srgbClr val="456278"/>
+                </a:solidFill>
+                <a:latin typeface="DejaVu Sans"/>
+                <a:ea typeface="DejaVu Sans"/>
+                <a:cs typeface="DejaVu Sans"/>
+              </a:rPr>
+              <a:t>15</a:t>
+            </a:r>
+          </a:p>
+        </p:txBody>
+      </p:sp>
+    </p:spTree>
+    <p:extLst>
+      <p:ext uri="{BB962C8B-B14F-4D97-AF65-F5344CB8AC3E}">
+        <p14:creationId xmlns:p14="http://schemas.microsoft.com/office/powerpoint/2010/main" val="1284621736"/>
+      </p:ext>
+    </p:extLst>
+  </p:cSld>
+</p:sld>
+</file>
+
 <file path=ppt/slides/slide2.xml><?xml version="1.0" encoding="utf-8"?>
 <p:sld xmlns:p="http://schemas.openxmlformats.org/presentationml/2006/main">
   <p:cSld>
@@ -12303,7 +13325,7 @@
                 <a:ea typeface="DejaVu Sans"/>
                 <a:cs typeface="DejaVu Sans"/>
               </a:rPr>
-              <a:t>Simulador web con ANTES y rediseño A/B.</a:t>
+              <a:t>Simulador ANTES y A/B con 13 escenas.</a:t>
             </a:r>
           </a:p>
           <a:p xmlns:a="http://schemas.openxmlformats.org/drawingml/2006/main">
@@ -12332,7 +13354,7 @@
                 <a:ea typeface="DejaVu Sans"/>
                 <a:cs typeface="DejaVu Sans"/>
               </a:rPr>
-              <a:t>Dispositivos con modelo, IP, VLAN, interfaces y puertos.</a:t>
+              <a:t>Interfaces, OSPF, VPN y servicios comparten el estado del tráfico.</a:t>
             </a:r>
           </a:p>
         </p:txBody>
@@ -12868,7 +13890,7 @@
                 <a:ea typeface="DejaVu Sans"/>
                 <a:cs typeface="DejaVu Sans"/>
               </a:rPr>
-              <a:t>Pruebas de caminos, políticas de acceso y fallas registradas</a:t>
+              <a:t>Operación por consola, fallas y recuperación con tiempo virtual</a:t>
             </a:r>
           </a:p>
         </p:txBody>
@@ -14742,7 +15764,7 @@
           <p:cNvPr id="3" name="">
             <a:extLst xmlns:a="http://schemas.openxmlformats.org/drawingml/2006/main">
               <a:ext uri="{FF2B5EF4-FFF2-40B4-BE49-F238E27FC236}">
-                <a16:creationId xmlns:a16="http://schemas.microsoft.com/office/drawing/2014/main" id="{735B11CB-B044-47FF-BF99-45F8DFD85DBA}"/>
+                <a16:creationId xmlns:a16="http://schemas.microsoft.com/office/drawing/2014/main" id="{DA2FB4EF-6D7E-43AB-942A-CBD2177F0F94}"/>
               </a:ext>
             </a:extLst>
           </p:cNvPr>
@@ -15638,7 +16660,7 @@
           <p:cNvPr id="3" name="">
             <a:extLst xmlns:a="http://schemas.openxmlformats.org/drawingml/2006/main">
               <a:ext uri="{FF2B5EF4-FFF2-40B4-BE49-F238E27FC236}">
-                <a16:creationId xmlns:a16="http://schemas.microsoft.com/office/drawing/2014/main" id="{09DB58CC-0121-42BD-9454-BE545040389D}"/>
+                <a16:creationId xmlns:a16="http://schemas.microsoft.com/office/drawing/2014/main" id="{56F7D091-B404-4272-AC7B-7739C2BDB870}"/>
               </a:ext>
             </a:extLst>
           </p:cNvPr>
@@ -15648,7 +16670,7 @@
           <p:nvPr/>
         </p:nvPicPr>
         <p:blipFill>
-          <a:blip xmlns:r="http://schemas.openxmlformats.org/officeDocument/2006/relationships" xmlns:a="http://schemas.openxmlformats.org/drawingml/2006/main" r:embed="Re1186f7c508c4aa8"/>
+          <a:blip xmlns:r="http://schemas.openxmlformats.org/officeDocument/2006/relationships" xmlns:a="http://schemas.openxmlformats.org/drawingml/2006/main" r:embed="R74cabc0a671e4450"/>
           <a:stretch xmlns:a="http://schemas.openxmlformats.org/drawingml/2006/main"/>
         </p:blipFill>
         <p:spPr>
@@ -16371,7 +17393,7 @@
           <p:cNvPr id="3" name="">
             <a:extLst xmlns:a="http://schemas.openxmlformats.org/drawingml/2006/main">
               <a:ext uri="{FF2B5EF4-FFF2-40B4-BE49-F238E27FC236}">
-                <a16:creationId xmlns:a16="http://schemas.microsoft.com/office/drawing/2014/main" id="{1DD59EB0-37C5-4552-A690-DEA74CEEB0CC}"/>
+                <a16:creationId xmlns:a16="http://schemas.microsoft.com/office/drawing/2014/main" id="{82A6FFDD-F939-4CC1-9C84-458E10812083}"/>
               </a:ext>
             </a:extLst>
           </p:cNvPr>
@@ -17560,7 +18582,7 @@
           <p:cNvPr id="3" name="">
             <a:extLst xmlns:a="http://schemas.openxmlformats.org/drawingml/2006/main">
               <a:ext uri="{FF2B5EF4-FFF2-40B4-BE49-F238E27FC236}">
-                <a16:creationId xmlns:a16="http://schemas.microsoft.com/office/drawing/2014/main" id="{14101F32-475C-4087-A488-F935E64134B2}"/>
+                <a16:creationId xmlns:a16="http://schemas.microsoft.com/office/drawing/2014/main" id="{E0C63C48-8A4B-46D8-849B-A2C42C70B683}"/>
               </a:ext>
             </a:extLst>
           </p:cNvPr>
@@ -19811,7 +20833,7 @@
                 <a:ea typeface="DejaVu Sans"/>
                 <a:cs typeface="DejaVu Sans"/>
               </a:rPr>
-              <a:t>RPO y recuperación son objetivos del diseño. El modelo no garantiza sesiones ni recuperación ante pérdida de toda CM.</a:t>
+              <a:t>Ejercicio base: RTO observado 50 s y RPO 30 s de tiempo virtual. Objetivos de diseño: 300 s y 60 s.</a:t>
             </a:r>
           </a:p>
         </p:txBody>
@@ -20188,7 +21210,7 @@
           <p:cNvPr id="3" name="">
             <a:extLst xmlns:a="http://schemas.openxmlformats.org/drawingml/2006/main">
               <a:ext uri="{FF2B5EF4-FFF2-40B4-BE49-F238E27FC236}">
-                <a16:creationId xmlns:a16="http://schemas.microsoft.com/office/drawing/2014/main" id="{4FBAA30C-62B4-4DED-85CE-8A935022B5CE}"/>
+                <a16:creationId xmlns:a16="http://schemas.microsoft.com/office/drawing/2014/main" id="{C3BA14FC-45EF-4ACA-8AFA-7B6D6FDDC395}"/>
               </a:ext>
             </a:extLst>
           </p:cNvPr>
@@ -20786,7 +21808,7 @@
                 <a:latin typeface="DejaVu Sans"/>
                 <a:ea typeface="DejaVu Sans"/>
                 <a:cs typeface="DejaVu Sans"/>
-                <a:hlinkClick xmlns:r="http://schemas.openxmlformats.org/officeDocument/2006/relationships" r:id="Rb2294dfe434949fb"/>
+                <a:hlinkClick xmlns:r="http://schemas.openxmlformats.org/officeDocument/2006/relationships" r:id="Rd480fa0fbb52441d"/>
               </a:rPr>
               <a:t>Abrir simulador</a:t>
             </a:r>

</xml_diff>

<commit_message>
Remove requests for professor feedback from progress presentation closing
</commit_message>
<xml_diff>
--- a/Presentacion/Avance_Financiera_Pacifico_30_oct_2026.pptx
+++ b/Presentacion/Avance_Financiera_Pacifico_30_oct_2026.pptx
@@ -2,18 +2,18 @@
 <file path=ppt/presentation.xml><?xml version="1.0" encoding="utf-8"?>
 <p:presentation xmlns:p="http://schemas.openxmlformats.org/presentationml/2006/main">
   <p:sldMasterIdLst>
-    <p:sldMasterId xmlns:r="http://schemas.openxmlformats.org/officeDocument/2006/relationships" id="2147483648" r:id="Rfa0a8a683aaa4bcd"/>
+    <p:sldMasterId xmlns:r="http://schemas.openxmlformats.org/officeDocument/2006/relationships" id="2147483648" r:id="R05d096aa4af74a65"/>
   </p:sldMasterIdLst>
   <p:notesMasterIdLst>
-    <p:notesMasterId xmlns:r="http://schemas.openxmlformats.org/officeDocument/2006/relationships" r:id="Rb96ba321e5544be0"/>
+    <p:notesMasterId xmlns:r="http://schemas.openxmlformats.org/officeDocument/2006/relationships" r:id="R4a523468c26c4110"/>
   </p:notesMasterIdLst>
   <p:sldIdLst>
-    <p:sldId xmlns:r="http://schemas.openxmlformats.org/officeDocument/2006/relationships" id="256" r:id="R8556fd0d80c64104"/>
-    <p:sldId xmlns:r="http://schemas.openxmlformats.org/officeDocument/2006/relationships" id="257" r:id="Ra7da00e1db74438e"/>
-    <p:sldId xmlns:r="http://schemas.openxmlformats.org/officeDocument/2006/relationships" id="258" r:id="Rf53c22501d1c46e7"/>
-    <p:sldId xmlns:r="http://schemas.openxmlformats.org/officeDocument/2006/relationships" id="259" r:id="Re450e42c8d2a49e0"/>
-    <p:sldId xmlns:r="http://schemas.openxmlformats.org/officeDocument/2006/relationships" id="260" r:id="R525f13047a77482b"/>
-    <p:sldId xmlns:r="http://schemas.openxmlformats.org/officeDocument/2006/relationships" id="261" r:id="Reb40a7bb87b54eeb"/>
+    <p:sldId xmlns:r="http://schemas.openxmlformats.org/officeDocument/2006/relationships" id="256" r:id="R12cfb594480b427f"/>
+    <p:sldId xmlns:r="http://schemas.openxmlformats.org/officeDocument/2006/relationships" id="257" r:id="R66dd1f6ab487484d"/>
+    <p:sldId xmlns:r="http://schemas.openxmlformats.org/officeDocument/2006/relationships" id="258" r:id="R8863c81932e449ad"/>
+    <p:sldId xmlns:r="http://schemas.openxmlformats.org/officeDocument/2006/relationships" id="259" r:id="R1e321470cc9a41cb"/>
+    <p:sldId xmlns:r="http://schemas.openxmlformats.org/officeDocument/2006/relationships" id="260" r:id="Rf679da0c6b544918"/>
+    <p:sldId xmlns:r="http://schemas.openxmlformats.org/officeDocument/2006/relationships" id="261" r:id="R95345893e3494eb8"/>
   </p:sldIdLst>
   <p:sldSz cx="12192000" cy="6858000"/>
   <p:notesSz cx="6858000" cy="9144000"/>
@@ -3240,12 +3240,12 @@
   </p:cSld>
   <p:clrMap bg1="lt1" tx1="dk1" bg2="lt2" tx2="dk2" accent1="accent1" accent2="accent2" accent3="accent3" accent4="accent4" accent5="accent5" accent6="accent6" hlink="hlink" folHlink="folHlink"/>
   <p:sldLayoutIdLst>
-    <p:sldLayoutId xmlns:r="http://schemas.openxmlformats.org/officeDocument/2006/relationships" id="2147483649" r:id="R87bfae4efd83402b"/>
-    <p:sldLayoutId xmlns:r="http://schemas.openxmlformats.org/officeDocument/2006/relationships" id="2147483650" r:id="R5c83f40baeeb426f"/>
-    <p:sldLayoutId xmlns:r="http://schemas.openxmlformats.org/officeDocument/2006/relationships" id="2147483651" r:id="Rb5f6cc96b5534604"/>
-    <p:sldLayoutId xmlns:r="http://schemas.openxmlformats.org/officeDocument/2006/relationships" id="2147483652" r:id="R83819e3fe8ec42ae"/>
-    <p:sldLayoutId xmlns:r="http://schemas.openxmlformats.org/officeDocument/2006/relationships" id="2147483653" r:id="R4eedcec1dbb24378"/>
-    <p:sldLayoutId xmlns:r="http://schemas.openxmlformats.org/officeDocument/2006/relationships" id="2147483654" r:id="R498413f120ca495b"/>
+    <p:sldLayoutId xmlns:r="http://schemas.openxmlformats.org/officeDocument/2006/relationships" id="2147483649" r:id="Rc5ee6af17c5f4a42"/>
+    <p:sldLayoutId xmlns:r="http://schemas.openxmlformats.org/officeDocument/2006/relationships" id="2147483650" r:id="R3555b85245b54783"/>
+    <p:sldLayoutId xmlns:r="http://schemas.openxmlformats.org/officeDocument/2006/relationships" id="2147483651" r:id="R2cab6ca0cd0a46a6"/>
+    <p:sldLayoutId xmlns:r="http://schemas.openxmlformats.org/officeDocument/2006/relationships" id="2147483652" r:id="Rb11cd3c2dbef4a65"/>
+    <p:sldLayoutId xmlns:r="http://schemas.openxmlformats.org/officeDocument/2006/relationships" id="2147483653" r:id="R0b665ccc809e46b9"/>
+    <p:sldLayoutId xmlns:r="http://schemas.openxmlformats.org/officeDocument/2006/relationships" id="2147483654" r:id="R0914c4e884f04f86"/>
   </p:sldLayoutIdLst>
   <p:txStyles>
     <p:titleStyle>
@@ -4788,7 +4788,7 @@
                 <a:ea typeface="DejaVu Sans"/>
                 <a:cs typeface="DejaVu Sans"/>
               </a:rPr>
-              <a:t>Diseño y prototipo desarrollados para revisar el enfoque.</a:t>
+              <a:t>Diseño de red, simulador, inventario y presupuesto.</a:t>
             </a:r>
           </a:p>
         </p:txBody>
@@ -5829,7 +5829,7 @@
           <p:cNvPr id="5" name="">
             <a:extLst xmlns:a="http://schemas.openxmlformats.org/drawingml/2006/main">
               <a:ext uri="{FF2B5EF4-FFF2-40B4-BE49-F238E27FC236}">
-                <a16:creationId xmlns:a16="http://schemas.microsoft.com/office/drawing/2014/main" id="{D59EDF21-D1AA-4C86-B66E-ECB93B409F99}"/>
+                <a16:creationId xmlns:a16="http://schemas.microsoft.com/office/drawing/2014/main" id="{42EED3DA-B338-4D6A-8703-FA898BA5350B}"/>
               </a:ext>
             </a:extLst>
           </p:cNvPr>
@@ -7389,7 +7389,7 @@
           <p:cNvPr id="7" name="">
             <a:extLst xmlns:a="http://schemas.openxmlformats.org/drawingml/2006/main">
               <a:ext uri="{FF2B5EF4-FFF2-40B4-BE49-F238E27FC236}">
-                <a16:creationId xmlns:a16="http://schemas.microsoft.com/office/drawing/2014/main" id="{F9A1C70E-B139-4057-B52F-FE907E6ED8AB}"/>
+                <a16:creationId xmlns:a16="http://schemas.microsoft.com/office/drawing/2014/main" id="{FF19E071-B095-4836-A80B-2BDC935E82D0}"/>
               </a:ext>
             </a:extLst>
           </p:cNvPr>
@@ -7399,7 +7399,7 @@
           <p:nvPr/>
         </p:nvPicPr>
         <p:blipFill>
-          <a:blip xmlns:r="http://schemas.openxmlformats.org/officeDocument/2006/relationships" xmlns:a="http://schemas.openxmlformats.org/drawingml/2006/main" r:embed="Ra340cf38ce7e4bd2"/>
+          <a:blip xmlns:r="http://schemas.openxmlformats.org/officeDocument/2006/relationships" xmlns:a="http://schemas.openxmlformats.org/drawingml/2006/main" r:embed="Raba22e457a384429"/>
           <a:stretch xmlns:a="http://schemas.openxmlformats.org/drawingml/2006/main"/>
         </p:blipFill>
         <p:spPr>
@@ -8114,7 +8114,7 @@
           <p:cNvPr id="5" name="">
             <a:extLst xmlns:a="http://schemas.openxmlformats.org/drawingml/2006/main">
               <a:ext uri="{FF2B5EF4-FFF2-40B4-BE49-F238E27FC236}">
-                <a16:creationId xmlns:a16="http://schemas.microsoft.com/office/drawing/2014/main" id="{C50DE47C-794A-44B5-8C8D-E8EA895BF9D6}"/>
+                <a16:creationId xmlns:a16="http://schemas.microsoft.com/office/drawing/2014/main" id="{373F654B-AA0B-4F90-B970-DAC47ACEB7BD}"/>
               </a:ext>
             </a:extLst>
           </p:cNvPr>
@@ -9257,7 +9257,7 @@
           <p:cNvPr id="5" name="">
             <a:extLst xmlns:a="http://schemas.openxmlformats.org/drawingml/2006/main">
               <a:ext uri="{FF2B5EF4-FFF2-40B4-BE49-F238E27FC236}">
-                <a16:creationId xmlns:a16="http://schemas.microsoft.com/office/drawing/2014/main" id="{46551E75-B6F0-46B6-AF11-07449C426412}"/>
+                <a16:creationId xmlns:a16="http://schemas.microsoft.com/office/drawing/2014/main" id="{97C8505F-4D22-4366-8D57-D5735D70D8CB}"/>
               </a:ext>
             </a:extLst>
           </p:cNvPr>
@@ -10687,7 +10687,7 @@
                 <a:ea typeface="DejaVu Sans"/>
                 <a:cs typeface="DejaVu Sans"/>
               </a:rPr>
-              <a:t>Estado del avance y decisiones para revisar con el profesor.</a:t>
+              <a:t>Diseño de red y prototipo desarrollados para Financiera Pacífico.</a:t>
             </a:r>
           </a:p>
         </p:txBody>
@@ -11188,7 +11188,7 @@
                 <a:ea typeface="DejaVu Sans"/>
                 <a:cs typeface="DejaVu Sans"/>
               </a:rPr>
-              <a:t>Aspectos para revisar con el profesor</a:t>
+              <a:t>Continuidad y control de acceso</a:t>
             </a:r>
           </a:p>
         </p:txBody>
@@ -11355,7 +11355,7 @@
                 <a:ea typeface="DejaVu Sans"/>
                 <a:cs typeface="DejaVu Sans"/>
               </a:rPr>
-              <a:t>Prioridades y alcance de la propuesta.</a:t>
+              <a:t>Diseño de red y pruebas del simulador.</a:t>
             </a:r>
           </a:p>
           <a:p xmlns:a="http://schemas.openxmlformats.org/drawingml/2006/main">
@@ -11379,7 +11379,7 @@
                 <a:ea typeface="DejaVu Sans"/>
                 <a:cs typeface="DejaVu Sans"/>
               </a:rPr>
-              <a:t>Alternativa de equipos e inversión.</a:t>
+              <a:t>Inventario y comparación de costos A/B.</a:t>
             </a:r>
           </a:p>
         </p:txBody>
@@ -11546,7 +11546,7 @@
                 <a:ea typeface="DejaVu Sans"/>
                 <a:cs typeface="DejaVu Sans"/>
               </a:rPr>
-              <a:t>Continuación: ajustar la propuesta con las observaciones recibidas.</a:t>
+              <a:t>Caminos alternativos y permisos por servicio.</a:t>
             </a:r>
           </a:p>
         </p:txBody>

</xml_diff>